<commit_message>
Update pitch deck: remove Two Screens slide, fix checks count, compliance copy
- Remove slide_arch (Two Screens) entirely
- AI Review: 8 checks → 6, remove Claude reference
- Replace HTML → PDF throughout
- Slide 7 heading: Compliance Report: What APG Receives
- Remove $15 AI cost from stats bar
- Font size tweaks (body +2 across middle slides, heading −3)
- Rename project to TrenchVerify; tagline → From Site Photo to Compliance Audit

Co-Authored-By: Claude Sonnet 4.6 <noreply@anthropic.com>
</commit_message>
<xml_diff>
--- a/APG_TrenchVerify_Pitch.pptx
+++ b/APG_TrenchVerify_Pitch.pptx
@@ -14,7 +14,6 @@
     <p:sldId id="262" r:id="rId13"/>
     <p:sldId id="263" r:id="rId14"/>
     <p:sldId id="264" r:id="rId15"/>
-    <p:sldId id="265" r:id="rId16"/>
   </p:sldIdLst>
   <p:sldSz cx="12188952" cy="6858000" type="screen4x3"/>
   <p:notesSz cx="6858000" cy="9144000"/>
@@ -3369,288 +3368,6 @@
 </p:sld>
 </file>
 
-<file path=ppt/slides/slide10.xml><?xml version="1.0" encoding="utf-8"?>
-<p:sld xmlns:a="http://schemas.openxmlformats.org/drawingml/2006/main" xmlns:p="http://schemas.openxmlformats.org/presentationml/2006/main" xmlns:r="http://schemas.openxmlformats.org/officeDocument/2006/relationships">
-  <p:cSld>
-    <p:bg>
-      <p:bgPr>
-        <a:solidFill>
-          <a:srgbClr val="0D1B2A"/>
-        </a:solidFill>
-        <a:effectLst/>
-      </p:bgPr>
-    </p:bg>
-    <p:spTree>
-      <p:nvGrpSpPr>
-        <p:cNvPr id="1" name=""/>
-        <p:cNvGrpSpPr/>
-        <p:nvPr/>
-      </p:nvGrpSpPr>
-      <p:grpSpPr/>
-      <p:sp>
-        <p:nvSpPr>
-          <p:cNvPr id="2" name="Rectangle 1"/>
-          <p:cNvSpPr/>
-          <p:nvPr/>
-        </p:nvSpPr>
-        <p:spPr>
-          <a:xfrm>
-            <a:off x="0" y="0"/>
-            <a:ext cx="12188952" cy="73152"/>
-          </a:xfrm>
-          <a:prstGeom prst="rect">
-            <a:avLst/>
-          </a:prstGeom>
-          <a:solidFill>
-            <a:srgbClr val="00A8E8"/>
-          </a:solidFill>
-          <a:ln>
-            <a:noFill/>
-          </a:ln>
-        </p:spPr>
-        <p:style>
-          <a:lnRef idx="1">
-            <a:schemeClr val="accent1"/>
-          </a:lnRef>
-          <a:fillRef idx="3">
-            <a:schemeClr val="accent1"/>
-          </a:fillRef>
-          <a:effectRef idx="2">
-            <a:schemeClr val="accent1"/>
-          </a:effectRef>
-          <a:fontRef idx="minor">
-            <a:schemeClr val="lt1"/>
-          </a:fontRef>
-        </p:style>
-        <p:txBody>
-          <a:bodyPr rtlCol="0" anchor="ctr"/>
-          <a:lstStyle/>
-          <a:p>
-            <a:pPr algn="ctr"/>
-          </a:p>
-        </p:txBody>
-      </p:sp>
-      <p:sp>
-        <p:nvSpPr>
-          <p:cNvPr id="3" name="Rectangle 2"/>
-          <p:cNvSpPr/>
-          <p:nvPr/>
-        </p:nvSpPr>
-        <p:spPr>
-          <a:xfrm>
-            <a:off x="0" y="6766560"/>
-            <a:ext cx="12188952" cy="73152"/>
-          </a:xfrm>
-          <a:prstGeom prst="rect">
-            <a:avLst/>
-          </a:prstGeom>
-          <a:solidFill>
-            <a:srgbClr val="00D47E"/>
-          </a:solidFill>
-          <a:ln>
-            <a:noFill/>
-          </a:ln>
-        </p:spPr>
-        <p:style>
-          <a:lnRef idx="1">
-            <a:schemeClr val="accent1"/>
-          </a:lnRef>
-          <a:fillRef idx="3">
-            <a:schemeClr val="accent1"/>
-          </a:fillRef>
-          <a:effectRef idx="2">
-            <a:schemeClr val="accent1"/>
-          </a:effectRef>
-          <a:fontRef idx="minor">
-            <a:schemeClr val="lt1"/>
-          </a:fontRef>
-        </p:style>
-        <p:txBody>
-          <a:bodyPr rtlCol="0" anchor="ctr"/>
-          <a:lstStyle/>
-          <a:p>
-            <a:pPr algn="ctr"/>
-          </a:p>
-        </p:txBody>
-      </p:sp>
-      <p:sp>
-        <p:nvSpPr>
-          <p:cNvPr id="4" name="TextBox 3"/>
-          <p:cNvSpPr txBox="1"/>
-          <p:nvPr/>
-        </p:nvSpPr>
-        <p:spPr>
-          <a:xfrm>
-            <a:off x="457200" y="1645920"/>
-            <a:ext cx="11247120" cy="1645920"/>
-          </a:xfrm>
-          <a:prstGeom prst="rect">
-            <a:avLst/>
-          </a:prstGeom>
-          <a:noFill/>
-        </p:spPr>
-        <p:txBody>
-          <a:bodyPr wrap="square">
-            <a:spAutoFit/>
-          </a:bodyPr>
-          <a:lstStyle/>
-          <a:p>
-            <a:pPr algn="ctr"/>
-            <a:r>
-              <a:rPr sz="8000" b="1" i="0">
-                <a:solidFill>
-                  <a:srgbClr val="FFFFFF"/>
-                </a:solidFill>
-              </a:rPr>
-              <a:t>Thank You</a:t>
-            </a:r>
-          </a:p>
-        </p:txBody>
-      </p:sp>
-      <p:sp>
-        <p:nvSpPr>
-          <p:cNvPr id="5" name="TextBox 4"/>
-          <p:cNvSpPr txBox="1"/>
-          <p:nvPr/>
-        </p:nvSpPr>
-        <p:spPr>
-          <a:xfrm>
-            <a:off x="457200" y="3383280"/>
-            <a:ext cx="11247120" cy="640080"/>
-          </a:xfrm>
-          <a:prstGeom prst="rect">
-            <a:avLst/>
-          </a:prstGeom>
-          <a:noFill/>
-        </p:spPr>
-        <p:txBody>
-          <a:bodyPr wrap="square">
-            <a:spAutoFit/>
-          </a:bodyPr>
-          <a:lstStyle/>
-          <a:p>
-            <a:pPr algn="ctr"/>
-            <a:r>
-              <a:rPr sz="3000" b="0" i="0">
-                <a:solidFill>
-                  <a:srgbClr val="00A8E8"/>
-                </a:solidFill>
-              </a:rPr>
-              <a:t>Questions welcome</a:t>
-            </a:r>
-          </a:p>
-        </p:txBody>
-      </p:sp>
-      <p:sp>
-        <p:nvSpPr>
-          <p:cNvPr id="6" name="TextBox 5"/>
-          <p:cNvSpPr txBox="1"/>
-          <p:nvPr/>
-        </p:nvSpPr>
-        <p:spPr>
-          <a:xfrm>
-            <a:off x="457200" y="4206240"/>
-            <a:ext cx="11247120" cy="502920"/>
-          </a:xfrm>
-          <a:prstGeom prst="rect">
-            <a:avLst/>
-          </a:prstGeom>
-          <a:noFill/>
-        </p:spPr>
-        <p:txBody>
-          <a:bodyPr wrap="square">
-            <a:spAutoFit/>
-          </a:bodyPr>
-          <a:lstStyle/>
-          <a:p>
-            <a:pPr algn="ctr"/>
-            <a:r>
-              <a:rPr sz="1600" b="0" i="0">
-                <a:solidFill>
-                  <a:srgbClr val="CCD6E0"/>
-                </a:solidFill>
-              </a:rPr>
-              <a:t>TrenchVerify — From Site Photo to Compliance Audit — Automatically</a:t>
-            </a:r>
-          </a:p>
-        </p:txBody>
-      </p:sp>
-      <p:sp>
-        <p:nvSpPr>
-          <p:cNvPr id="7" name="TextBox 6"/>
-          <p:cNvSpPr txBox="1"/>
-          <p:nvPr/>
-        </p:nvSpPr>
-        <p:spPr>
-          <a:xfrm>
-            <a:off x="457200" y="4754880"/>
-            <a:ext cx="11247120" cy="457200"/>
-          </a:xfrm>
-          <a:prstGeom prst="rect">
-            <a:avLst/>
-          </a:prstGeom>
-          <a:noFill/>
-        </p:spPr>
-        <p:txBody>
-          <a:bodyPr wrap="square">
-            <a:spAutoFit/>
-          </a:bodyPr>
-          <a:lstStyle/>
-          <a:p>
-            <a:pPr algn="ctr"/>
-            <a:r>
-              <a:rPr sz="1500" b="0" i="0">
-                <a:solidFill>
-                  <a:srgbClr val="CCD6E0"/>
-                </a:solidFill>
-              </a:rPr>
-              <a:t>Team: [Name 1]  ·  [Name 2]  ·  [Name 3]</a:t>
-            </a:r>
-          </a:p>
-        </p:txBody>
-      </p:sp>
-      <p:sp>
-        <p:nvSpPr>
-          <p:cNvPr id="8" name="TextBox 7"/>
-          <p:cNvSpPr txBox="1"/>
-          <p:nvPr/>
-        </p:nvSpPr>
-        <p:spPr>
-          <a:xfrm>
-            <a:off x="457200" y="5989320"/>
-            <a:ext cx="11247120" cy="365760"/>
-          </a:xfrm>
-          <a:prstGeom prst="rect">
-            <a:avLst/>
-          </a:prstGeom>
-          <a:noFill/>
-        </p:spPr>
-        <p:txBody>
-          <a:bodyPr wrap="square">
-            <a:spAutoFit/>
-          </a:bodyPr>
-          <a:lstStyle/>
-          <a:p>
-            <a:pPr algn="ctr"/>
-            <a:r>
-              <a:rPr sz="1100" b="0" i="1">
-                <a:solidFill>
-                  <a:srgbClr val="445566"/>
-                </a:solidFill>
-              </a:rPr>
-              <a:t>Built at Vienna UP 2026  ·  All pilot data from APG partner dataset</a:t>
-            </a:r>
-          </a:p>
-        </p:txBody>
-      </p:sp>
-    </p:spTree>
-  </p:cSld>
-  <p:clrMapOvr>
-    <a:masterClrMapping/>
-  </p:clrMapOvr>
-</p:sld>
-</file>
-
 <file path=ppt/slides/slide2.xml><?xml version="1.0" encoding="utf-8"?>
 <p:sld xmlns:a="http://schemas.openxmlformats.org/drawingml/2006/main" xmlns:p="http://schemas.openxmlformats.org/presentationml/2006/main" xmlns:r="http://schemas.openxmlformats.org/officeDocument/2006/relationships">
   <p:cSld>
@@ -6302,9 +6019,9 @@
                   <a:srgbClr val="CCD6E0"/>
                 </a:solidFill>
               </a:rPr>
-              <a:t>8 compliance checks
+              <a:t>6 compliance checks
 per photo via
-Claude vision model</a:t>
+AI vision model</a:t>
             </a:r>
           </a:p>
         </p:txBody>
@@ -6974,7 +6691,7 @@
                   <a:srgbClr val="CCD6E0"/>
                 </a:solidFill>
               </a:rPr>
-              <a:t>CSV + HTML report
+              <a:t>CSV + PDF report
 downloaded; full
 per-meter log exported</a:t>
             </a:r>
@@ -7010,7 +6727,7 @@
                   <a:srgbClr val="445566"/>
                 </a:solidFill>
               </a:rPr>
-              <a:t>8 checks: warning tape · sand bedding · side-view angle · depth reference · sealed cable ends · GDPR (faces/plates) · duplicate detection · GPS↔address match</a:t>
+              <a:t>6 checks: warning tape · sand bedding · side-view angle · depth reference · sealed cable ends · GDPR (faces/plates)</a:t>
             </a:r>
           </a:p>
         </p:txBody>
@@ -7133,6 +6850,315 @@
             <a:avLst/>
           </a:prstGeom>
           <a:solidFill>
+            <a:srgbClr val="00D47E"/>
+          </a:solidFill>
+          <a:ln>
+            <a:noFill/>
+          </a:ln>
+        </p:spPr>
+        <p:style>
+          <a:lnRef idx="1">
+            <a:schemeClr val="accent1"/>
+          </a:lnRef>
+          <a:fillRef idx="3">
+            <a:schemeClr val="accent1"/>
+          </a:fillRef>
+          <a:effectRef idx="2">
+            <a:schemeClr val="accent1"/>
+          </a:effectRef>
+          <a:fontRef idx="minor">
+            <a:schemeClr val="lt1"/>
+          </a:fontRef>
+        </p:style>
+        <p:txBody>
+          <a:bodyPr rtlCol="0" anchor="ctr"/>
+          <a:lstStyle/>
+          <a:p>
+            <a:pPr algn="ctr"/>
+          </a:p>
+        </p:txBody>
+      </p:sp>
+      <p:sp>
+        <p:nvSpPr>
+          <p:cNvPr id="3" name="TextBox 2"/>
+          <p:cNvSpPr txBox="1"/>
+          <p:nvPr/>
+        </p:nvSpPr>
+        <p:spPr>
+          <a:xfrm>
+            <a:off x="457200" y="228600"/>
+            <a:ext cx="10972800" cy="365760"/>
+          </a:xfrm>
+          <a:prstGeom prst="rect">
+            <a:avLst/>
+          </a:prstGeom>
+          <a:noFill/>
+        </p:spPr>
+        <p:txBody>
+          <a:bodyPr wrap="square">
+            <a:spAutoFit/>
+          </a:bodyPr>
+          <a:lstStyle/>
+          <a:p>
+            <a:pPr algn="l"/>
+            <a:r>
+              <a:rPr sz="900" b="1" i="0">
+                <a:solidFill>
+                  <a:srgbClr val="00A8E8"/>
+                </a:solidFill>
+              </a:rPr>
+              <a:t>COMPLIANCE &amp; GDPR</a:t>
+            </a:r>
+          </a:p>
+        </p:txBody>
+      </p:sp>
+      <p:sp>
+        <p:nvSpPr>
+          <p:cNvPr id="4" name="TextBox 3"/>
+          <p:cNvSpPr txBox="1"/>
+          <p:nvPr/>
+        </p:nvSpPr>
+        <p:spPr>
+          <a:xfrm>
+            <a:off x="457200" y="502920"/>
+            <a:ext cx="10972800" cy="640080"/>
+          </a:xfrm>
+          <a:prstGeom prst="rect">
+            <a:avLst/>
+          </a:prstGeom>
+          <a:noFill/>
+        </p:spPr>
+        <p:txBody>
+          <a:bodyPr wrap="square">
+            <a:spAutoFit/>
+          </a:bodyPr>
+          <a:lstStyle/>
+          <a:p>
+            <a:pPr algn="l"/>
+            <a:r>
+              <a:rPr sz="3200" b="1" i="0">
+                <a:solidFill>
+                  <a:srgbClr val="FFFFFF"/>
+                </a:solidFill>
+              </a:rPr>
+              <a:t>Compliance Report: What APG Receives</a:t>
+            </a:r>
+          </a:p>
+        </p:txBody>
+      </p:sp>
+      <p:sp>
+        <p:nvSpPr>
+          <p:cNvPr id="5" name="Rectangle 4"/>
+          <p:cNvSpPr/>
+          <p:nvPr/>
+        </p:nvSpPr>
+        <p:spPr>
+          <a:xfrm>
+            <a:off x="365760" y="1371600"/>
+            <a:ext cx="5303520" cy="2286000"/>
+          </a:xfrm>
+          <a:prstGeom prst="rect">
+            <a:avLst/>
+          </a:prstGeom>
+          <a:solidFill>
+            <a:srgbClr val="122636"/>
+          </a:solidFill>
+          <a:ln>
+            <a:noFill/>
+          </a:ln>
+        </p:spPr>
+        <p:style>
+          <a:lnRef idx="1">
+            <a:schemeClr val="accent1"/>
+          </a:lnRef>
+          <a:fillRef idx="3">
+            <a:schemeClr val="accent1"/>
+          </a:fillRef>
+          <a:effectRef idx="2">
+            <a:schemeClr val="accent1"/>
+          </a:effectRef>
+          <a:fontRef idx="minor">
+            <a:schemeClr val="lt1"/>
+          </a:fontRef>
+        </p:style>
+        <p:txBody>
+          <a:bodyPr rtlCol="0" anchor="ctr"/>
+          <a:lstStyle/>
+          <a:p>
+            <a:pPr algn="ctr"/>
+          </a:p>
+        </p:txBody>
+      </p:sp>
+      <p:sp>
+        <p:nvSpPr>
+          <p:cNvPr id="6" name="Rectangle 5"/>
+          <p:cNvSpPr/>
+          <p:nvPr/>
+        </p:nvSpPr>
+        <p:spPr>
+          <a:xfrm>
+            <a:off x="365760" y="1371600"/>
+            <a:ext cx="5303520" cy="91440"/>
+          </a:xfrm>
+          <a:prstGeom prst="rect">
+            <a:avLst/>
+          </a:prstGeom>
+          <a:solidFill>
+            <a:srgbClr val="00D47E"/>
+          </a:solidFill>
+          <a:ln>
+            <a:noFill/>
+          </a:ln>
+        </p:spPr>
+        <p:style>
+          <a:lnRef idx="1">
+            <a:schemeClr val="accent1"/>
+          </a:lnRef>
+          <a:fillRef idx="3">
+            <a:schemeClr val="accent1"/>
+          </a:fillRef>
+          <a:effectRef idx="2">
+            <a:schemeClr val="accent1"/>
+          </a:effectRef>
+          <a:fontRef idx="minor">
+            <a:schemeClr val="lt1"/>
+          </a:fontRef>
+        </p:style>
+        <p:txBody>
+          <a:bodyPr rtlCol="0" anchor="ctr"/>
+          <a:lstStyle/>
+          <a:p>
+            <a:pPr algn="ctr"/>
+          </a:p>
+        </p:txBody>
+      </p:sp>
+      <p:sp>
+        <p:nvSpPr>
+          <p:cNvPr id="7" name="TextBox 6"/>
+          <p:cNvSpPr txBox="1"/>
+          <p:nvPr/>
+        </p:nvSpPr>
+        <p:spPr>
+          <a:xfrm>
+            <a:off x="548640" y="1508760"/>
+            <a:ext cx="4937760" cy="685800"/>
+          </a:xfrm>
+          <a:prstGeom prst="rect">
+            <a:avLst/>
+          </a:prstGeom>
+          <a:noFill/>
+        </p:spPr>
+        <p:txBody>
+          <a:bodyPr wrap="square">
+            <a:spAutoFit/>
+          </a:bodyPr>
+          <a:lstStyle/>
+          <a:p>
+            <a:pPr algn="l"/>
+            <a:r>
+              <a:rPr sz="1700" b="1" i="0">
+                <a:solidFill>
+                  <a:srgbClr val="00D47E"/>
+                </a:solidFill>
+              </a:rPr>
+              <a:t>GDPR / NIS2
+Compliant</a:t>
+            </a:r>
+          </a:p>
+        </p:txBody>
+      </p:sp>
+      <p:sp>
+        <p:nvSpPr>
+          <p:cNvPr id="8" name="TextBox 7"/>
+          <p:cNvSpPr txBox="1"/>
+          <p:nvPr/>
+        </p:nvSpPr>
+        <p:spPr>
+          <a:xfrm>
+            <a:off x="548640" y="2240280"/>
+            <a:ext cx="4937760" cy="1280160"/>
+          </a:xfrm>
+          <a:prstGeom prst="rect">
+            <a:avLst/>
+          </a:prstGeom>
+          <a:noFill/>
+        </p:spPr>
+        <p:txBody>
+          <a:bodyPr wrap="square">
+            <a:spAutoFit/>
+          </a:bodyPr>
+          <a:lstStyle/>
+          <a:p>
+            <a:pPr algn="l"/>
+            <a:r>
+              <a:rPr sz="1800" b="0" i="0">
+                <a:solidFill>
+                  <a:srgbClr val="CCD6E0"/>
+                </a:solidFill>
+              </a:rPr>
+              <a:t>Faces and license plates detected in every photo before any reviewer sees them. Flagged images are withheld from the display grid and routed to a "needs retake" list. No personal data is ever shown, stored, or transmitted to our infrastructure.</a:t>
+            </a:r>
+          </a:p>
+        </p:txBody>
+      </p:sp>
+      <p:sp>
+        <p:nvSpPr>
+          <p:cNvPr id="9" name="Rectangle 8"/>
+          <p:cNvSpPr/>
+          <p:nvPr/>
+        </p:nvSpPr>
+        <p:spPr>
+          <a:xfrm>
+            <a:off x="6309360" y="1371600"/>
+            <a:ext cx="5303520" cy="2286000"/>
+          </a:xfrm>
+          <a:prstGeom prst="rect">
+            <a:avLst/>
+          </a:prstGeom>
+          <a:solidFill>
+            <a:srgbClr val="122636"/>
+          </a:solidFill>
+          <a:ln>
+            <a:noFill/>
+          </a:ln>
+        </p:spPr>
+        <p:style>
+          <a:lnRef idx="1">
+            <a:schemeClr val="accent1"/>
+          </a:lnRef>
+          <a:fillRef idx="3">
+            <a:schemeClr val="accent1"/>
+          </a:fillRef>
+          <a:effectRef idx="2">
+            <a:schemeClr val="accent1"/>
+          </a:effectRef>
+          <a:fontRef idx="minor">
+            <a:schemeClr val="lt1"/>
+          </a:fontRef>
+        </p:style>
+        <p:txBody>
+          <a:bodyPr rtlCol="0" anchor="ctr"/>
+          <a:lstStyle/>
+          <a:p>
+            <a:pPr algn="ctr"/>
+          </a:p>
+        </p:txBody>
+      </p:sp>
+      <p:sp>
+        <p:nvSpPr>
+          <p:cNvPr id="10" name="Rectangle 9"/>
+          <p:cNvSpPr/>
+          <p:nvPr/>
+        </p:nvSpPr>
+        <p:spPr>
+          <a:xfrm>
+            <a:off x="6309360" y="1371600"/>
+            <a:ext cx="5303520" cy="91440"/>
+          </a:xfrm>
+          <a:prstGeom prst="rect">
+            <a:avLst/>
+          </a:prstGeom>
+          <a:solidFill>
             <a:srgbClr val="00A8E8"/>
           </a:solidFill>
           <a:ln>
@@ -7163,14 +7189,14 @@
       </p:sp>
       <p:sp>
         <p:nvSpPr>
-          <p:cNvPr id="3" name="TextBox 2"/>
-          <p:cNvSpPr txBox="1"/>
-          <p:nvPr/>
-        </p:nvSpPr>
-        <p:spPr>
-          <a:xfrm>
-            <a:off x="457200" y="228600"/>
-            <a:ext cx="10972800" cy="365760"/>
+          <p:cNvPr id="11" name="TextBox 10"/>
+          <p:cNvSpPr txBox="1"/>
+          <p:nvPr/>
+        </p:nvSpPr>
+        <p:spPr>
+          <a:xfrm>
+            <a:off x="6492240" y="1508760"/>
+            <a:ext cx="4937760" cy="685800"/>
           </a:xfrm>
           <a:prstGeom prst="rect">
             <a:avLst/>
@@ -7185,26 +7211,27 @@
           <a:p>
             <a:pPr algn="l"/>
             <a:r>
-              <a:rPr sz="900" b="1" i="0">
+              <a:rPr sz="1700" b="1" i="0">
                 <a:solidFill>
                   <a:srgbClr val="00A8E8"/>
                 </a:solidFill>
               </a:rPr>
-              <a:t>ARCHITECTURE</a:t>
-            </a:r>
-          </a:p>
-        </p:txBody>
-      </p:sp>
-      <p:sp>
-        <p:nvSpPr>
-          <p:cNvPr id="4" name="TextBox 3"/>
-          <p:cNvSpPr txBox="1"/>
-          <p:nvPr/>
-        </p:nvSpPr>
-        <p:spPr>
-          <a:xfrm>
-            <a:off x="457200" y="502920"/>
-            <a:ext cx="10972800" cy="640080"/>
+              <a:t>Zero Data
+Retention</a:t>
+            </a:r>
+          </a:p>
+        </p:txBody>
+      </p:sp>
+      <p:sp>
+        <p:nvSpPr>
+          <p:cNvPr id="12" name="TextBox 11"/>
+          <p:cNvSpPr txBox="1"/>
+          <p:nvPr/>
+        </p:nvSpPr>
+        <p:spPr>
+          <a:xfrm>
+            <a:off x="6492240" y="2240280"/>
+            <a:ext cx="4937760" cy="1280160"/>
           </a:xfrm>
           <a:prstGeom prst="rect">
             <a:avLst/>
@@ -7219,32 +7246,32 @@
           <a:p>
             <a:pPr algn="l"/>
             <a:r>
-              <a:rPr sz="3200" b="1" i="0">
-                <a:solidFill>
-                  <a:srgbClr val="FFFFFF"/>
-                </a:solidFill>
-              </a:rPr>
-              <a:t>Two Screens. One Pipeline. Zero Data Retained.</a:t>
-            </a:r>
-          </a:p>
-        </p:txBody>
-      </p:sp>
-      <p:sp>
-        <p:nvSpPr>
-          <p:cNvPr id="5" name="Rectangle 4"/>
+              <a:rPr sz="1800" b="0" i="0">
+                <a:solidFill>
+                  <a:srgbClr val="CCD6E0"/>
+                </a:solidFill>
+              </a:rPr>
+              <a:t>Photos are processed transiently — held in memory for the duration of the AI call, then released. Nothing is persisted on our servers. All results (scores, logs) are written exclusively to the customer's own database.</a:t>
+            </a:r>
+          </a:p>
+        </p:txBody>
+      </p:sp>
+      <p:sp>
+        <p:nvSpPr>
+          <p:cNvPr id="13" name="Rectangle 12"/>
           <p:cNvSpPr/>
           <p:nvPr/>
         </p:nvSpPr>
         <p:spPr>
           <a:xfrm>
-            <a:off x="365760" y="1371600"/>
-            <a:ext cx="5029200" cy="4846320"/>
+            <a:off x="365760" y="3840480"/>
+            <a:ext cx="5303520" cy="2286000"/>
           </a:xfrm>
           <a:prstGeom prst="rect">
             <a:avLst/>
           </a:prstGeom>
           <a:solidFill>
-            <a:srgbClr val="0C2A1A"/>
+            <a:srgbClr val="122636"/>
           </a:solidFill>
           <a:ln>
             <a:noFill/>
@@ -7274,190 +7301,20 @@
       </p:sp>
       <p:sp>
         <p:nvSpPr>
-          <p:cNvPr id="6" name="TextBox 5"/>
-          <p:cNvSpPr txBox="1"/>
-          <p:nvPr/>
-        </p:nvSpPr>
-        <p:spPr>
-          <a:xfrm>
-            <a:off x="457200" y="1463040"/>
-            <a:ext cx="4846320" cy="457200"/>
-          </a:xfrm>
-          <a:prstGeom prst="rect">
-            <a:avLst/>
-          </a:prstGeom>
-          <a:noFill/>
-        </p:spPr>
-        <p:txBody>
-          <a:bodyPr wrap="square">
-            <a:spAutoFit/>
-          </a:bodyPr>
-          <a:lstStyle/>
-          <a:p>
-            <a:pPr algn="l"/>
-            <a:r>
-              <a:rPr sz="1300" b="1" i="0">
-                <a:solidFill>
-                  <a:srgbClr val="00D47E"/>
-                </a:solidFill>
-              </a:rPr>
-              <a:t>OPERATOR SCREEN  (on-site)</a:t>
-            </a:r>
-          </a:p>
-        </p:txBody>
-      </p:sp>
-      <p:sp>
-        <p:nvSpPr>
-          <p:cNvPr id="7" name="TextBox 6"/>
-          <p:cNvSpPr txBox="1"/>
-          <p:nvPr/>
-        </p:nvSpPr>
-        <p:spPr>
-          <a:xfrm>
-            <a:off x="548640" y="1965960"/>
-            <a:ext cx="4663440" cy="594360"/>
-          </a:xfrm>
-          <a:prstGeom prst="rect">
-            <a:avLst/>
-          </a:prstGeom>
-          <a:noFill/>
-        </p:spPr>
-        <p:txBody>
-          <a:bodyPr wrap="square">
-            <a:spAutoFit/>
-          </a:bodyPr>
-          <a:lstStyle/>
-          <a:p>
-            <a:pPr algn="l"/>
-            <a:r>
-              <a:rPr sz="1600" b="0" i="0">
-                <a:solidFill>
-                  <a:srgbClr val="FFFFFF"/>
-                </a:solidFill>
-              </a:rPr>
-              <a:t>• Upload photos from site tablet</a:t>
-            </a:r>
-          </a:p>
-        </p:txBody>
-      </p:sp>
-      <p:sp>
-        <p:nvSpPr>
-          <p:cNvPr id="8" name="TextBox 7"/>
-          <p:cNvSpPr txBox="1"/>
-          <p:nvPr/>
-        </p:nvSpPr>
-        <p:spPr>
-          <a:xfrm>
-            <a:off x="548640" y="2651760"/>
-            <a:ext cx="4663440" cy="594360"/>
-          </a:xfrm>
-          <a:prstGeom prst="rect">
-            <a:avLst/>
-          </a:prstGeom>
-          <a:noFill/>
-        </p:spPr>
-        <p:txBody>
-          <a:bodyPr wrap="square">
-            <a:spAutoFit/>
-          </a:bodyPr>
-          <a:lstStyle/>
-          <a:p>
-            <a:pPr algn="l"/>
-            <a:r>
-              <a:rPr sz="1600" b="0" i="0">
-                <a:solidFill>
-                  <a:srgbClr val="FFFFFF"/>
-                </a:solidFill>
-              </a:rPr>
-              <a:t>• Instant per-photo feedback</a:t>
-            </a:r>
-          </a:p>
-        </p:txBody>
-      </p:sp>
-      <p:sp>
-        <p:nvSpPr>
-          <p:cNvPr id="9" name="TextBox 8"/>
-          <p:cNvSpPr txBox="1"/>
-          <p:nvPr/>
-        </p:nvSpPr>
-        <p:spPr>
-          <a:xfrm>
-            <a:off x="548640" y="3337560"/>
-            <a:ext cx="4663440" cy="594360"/>
-          </a:xfrm>
-          <a:prstGeom prst="rect">
-            <a:avLst/>
-          </a:prstGeom>
-          <a:noFill/>
-        </p:spPr>
-        <p:txBody>
-          <a:bodyPr wrap="square">
-            <a:spAutoFit/>
-          </a:bodyPr>
-          <a:lstStyle/>
-          <a:p>
-            <a:pPr algn="l"/>
-            <a:r>
-              <a:rPr sz="1600" b="0" i="0">
-                <a:solidFill>
-                  <a:srgbClr val="FFFFFF"/>
-                </a:solidFill>
-              </a:rPr>
-              <a:t>• "Missing sand photo — retake now"</a:t>
-            </a:r>
-          </a:p>
-        </p:txBody>
-      </p:sp>
-      <p:sp>
-        <p:nvSpPr>
-          <p:cNvPr id="10" name="TextBox 9"/>
-          <p:cNvSpPr txBox="1"/>
-          <p:nvPr/>
-        </p:nvSpPr>
-        <p:spPr>
-          <a:xfrm>
-            <a:off x="548640" y="4023360"/>
-            <a:ext cx="4663440" cy="594360"/>
-          </a:xfrm>
-          <a:prstGeom prst="rect">
-            <a:avLst/>
-          </a:prstGeom>
-          <a:noFill/>
-        </p:spPr>
-        <p:txBody>
-          <a:bodyPr wrap="square">
-            <a:spAutoFit/>
-          </a:bodyPr>
-          <a:lstStyle/>
-          <a:p>
-            <a:pPr algn="l"/>
-            <a:r>
-              <a:rPr sz="1600" b="0" i="0">
-                <a:solidFill>
-                  <a:srgbClr val="FFFFFF"/>
-                </a:solidFill>
-              </a:rPr>
-              <a:t>• Catches gaps while trench is open</a:t>
-            </a:r>
-          </a:p>
-        </p:txBody>
-      </p:sp>
-      <p:sp>
-        <p:nvSpPr>
-          <p:cNvPr id="11" name="Rectangle 10"/>
+          <p:cNvPr id="14" name="Rectangle 13"/>
           <p:cNvSpPr/>
           <p:nvPr/>
         </p:nvSpPr>
         <p:spPr>
           <a:xfrm>
-            <a:off x="6492240" y="1371600"/>
-            <a:ext cx="5303520" cy="4846320"/>
+            <a:off x="365760" y="3840480"/>
+            <a:ext cx="5303520" cy="91440"/>
           </a:xfrm>
           <a:prstGeom prst="rect">
             <a:avLst/>
           </a:prstGeom>
           <a:solidFill>
-            <a:srgbClr val="0C1A2E"/>
+            <a:srgbClr val="FFC107"/>
           </a:solidFill>
           <a:ln>
             <a:noFill/>
@@ -7487,14 +7344,14 @@
       </p:sp>
       <p:sp>
         <p:nvSpPr>
-          <p:cNvPr id="12" name="TextBox 11"/>
-          <p:cNvSpPr txBox="1"/>
-          <p:nvPr/>
-        </p:nvSpPr>
-        <p:spPr>
-          <a:xfrm>
-            <a:off x="6583680" y="1463040"/>
-            <a:ext cx="5120640" cy="457200"/>
+          <p:cNvPr id="15" name="TextBox 14"/>
+          <p:cNvSpPr txBox="1"/>
+          <p:nvPr/>
+        </p:nvSpPr>
+        <p:spPr>
+          <a:xfrm>
+            <a:off x="548640" y="3977640"/>
+            <a:ext cx="4937760" cy="685800"/>
           </a:xfrm>
           <a:prstGeom prst="rect">
             <a:avLst/>
@@ -7509,26 +7366,27 @@
           <a:p>
             <a:pPr algn="l"/>
             <a:r>
-              <a:rPr sz="1300" b="1" i="0">
-                <a:solidFill>
-                  <a:srgbClr val="00A8E8"/>
-                </a:solidFill>
-              </a:rPr>
-              <a:t>REVIEWER DASHBOARD  (APG office)</a:t>
-            </a:r>
-          </a:p>
-        </p:txBody>
-      </p:sp>
-      <p:sp>
-        <p:nvSpPr>
-          <p:cNvPr id="13" name="TextBox 12"/>
-          <p:cNvSpPr txBox="1"/>
-          <p:nvPr/>
-        </p:nvSpPr>
-        <p:spPr>
-          <a:xfrm>
-            <a:off x="6675120" y="1965960"/>
-            <a:ext cx="4937760" cy="594360"/>
+              <a:rPr sz="1700" b="1" i="0">
+                <a:solidFill>
+                  <a:srgbClr val="FFC107"/>
+                </a:solidFill>
+              </a:rPr>
+              <a:t>Full Audit
+Trail</a:t>
+            </a:r>
+          </a:p>
+        </p:txBody>
+      </p:sp>
+      <p:sp>
+        <p:nvSpPr>
+          <p:cNvPr id="16" name="TextBox 15"/>
+          <p:cNvSpPr txBox="1"/>
+          <p:nvPr/>
+        </p:nvSpPr>
+        <p:spPr>
+          <a:xfrm>
+            <a:off x="548640" y="4709160"/>
+            <a:ext cx="4937760" cy="1280160"/>
           </a:xfrm>
           <a:prstGeom prst="rect">
             <a:avLst/>
@@ -7543,203 +7401,32 @@
           <a:p>
             <a:pPr algn="l"/>
             <a:r>
-              <a:rPr sz="1600" b="0" i="0">
-                <a:solidFill>
-                  <a:srgbClr val="FFFFFF"/>
-                </a:solidFill>
-              </a:rPr>
-              <a:t>• AI runs once at upload — results stored, zero re-processing per session</a:t>
-            </a:r>
-          </a:p>
-        </p:txBody>
-      </p:sp>
-      <p:sp>
-        <p:nvSpPr>
-          <p:cNvPr id="14" name="TextBox 13"/>
-          <p:cNvSpPr txBox="1"/>
-          <p:nvPr/>
-        </p:nvSpPr>
-        <p:spPr>
-          <a:xfrm>
-            <a:off x="6675120" y="2651760"/>
-            <a:ext cx="4937760" cy="594360"/>
-          </a:xfrm>
-          <a:prstGeom prst="rect">
-            <a:avLst/>
-          </a:prstGeom>
-          <a:noFill/>
-        </p:spPr>
-        <p:txBody>
-          <a:bodyPr wrap="square">
-            <a:spAutoFit/>
-          </a:bodyPr>
-          <a:lstStyle/>
-          <a:p>
-            <a:pPr algn="l"/>
-            <a:r>
-              <a:rPr sz="1600" b="0" i="0">
-                <a:solidFill>
-                  <a:srgbClr val="FFFFFF"/>
-                </a:solidFill>
-              </a:rPr>
-              <a:t>• Color map: click any red segment</a:t>
-            </a:r>
-          </a:p>
-        </p:txBody>
-      </p:sp>
-      <p:sp>
-        <p:nvSpPr>
-          <p:cNvPr id="15" name="TextBox 14"/>
-          <p:cNvSpPr txBox="1"/>
-          <p:nvPr/>
-        </p:nvSpPr>
-        <p:spPr>
-          <a:xfrm>
-            <a:off x="6675120" y="3337560"/>
-            <a:ext cx="4937760" cy="594360"/>
-          </a:xfrm>
-          <a:prstGeom prst="rect">
-            <a:avLst/>
-          </a:prstGeom>
-          <a:noFill/>
-        </p:spPr>
-        <p:txBody>
-          <a:bodyPr wrap="square">
-            <a:spAutoFit/>
-          </a:bodyPr>
-          <a:lstStyle/>
-          <a:p>
-            <a:pPr algn="l"/>
-            <a:r>
-              <a:rPr sz="1600" b="0" i="0">
-                <a:solidFill>
-                  <a:srgbClr val="FFFFFF"/>
-                </a:solidFill>
-              </a:rPr>
-              <a:t>• View evidence photos + check results</a:t>
-            </a:r>
-          </a:p>
-        </p:txBody>
-      </p:sp>
-      <p:sp>
-        <p:nvSpPr>
-          <p:cNvPr id="16" name="TextBox 15"/>
-          <p:cNvSpPr txBox="1"/>
-          <p:nvPr/>
-        </p:nvSpPr>
-        <p:spPr>
-          <a:xfrm>
-            <a:off x="6675120" y="4023360"/>
-            <a:ext cx="4937760" cy="594360"/>
-          </a:xfrm>
-          <a:prstGeom prst="rect">
-            <a:avLst/>
-          </a:prstGeom>
-          <a:noFill/>
-        </p:spPr>
-        <p:txBody>
-          <a:bodyPr wrap="square">
-            <a:spAutoFit/>
-          </a:bodyPr>
-          <a:lstStyle/>
-          <a:p>
-            <a:pPr algn="l"/>
-            <a:r>
-              <a:rPr sz="1600" b="0" i="0">
-                <a:solidFill>
-                  <a:srgbClr val="FFFFFF"/>
-                </a:solidFill>
-              </a:rPr>
-              <a:t>• Download audit CSV / HTML report</a:t>
-            </a:r>
-          </a:p>
-        </p:txBody>
-      </p:sp>
-      <p:sp>
-        <p:nvSpPr>
-          <p:cNvPr id="17" name="TextBox 16"/>
-          <p:cNvSpPr txBox="1"/>
-          <p:nvPr/>
-        </p:nvSpPr>
-        <p:spPr>
-          <a:xfrm>
-            <a:off x="5440680" y="2834640"/>
-            <a:ext cx="1097280" cy="548640"/>
-          </a:xfrm>
-          <a:prstGeom prst="rect">
-            <a:avLst/>
-          </a:prstGeom>
-          <a:noFill/>
-        </p:spPr>
-        <p:txBody>
-          <a:bodyPr wrap="square">
-            <a:spAutoFit/>
-          </a:bodyPr>
-          <a:lstStyle/>
-          <a:p>
-            <a:pPr algn="ctr"/>
-            <a:r>
-              <a:rPr sz="3000" b="1" i="0">
-                <a:solidFill>
-                  <a:srgbClr val="00A8E8"/>
-                </a:solidFill>
-              </a:rPr>
-              <a:t>⟷</a:t>
-            </a:r>
-          </a:p>
-        </p:txBody>
-      </p:sp>
-      <p:sp>
-        <p:nvSpPr>
-          <p:cNvPr id="18" name="TextBox 17"/>
-          <p:cNvSpPr txBox="1"/>
-          <p:nvPr/>
-        </p:nvSpPr>
-        <p:spPr>
-          <a:xfrm>
-            <a:off x="5257800" y="3429000"/>
-            <a:ext cx="1463040" cy="502920"/>
-          </a:xfrm>
-          <a:prstGeom prst="rect">
-            <a:avLst/>
-          </a:prstGeom>
-          <a:noFill/>
-        </p:spPr>
-        <p:txBody>
-          <a:bodyPr wrap="square">
-            <a:spAutoFit/>
-          </a:bodyPr>
-          <a:lstStyle/>
-          <a:p>
-            <a:pPr algn="ctr"/>
-            <a:r>
-              <a:rPr sz="1000" b="0" i="0">
+              <a:rPr sz="1800" b="0" i="0">
                 <a:solidFill>
                   <a:srgbClr val="CCD6E0"/>
                 </a:solidFill>
               </a:rPr>
-              <a:t>One platform
-two entry points</a:t>
-            </a:r>
-          </a:p>
-        </p:txBody>
-      </p:sp>
-      <p:sp>
-        <p:nvSpPr>
-          <p:cNvPr id="19" name="Rectangle 18"/>
+              <a:t>Every check result is logged with: photo ID · trench segment · GPS coordinates · timestamp · pass/fail per check. The export is a court-admissible evidence trail, not just a summary report.</a:t>
+            </a:r>
+          </a:p>
+        </p:txBody>
+      </p:sp>
+      <p:sp>
+        <p:nvSpPr>
+          <p:cNvPr id="17" name="Rectangle 16"/>
           <p:cNvSpPr/>
           <p:nvPr/>
         </p:nvSpPr>
         <p:spPr>
           <a:xfrm>
-            <a:off x="365760" y="6263640"/>
-            <a:ext cx="11430000" cy="457200"/>
+            <a:off x="6309360" y="3840480"/>
+            <a:ext cx="5303520" cy="2286000"/>
           </a:xfrm>
           <a:prstGeom prst="rect">
             <a:avLst/>
           </a:prstGeom>
           <a:solidFill>
-            <a:srgbClr val="1A1A1A"/>
+            <a:srgbClr val="122636"/>
           </a:solidFill>
           <a:ln>
             <a:noFill/>
@@ -7769,14 +7456,92 @@
       </p:sp>
       <p:sp>
         <p:nvSpPr>
+          <p:cNvPr id="18" name="Rectangle 17"/>
+          <p:cNvSpPr/>
+          <p:nvPr/>
+        </p:nvSpPr>
+        <p:spPr>
+          <a:xfrm>
+            <a:off x="6309360" y="3840480"/>
+            <a:ext cx="5303520" cy="91440"/>
+          </a:xfrm>
+          <a:prstGeom prst="rect">
+            <a:avLst/>
+          </a:prstGeom>
+          <a:solidFill>
+            <a:srgbClr val="FFFFFF"/>
+          </a:solidFill>
+          <a:ln>
+            <a:noFill/>
+          </a:ln>
+        </p:spPr>
+        <p:style>
+          <a:lnRef idx="1">
+            <a:schemeClr val="accent1"/>
+          </a:lnRef>
+          <a:fillRef idx="3">
+            <a:schemeClr val="accent1"/>
+          </a:fillRef>
+          <a:effectRef idx="2">
+            <a:schemeClr val="accent1"/>
+          </a:effectRef>
+          <a:fontRef idx="minor">
+            <a:schemeClr val="lt1"/>
+          </a:fontRef>
+        </p:style>
+        <p:txBody>
+          <a:bodyPr rtlCol="0" anchor="ctr"/>
+          <a:lstStyle/>
+          <a:p>
+            <a:pPr algn="ctr"/>
+          </a:p>
+        </p:txBody>
+      </p:sp>
+      <p:sp>
+        <p:nvSpPr>
+          <p:cNvPr id="19" name="TextBox 18"/>
+          <p:cNvSpPr txBox="1"/>
+          <p:nvPr/>
+        </p:nvSpPr>
+        <p:spPr>
+          <a:xfrm>
+            <a:off x="6492240" y="3977640"/>
+            <a:ext cx="4937760" cy="685800"/>
+          </a:xfrm>
+          <a:prstGeom prst="rect">
+            <a:avLst/>
+          </a:prstGeom>
+          <a:noFill/>
+        </p:spPr>
+        <p:txBody>
+          <a:bodyPr wrap="square">
+            <a:spAutoFit/>
+          </a:bodyPr>
+          <a:lstStyle/>
+          <a:p>
+            <a:pPr algn="l"/>
+            <a:r>
+              <a:rPr sz="1700" b="1" i="0">
+                <a:solidFill>
+                  <a:srgbClr val="FFFFFF"/>
+                </a:solidFill>
+              </a:rPr>
+              <a:t>Contractor
+Accountability</a:t>
+            </a:r>
+          </a:p>
+        </p:txBody>
+      </p:sp>
+      <p:sp>
+        <p:nvSpPr>
           <p:cNvPr id="20" name="TextBox 19"/>
           <p:cNvSpPr txBox="1"/>
           <p:nvPr/>
         </p:nvSpPr>
         <p:spPr>
           <a:xfrm>
-            <a:off x="548640" y="6291072"/>
-            <a:ext cx="11155680" cy="411480"/>
+            <a:off x="6492240" y="4709160"/>
+            <a:ext cx="4937760" cy="1280160"/>
           </a:xfrm>
           <a:prstGeom prst="rect">
             <a:avLst/>
@@ -7791,12 +7556,12 @@
           <a:p>
             <a:pPr algn="l"/>
             <a:r>
-              <a:rPr sz="1100" b="0" i="1">
+              <a:rPr sz="1800" b="0" i="0">
                 <a:solidFill>
                   <a:srgbClr val="CCD6E0"/>
                 </a:solidFill>
               </a:rPr>
-              <a:t>Data flow: photos processed transiently in customer cloud  ·  AI model called via API — no photo stored  ·  Results written to customer-owned DB only</a:t>
+              <a:t>Duplicate-photo detection fingerprints every image. If a contractor reuses the same photo across jobs, the system catches the original, the copy, and all job IDs it was submitted to. In our pilot: ~600 duplicates detected automatically.</a:t>
             </a:r>
           </a:p>
         </p:txBody>
@@ -7899,7 +7664,7 @@
                   <a:srgbClr val="00A8E8"/>
                 </a:solidFill>
               </a:rPr>
-              <a:t>COMPLIANCE &amp; GDPR</a:t>
+              <a:t>BUSINESS VALUE</a:t>
             </a:r>
           </a:p>
         </p:txBody>
@@ -7928,12 +7693,12 @@
           <a:p>
             <a:pPr algn="l"/>
             <a:r>
-              <a:rPr sz="3200" b="1" i="0">
+              <a:rPr sz="2900" b="1" i="0">
                 <a:solidFill>
                   <a:srgbClr val="FFFFFF"/>
                 </a:solidFill>
               </a:rPr>
-              <a:t>Regulatory Compliance Baked In — Not Bolted On</a:t>
+              <a:t>The Numbers Speak for Themselves</a:t>
             </a:r>
           </a:p>
         </p:txBody>
@@ -7947,7 +7712,7 @@
         <p:spPr>
           <a:xfrm>
             <a:off x="365760" y="1371600"/>
-            <a:ext cx="5303520" cy="2286000"/>
+            <a:ext cx="11430000" cy="859536"/>
           </a:xfrm>
           <a:prstGeom prst="rect">
             <a:avLst/>
@@ -7983,44 +7748,35 @@
       </p:sp>
       <p:sp>
         <p:nvSpPr>
-          <p:cNvPr id="6" name="Rectangle 5"/>
-          <p:cNvSpPr/>
-          <p:nvPr/>
-        </p:nvSpPr>
-        <p:spPr>
-          <a:xfrm>
-            <a:off x="365760" y="1371600"/>
-            <a:ext cx="5303520" cy="91440"/>
-          </a:xfrm>
-          <a:prstGeom prst="rect">
-            <a:avLst/>
-          </a:prstGeom>
-          <a:solidFill>
-            <a:srgbClr val="00D47E"/>
-          </a:solidFill>
-          <a:ln>
-            <a:noFill/>
-          </a:ln>
-        </p:spPr>
-        <p:style>
-          <a:lnRef idx="1">
-            <a:schemeClr val="accent1"/>
-          </a:lnRef>
-          <a:fillRef idx="3">
-            <a:schemeClr val="accent1"/>
-          </a:fillRef>
-          <a:effectRef idx="2">
-            <a:schemeClr val="accent1"/>
-          </a:effectRef>
-          <a:fontRef idx="minor">
-            <a:schemeClr val="lt1"/>
-          </a:fontRef>
-        </p:style>
-        <p:txBody>
-          <a:bodyPr rtlCol="0" anchor="ctr"/>
-          <a:lstStyle/>
-          <a:p>
-            <a:pPr algn="ctr"/>
+          <p:cNvPr id="6" name="TextBox 5"/>
+          <p:cNvSpPr txBox="1"/>
+          <p:nvPr/>
+        </p:nvSpPr>
+        <p:spPr>
+          <a:xfrm>
+            <a:off x="548640" y="1463040"/>
+            <a:ext cx="1463040" cy="731520"/>
+          </a:xfrm>
+          <a:prstGeom prst="rect">
+            <a:avLst/>
+          </a:prstGeom>
+          <a:noFill/>
+        </p:spPr>
+        <p:txBody>
+          <a:bodyPr wrap="square">
+            <a:spAutoFit/>
+          </a:bodyPr>
+          <a:lstStyle/>
+          <a:p>
+            <a:pPr algn="ctr"/>
+            <a:r>
+              <a:rPr sz="3400" b="1" i="0">
+                <a:solidFill>
+                  <a:srgbClr val="00D47E"/>
+                </a:solidFill>
+              </a:rPr>
+              <a:t>€2.4M+</a:t>
+            </a:r>
           </a:p>
         </p:txBody>
       </p:sp>
@@ -8032,8 +7788,8 @@
         </p:nvSpPr>
         <p:spPr>
           <a:xfrm>
-            <a:off x="548640" y="1508760"/>
-            <a:ext cx="4937760" cy="685800"/>
+            <a:off x="2194560" y="1417320"/>
+            <a:ext cx="3657600" cy="457200"/>
           </a:xfrm>
           <a:prstGeom prst="rect">
             <a:avLst/>
@@ -8048,13 +7804,12 @@
           <a:p>
             <a:pPr algn="l"/>
             <a:r>
-              <a:rPr sz="1700" b="1" i="0">
-                <a:solidFill>
-                  <a:srgbClr val="00D47E"/>
-                </a:solidFill>
-              </a:rPr>
-              <a:t>GDPR / NIS2
-Compliant</a:t>
+              <a:rPr sz="1600" b="1" i="0">
+                <a:solidFill>
+                  <a:srgbClr val="FFFFFF"/>
+                </a:solidFill>
+              </a:rPr>
+              <a:t>5-year liability exposure eliminated</a:t>
             </a:r>
           </a:p>
         </p:txBody>
@@ -8067,8 +7822,8 @@
         </p:nvSpPr>
         <p:spPr>
           <a:xfrm>
-            <a:off x="548640" y="2240280"/>
-            <a:ext cx="4937760" cy="1280160"/>
+            <a:off x="2194560" y="1847088"/>
+            <a:ext cx="9144000" cy="384048"/>
           </a:xfrm>
           <a:prstGeom prst="rect">
             <a:avLst/>
@@ -8083,12 +7838,13 @@
           <a:p>
             <a:pPr algn="l"/>
             <a:r>
-              <a:rPr sz="1800" b="0" i="0">
+              <a:rPr sz="1700" b="0" i="1">
                 <a:solidFill>
                   <a:srgbClr val="CCD6E0"/>
                 </a:solidFill>
               </a:rPr>
-              <a:t>Faces and license plates detected in every photo before any reviewer sees them. Flagged images are withheld from the display grid and routed to a "needs retake" list. No personal data is ever shown, stored, or transmitted to our infrastructure.</a:t>
+              <a:t>by catching every defect before contractor sign-off
+(€120K/incident × ~30% miss rate)</a:t>
             </a:r>
           </a:p>
         </p:txBody>
@@ -8101,8 +7857,8 @@
         </p:nvSpPr>
         <p:spPr>
           <a:xfrm>
-            <a:off x="6309360" y="1371600"/>
-            <a:ext cx="5303520" cy="2286000"/>
+            <a:off x="365760" y="2286000"/>
+            <a:ext cx="11430000" cy="859536"/>
           </a:xfrm>
           <a:prstGeom prst="rect">
             <a:avLst/>
@@ -8138,44 +7894,35 @@
       </p:sp>
       <p:sp>
         <p:nvSpPr>
-          <p:cNvPr id="10" name="Rectangle 9"/>
-          <p:cNvSpPr/>
-          <p:nvPr/>
-        </p:nvSpPr>
-        <p:spPr>
-          <a:xfrm>
-            <a:off x="6309360" y="1371600"/>
-            <a:ext cx="5303520" cy="91440"/>
-          </a:xfrm>
-          <a:prstGeom prst="rect">
-            <a:avLst/>
-          </a:prstGeom>
-          <a:solidFill>
-            <a:srgbClr val="00A8E8"/>
-          </a:solidFill>
-          <a:ln>
-            <a:noFill/>
-          </a:ln>
-        </p:spPr>
-        <p:style>
-          <a:lnRef idx="1">
-            <a:schemeClr val="accent1"/>
-          </a:lnRef>
-          <a:fillRef idx="3">
-            <a:schemeClr val="accent1"/>
-          </a:fillRef>
-          <a:effectRef idx="2">
-            <a:schemeClr val="accent1"/>
-          </a:effectRef>
-          <a:fontRef idx="minor">
-            <a:schemeClr val="lt1"/>
-          </a:fontRef>
-        </p:style>
-        <p:txBody>
-          <a:bodyPr rtlCol="0" anchor="ctr"/>
-          <a:lstStyle/>
-          <a:p>
-            <a:pPr algn="ctr"/>
+          <p:cNvPr id="10" name="TextBox 9"/>
+          <p:cNvSpPr txBox="1"/>
+          <p:nvPr/>
+        </p:nvSpPr>
+        <p:spPr>
+          <a:xfrm>
+            <a:off x="548640" y="2377440"/>
+            <a:ext cx="1463040" cy="731520"/>
+          </a:xfrm>
+          <a:prstGeom prst="rect">
+            <a:avLst/>
+          </a:prstGeom>
+          <a:noFill/>
+        </p:spPr>
+        <p:txBody>
+          <a:bodyPr wrap="square">
+            <a:spAutoFit/>
+          </a:bodyPr>
+          <a:lstStyle/>
+          <a:p>
+            <a:pPr algn="ctr"/>
+            <a:r>
+              <a:rPr sz="3400" b="1" i="0">
+                <a:solidFill>
+                  <a:srgbClr val="00A8E8"/>
+                </a:solidFill>
+              </a:rPr>
+              <a:t>99%</a:t>
+            </a:r>
           </a:p>
         </p:txBody>
       </p:sp>
@@ -8187,8 +7934,8 @@
         </p:nvSpPr>
         <p:spPr>
           <a:xfrm>
-            <a:off x="6492240" y="1508760"/>
-            <a:ext cx="4937760" cy="685800"/>
+            <a:off x="2194560" y="2331720"/>
+            <a:ext cx="3657600" cy="457200"/>
           </a:xfrm>
           <a:prstGeom prst="rect">
             <a:avLst/>
@@ -8203,13 +7950,12 @@
           <a:p>
             <a:pPr algn="l"/>
             <a:r>
-              <a:rPr sz="1700" b="1" i="0">
-                <a:solidFill>
-                  <a:srgbClr val="00A8E8"/>
-                </a:solidFill>
-              </a:rPr>
-              <a:t>Zero Data
-Retention</a:t>
+              <a:rPr sz="1600" b="1" i="0">
+                <a:solidFill>
+                  <a:srgbClr val="FFFFFF"/>
+                </a:solidFill>
+              </a:rPr>
+              <a:t>faster review time</a:t>
             </a:r>
           </a:p>
         </p:txBody>
@@ -8222,8 +7968,8 @@
         </p:nvSpPr>
         <p:spPr>
           <a:xfrm>
-            <a:off x="6492240" y="2240280"/>
-            <a:ext cx="4937760" cy="1280160"/>
+            <a:off x="2194560" y="2761488"/>
+            <a:ext cx="9144000" cy="384048"/>
           </a:xfrm>
           <a:prstGeom prst="rect">
             <a:avLst/>
@@ -8238,12 +7984,13 @@
           <a:p>
             <a:pPr algn="l"/>
             <a:r>
-              <a:rPr sz="1800" b="0" i="0">
+              <a:rPr sz="1700" b="0" i="1">
                 <a:solidFill>
                   <a:srgbClr val="CCD6E0"/>
                 </a:solidFill>
               </a:rPr>
-              <a:t>Photos are processed transiently — held in memory for the duration of the AI call, then released. Nothing is persisted on our servers. All results (scores, logs) are written exclusively to the customer's own database.</a:t>
+              <a:t>3–5 days per section → &lt; 30 min for the full route
+(measured: 3,929 photos in 28 min)</a:t>
             </a:r>
           </a:p>
         </p:txBody>
@@ -8256,8 +8003,8 @@
         </p:nvSpPr>
         <p:spPr>
           <a:xfrm>
-            <a:off x="365760" y="3840480"/>
-            <a:ext cx="5303520" cy="2286000"/>
+            <a:off x="365760" y="3200400"/>
+            <a:ext cx="11430000" cy="859536"/>
           </a:xfrm>
           <a:prstGeom prst="rect">
             <a:avLst/>
@@ -8293,44 +8040,35 @@
       </p:sp>
       <p:sp>
         <p:nvSpPr>
-          <p:cNvPr id="14" name="Rectangle 13"/>
-          <p:cNvSpPr/>
-          <p:nvPr/>
-        </p:nvSpPr>
-        <p:spPr>
-          <a:xfrm>
-            <a:off x="365760" y="3840480"/>
-            <a:ext cx="5303520" cy="91440"/>
-          </a:xfrm>
-          <a:prstGeom prst="rect">
-            <a:avLst/>
-          </a:prstGeom>
-          <a:solidFill>
-            <a:srgbClr val="FFC107"/>
-          </a:solidFill>
-          <a:ln>
-            <a:noFill/>
-          </a:ln>
-        </p:spPr>
-        <p:style>
-          <a:lnRef idx="1">
-            <a:schemeClr val="accent1"/>
-          </a:lnRef>
-          <a:fillRef idx="3">
-            <a:schemeClr val="accent1"/>
-          </a:fillRef>
-          <a:effectRef idx="2">
-            <a:schemeClr val="accent1"/>
-          </a:effectRef>
-          <a:fontRef idx="minor">
-            <a:schemeClr val="lt1"/>
-          </a:fontRef>
-        </p:style>
-        <p:txBody>
-          <a:bodyPr rtlCol="0" anchor="ctr"/>
-          <a:lstStyle/>
-          <a:p>
-            <a:pPr algn="ctr"/>
+          <p:cNvPr id="14" name="TextBox 13"/>
+          <p:cNvSpPr txBox="1"/>
+          <p:nvPr/>
+        </p:nvSpPr>
+        <p:spPr>
+          <a:xfrm>
+            <a:off x="548640" y="3291840"/>
+            <a:ext cx="1463040" cy="731520"/>
+          </a:xfrm>
+          <a:prstGeom prst="rect">
+            <a:avLst/>
+          </a:prstGeom>
+          <a:noFill/>
+        </p:spPr>
+        <p:txBody>
+          <a:bodyPr wrap="square">
+            <a:spAutoFit/>
+          </a:bodyPr>
+          <a:lstStyle/>
+          <a:p>
+            <a:pPr algn="ctr"/>
+            <a:r>
+              <a:rPr sz="3400" b="1" i="0">
+                <a:solidFill>
+                  <a:srgbClr val="00D47E"/>
+                </a:solidFill>
+              </a:rPr>
+              <a:t>100%</a:t>
+            </a:r>
           </a:p>
         </p:txBody>
       </p:sp>
@@ -8342,8 +8080,8 @@
         </p:nvSpPr>
         <p:spPr>
           <a:xfrm>
-            <a:off x="548640" y="3977640"/>
-            <a:ext cx="4937760" cy="685800"/>
+            <a:off x="2194560" y="3246120"/>
+            <a:ext cx="3657600" cy="457200"/>
           </a:xfrm>
           <a:prstGeom prst="rect">
             <a:avLst/>
@@ -8358,13 +8096,12 @@
           <a:p>
             <a:pPr algn="l"/>
             <a:r>
-              <a:rPr sz="1700" b="1" i="0">
-                <a:solidFill>
-                  <a:srgbClr val="FFC107"/>
-                </a:solidFill>
-              </a:rPr>
-              <a:t>Full Audit
-Trail</a:t>
+              <a:rPr sz="1600" b="1" i="0">
+                <a:solidFill>
+                  <a:srgbClr val="FFFFFF"/>
+                </a:solidFill>
+              </a:rPr>
+              <a:t>segment coverage</a:t>
             </a:r>
           </a:p>
         </p:txBody>
@@ -8377,8 +8114,8 @@
         </p:nvSpPr>
         <p:spPr>
           <a:xfrm>
-            <a:off x="548640" y="4709160"/>
-            <a:ext cx="4937760" cy="1280160"/>
+            <a:off x="2194560" y="3675888"/>
+            <a:ext cx="9144000" cy="384048"/>
           </a:xfrm>
           <a:prstGeom prst="rect">
             <a:avLst/>
@@ -8393,12 +8130,13 @@
           <a:p>
             <a:pPr algn="l"/>
             <a:r>
-              <a:rPr sz="1800" b="0" i="0">
+              <a:rPr sz="1700" b="0" i="1">
                 <a:solidFill>
                   <a:srgbClr val="CCD6E0"/>
                 </a:solidFill>
               </a:rPr>
-              <a:t>Every check result is logged with: photo ID · trench segment · GPS coordinates · timestamp · pass/fail per check. The export is a court-admissible evidence trail, not just a summary report.</a:t>
+              <a:t>zero trench meters go unreviewed
+(photo-per-5 m rule across all 2,983 segments)</a:t>
             </a:r>
           </a:p>
         </p:txBody>
@@ -8411,8 +8149,8 @@
         </p:nvSpPr>
         <p:spPr>
           <a:xfrm>
-            <a:off x="6309360" y="3840480"/>
-            <a:ext cx="5303520" cy="2286000"/>
+            <a:off x="365760" y="4114800"/>
+            <a:ext cx="11430000" cy="859536"/>
           </a:xfrm>
           <a:prstGeom prst="rect">
             <a:avLst/>
@@ -8448,20 +8186,123 @@
       </p:sp>
       <p:sp>
         <p:nvSpPr>
-          <p:cNvPr id="18" name="Rectangle 17"/>
+          <p:cNvPr id="18" name="TextBox 17"/>
+          <p:cNvSpPr txBox="1"/>
+          <p:nvPr/>
+        </p:nvSpPr>
+        <p:spPr>
+          <a:xfrm>
+            <a:off x="548640" y="4206240"/>
+            <a:ext cx="1463040" cy="731520"/>
+          </a:xfrm>
+          <a:prstGeom prst="rect">
+            <a:avLst/>
+          </a:prstGeom>
+          <a:noFill/>
+        </p:spPr>
+        <p:txBody>
+          <a:bodyPr wrap="square">
+            <a:spAutoFit/>
+          </a:bodyPr>
+          <a:lstStyle/>
+          <a:p>
+            <a:pPr algn="ctr"/>
+            <a:r>
+              <a:rPr sz="3400" b="1" i="0">
+                <a:solidFill>
+                  <a:srgbClr val="00D47E"/>
+                </a:solidFill>
+              </a:rPr>
+              <a:t>100%</a:t>
+            </a:r>
+          </a:p>
+        </p:txBody>
+      </p:sp>
+      <p:sp>
+        <p:nvSpPr>
+          <p:cNvPr id="19" name="TextBox 18"/>
+          <p:cNvSpPr txBox="1"/>
+          <p:nvPr/>
+        </p:nvSpPr>
+        <p:spPr>
+          <a:xfrm>
+            <a:off x="2194560" y="4160520"/>
+            <a:ext cx="3657600" cy="457200"/>
+          </a:xfrm>
+          <a:prstGeom prst="rect">
+            <a:avLst/>
+          </a:prstGeom>
+          <a:noFill/>
+        </p:spPr>
+        <p:txBody>
+          <a:bodyPr wrap="square">
+            <a:spAutoFit/>
+          </a:bodyPr>
+          <a:lstStyle/>
+          <a:p>
+            <a:pPr algn="l"/>
+            <a:r>
+              <a:rPr sz="1600" b="1" i="0">
+                <a:solidFill>
+                  <a:srgbClr val="FFFFFF"/>
+                </a:solidFill>
+              </a:rPr>
+              <a:t>audit transparency</a:t>
+            </a:r>
+          </a:p>
+        </p:txBody>
+      </p:sp>
+      <p:sp>
+        <p:nvSpPr>
+          <p:cNvPr id="20" name="TextBox 19"/>
+          <p:cNvSpPr txBox="1"/>
+          <p:nvPr/>
+        </p:nvSpPr>
+        <p:spPr>
+          <a:xfrm>
+            <a:off x="2194560" y="4590288"/>
+            <a:ext cx="9144000" cy="384048"/>
+          </a:xfrm>
+          <a:prstGeom prst="rect">
+            <a:avLst/>
+          </a:prstGeom>
+          <a:noFill/>
+        </p:spPr>
+        <p:txBody>
+          <a:bodyPr wrap="square">
+            <a:spAutoFit/>
+          </a:bodyPr>
+          <a:lstStyle/>
+          <a:p>
+            <a:pPr algn="l"/>
+            <a:r>
+              <a:rPr sz="1700" b="0" i="1">
+                <a:solidFill>
+                  <a:srgbClr val="CCD6E0"/>
+                </a:solidFill>
+              </a:rPr>
+              <a:t>every check logged per photo · per meter · per timestamp
+(exportable CSV/PDF, court-admissible)</a:t>
+            </a:r>
+          </a:p>
+        </p:txBody>
+      </p:sp>
+      <p:sp>
+        <p:nvSpPr>
+          <p:cNvPr id="21" name="Rectangle 20"/>
           <p:cNvSpPr/>
           <p:nvPr/>
         </p:nvSpPr>
         <p:spPr>
           <a:xfrm>
-            <a:off x="6309360" y="3840480"/>
-            <a:ext cx="5303520" cy="91440"/>
+            <a:off x="365760" y="5029200"/>
+            <a:ext cx="11430000" cy="859536"/>
           </a:xfrm>
           <a:prstGeom prst="rect">
             <a:avLst/>
           </a:prstGeom>
           <a:solidFill>
-            <a:srgbClr val="FFFFFF"/>
+            <a:srgbClr val="122636"/>
           </a:solidFill>
           <a:ln>
             <a:noFill/>
@@ -8491,14 +8332,48 @@
       </p:sp>
       <p:sp>
         <p:nvSpPr>
-          <p:cNvPr id="19" name="TextBox 18"/>
-          <p:cNvSpPr txBox="1"/>
-          <p:nvPr/>
-        </p:nvSpPr>
-        <p:spPr>
-          <a:xfrm>
-            <a:off x="6492240" y="3977640"/>
-            <a:ext cx="4937760" cy="685800"/>
+          <p:cNvPr id="22" name="TextBox 21"/>
+          <p:cNvSpPr txBox="1"/>
+          <p:nvPr/>
+        </p:nvSpPr>
+        <p:spPr>
+          <a:xfrm>
+            <a:off x="548640" y="5120640"/>
+            <a:ext cx="1463040" cy="731520"/>
+          </a:xfrm>
+          <a:prstGeom prst="rect">
+            <a:avLst/>
+          </a:prstGeom>
+          <a:noFill/>
+        </p:spPr>
+        <p:txBody>
+          <a:bodyPr wrap="square">
+            <a:spAutoFit/>
+          </a:bodyPr>
+          <a:lstStyle/>
+          <a:p>
+            <a:pPr algn="ctr"/>
+            <a:r>
+              <a:rPr sz="3400" b="1" i="0">
+                <a:solidFill>
+                  <a:srgbClr val="00D47E"/>
+                </a:solidFill>
+              </a:rPr>
+              <a:t>0%</a:t>
+            </a:r>
+          </a:p>
+        </p:txBody>
+      </p:sp>
+      <p:sp>
+        <p:nvSpPr>
+          <p:cNvPr id="23" name="TextBox 22"/>
+          <p:cNvSpPr txBox="1"/>
+          <p:nvPr/>
+        </p:nvSpPr>
+        <p:spPr>
+          <a:xfrm>
+            <a:off x="2194560" y="5074920"/>
+            <a:ext cx="3657600" cy="457200"/>
           </a:xfrm>
           <a:prstGeom prst="rect">
             <a:avLst/>
@@ -8513,27 +8388,26 @@
           <a:p>
             <a:pPr algn="l"/>
             <a:r>
-              <a:rPr sz="1700" b="1" i="0">
+              <a:rPr sz="1600" b="1" i="0">
                 <a:solidFill>
                   <a:srgbClr val="FFFFFF"/>
                 </a:solidFill>
               </a:rPr>
-              <a:t>Contractor
-Accountability</a:t>
-            </a:r>
-          </a:p>
-        </p:txBody>
-      </p:sp>
-      <p:sp>
-        <p:nvSpPr>
-          <p:cNvPr id="20" name="TextBox 19"/>
-          <p:cNvSpPr txBox="1"/>
-          <p:nvPr/>
-        </p:nvSpPr>
-        <p:spPr>
-          <a:xfrm>
-            <a:off x="6492240" y="4709160"/>
-            <a:ext cx="4937760" cy="1280160"/>
+              <a:t>hidden GDPR risk</a:t>
+            </a:r>
+          </a:p>
+        </p:txBody>
+      </p:sp>
+      <p:sp>
+        <p:nvSpPr>
+          <p:cNvPr id="24" name="TextBox 23"/>
+          <p:cNvSpPr txBox="1"/>
+          <p:nvPr/>
+        </p:nvSpPr>
+        <p:spPr>
+          <a:xfrm>
+            <a:off x="2194560" y="5504688"/>
+            <a:ext cx="9144000" cy="384048"/>
           </a:xfrm>
           <a:prstGeom prst="rect">
             <a:avLst/>
@@ -8548,12 +8422,90 @@
           <a:p>
             <a:pPr algn="l"/>
             <a:r>
-              <a:rPr sz="1800" b="0" i="0">
+              <a:rPr sz="1700" b="0" i="1">
                 <a:solidFill>
                   <a:srgbClr val="CCD6E0"/>
                 </a:solidFill>
               </a:rPr>
-              <a:t>Duplicate-photo detection fingerprints every image. If a contractor reuses the same photo across jobs, the system catches the original, the copy, and all job IDs it was submitted to. In our pilot: ~600 duplicates detected automatically.</a:t>
+              <a:t>faces &amp; plates flagged and withheld before any reviewer sees them
+(NIS2/GDPR checks run on 100% of photos)</a:t>
+            </a:r>
+          </a:p>
+        </p:txBody>
+      </p:sp>
+      <p:sp>
+        <p:nvSpPr>
+          <p:cNvPr id="25" name="Rectangle 24"/>
+          <p:cNvSpPr/>
+          <p:nvPr/>
+        </p:nvSpPr>
+        <p:spPr>
+          <a:xfrm>
+            <a:off x="365760" y="6080760"/>
+            <a:ext cx="11430000" cy="594360"/>
+          </a:xfrm>
+          <a:prstGeom prst="rect">
+            <a:avLst/>
+          </a:prstGeom>
+          <a:solidFill>
+            <a:srgbClr val="003A20"/>
+          </a:solidFill>
+          <a:ln>
+            <a:noFill/>
+          </a:ln>
+        </p:spPr>
+        <p:style>
+          <a:lnRef idx="1">
+            <a:schemeClr val="accent1"/>
+          </a:lnRef>
+          <a:fillRef idx="3">
+            <a:schemeClr val="accent1"/>
+          </a:fillRef>
+          <a:effectRef idx="2">
+            <a:schemeClr val="accent1"/>
+          </a:effectRef>
+          <a:fontRef idx="minor">
+            <a:schemeClr val="lt1"/>
+          </a:fontRef>
+        </p:style>
+        <p:txBody>
+          <a:bodyPr rtlCol="0" anchor="ctr"/>
+          <a:lstStyle/>
+          <a:p>
+            <a:pPr algn="ctr"/>
+          </a:p>
+        </p:txBody>
+      </p:sp>
+      <p:sp>
+        <p:nvSpPr>
+          <p:cNvPr id="26" name="TextBox 25"/>
+          <p:cNvSpPr txBox="1"/>
+          <p:nvPr/>
+        </p:nvSpPr>
+        <p:spPr>
+          <a:xfrm>
+            <a:off x="548640" y="6126480"/>
+            <a:ext cx="11155680" cy="502920"/>
+          </a:xfrm>
+          <a:prstGeom prst="rect">
+            <a:avLst/>
+          </a:prstGeom>
+          <a:noFill/>
+        </p:spPr>
+        <p:txBody>
+          <a:bodyPr wrap="square">
+            <a:spAutoFit/>
+          </a:bodyPr>
+          <a:lstStyle/>
+          <a:p>
+            <a:pPr algn="ctr"/>
+            <a:r>
+              <a:rPr sz="1400" b="1" i="0">
+                <a:solidFill>
+                  <a:srgbClr val="00D47E"/>
+                </a:solidFill>
+              </a:rPr>
+              <a:t>28 minutes end-to-end  ·  3,929 photos  ·  2,983 segments scored  ·  ~600 duplicates caught</a:t>
             </a:r>
           </a:p>
         </p:txBody>
@@ -8592,7 +8544,50 @@
         </p:nvSpPr>
         <p:spPr>
           <a:xfrm>
-            <a:off x="0" y="109728"/>
+            <a:off x="0" y="0"/>
+            <a:ext cx="12188952" cy="73152"/>
+          </a:xfrm>
+          <a:prstGeom prst="rect">
+            <a:avLst/>
+          </a:prstGeom>
+          <a:solidFill>
+            <a:srgbClr val="00A8E8"/>
+          </a:solidFill>
+          <a:ln>
+            <a:noFill/>
+          </a:ln>
+        </p:spPr>
+        <p:style>
+          <a:lnRef idx="1">
+            <a:schemeClr val="accent1"/>
+          </a:lnRef>
+          <a:fillRef idx="3">
+            <a:schemeClr val="accent1"/>
+          </a:fillRef>
+          <a:effectRef idx="2">
+            <a:schemeClr val="accent1"/>
+          </a:effectRef>
+          <a:fontRef idx="minor">
+            <a:schemeClr val="lt1"/>
+          </a:fontRef>
+        </p:style>
+        <p:txBody>
+          <a:bodyPr rtlCol="0" anchor="ctr"/>
+          <a:lstStyle/>
+          <a:p>
+            <a:pPr algn="ctr"/>
+          </a:p>
+        </p:txBody>
+      </p:sp>
+      <p:sp>
+        <p:nvSpPr>
+          <p:cNvPr id="3" name="Rectangle 2"/>
+          <p:cNvSpPr/>
+          <p:nvPr/>
+        </p:nvSpPr>
+        <p:spPr>
+          <a:xfrm>
+            <a:off x="0" y="6766560"/>
             <a:ext cx="12188952" cy="73152"/>
           </a:xfrm>
           <a:prstGeom prst="rect">
@@ -8629,68 +8624,35 @@
       </p:sp>
       <p:sp>
         <p:nvSpPr>
-          <p:cNvPr id="3" name="TextBox 2"/>
-          <p:cNvSpPr txBox="1"/>
-          <p:nvPr/>
-        </p:nvSpPr>
-        <p:spPr>
-          <a:xfrm>
-            <a:off x="457200" y="228600"/>
-            <a:ext cx="10972800" cy="365760"/>
-          </a:xfrm>
-          <a:prstGeom prst="rect">
-            <a:avLst/>
-          </a:prstGeom>
-          <a:noFill/>
-        </p:spPr>
-        <p:txBody>
-          <a:bodyPr wrap="square">
-            <a:spAutoFit/>
-          </a:bodyPr>
-          <a:lstStyle/>
-          <a:p>
-            <a:pPr algn="l"/>
-            <a:r>
-              <a:rPr sz="900" b="1" i="0">
-                <a:solidFill>
-                  <a:srgbClr val="00A8E8"/>
-                </a:solidFill>
-              </a:rPr>
-              <a:t>BUSINESS VALUE</a:t>
-            </a:r>
-          </a:p>
-        </p:txBody>
-      </p:sp>
-      <p:sp>
-        <p:nvSpPr>
           <p:cNvPr id="4" name="TextBox 3"/>
           <p:cNvSpPr txBox="1"/>
           <p:nvPr/>
         </p:nvSpPr>
         <p:spPr>
           <a:xfrm>
-            <a:off x="457200" y="502920"/>
-            <a:ext cx="10972800" cy="640080"/>
-          </a:xfrm>
-          <a:prstGeom prst="rect">
-            <a:avLst/>
-          </a:prstGeom>
-          <a:noFill/>
-        </p:spPr>
-        <p:txBody>
-          <a:bodyPr wrap="square">
-            <a:spAutoFit/>
-          </a:bodyPr>
-          <a:lstStyle/>
-          <a:p>
-            <a:pPr algn="l"/>
-            <a:r>
-              <a:rPr sz="3200" b="1" i="0">
+            <a:off x="640080" y="548640"/>
+            <a:ext cx="10515600" cy="822960"/>
+          </a:xfrm>
+          <a:prstGeom prst="rect">
+            <a:avLst/>
+          </a:prstGeom>
+          <a:noFill/>
+        </p:spPr>
+        <p:txBody>
+          <a:bodyPr wrap="square">
+            <a:spAutoFit/>
+          </a:bodyPr>
+          <a:lstStyle/>
+          <a:p>
+            <a:pPr algn="ctr"/>
+            <a:r>
+              <a:rPr sz="2800" b="1" i="0">
                 <a:solidFill>
                   <a:srgbClr val="FFFFFF"/>
                 </a:solidFill>
               </a:rPr>
-              <a:t>The Numbers Speak for Themselves</a:t>
+              <a:t>Every Unreviewed Meter Is a Liability.
+We Close That Gap — Automatically.</a:t>
             </a:r>
           </a:p>
         </p:txBody>
@@ -8703,8 +8665,8 @@
         </p:nvSpPr>
         <p:spPr>
           <a:xfrm>
-            <a:off x="365760" y="1371600"/>
-            <a:ext cx="11430000" cy="859536"/>
+            <a:off x="868680" y="1600200"/>
+            <a:ext cx="3291840" cy="3840480"/>
           </a:xfrm>
           <a:prstGeom prst="rect">
             <a:avLst/>
@@ -8740,35 +8702,44 @@
       </p:sp>
       <p:sp>
         <p:nvSpPr>
-          <p:cNvPr id="6" name="TextBox 5"/>
-          <p:cNvSpPr txBox="1"/>
-          <p:nvPr/>
-        </p:nvSpPr>
-        <p:spPr>
-          <a:xfrm>
-            <a:off x="548640" y="1463040"/>
-            <a:ext cx="1463040" cy="731520"/>
-          </a:xfrm>
-          <a:prstGeom prst="rect">
-            <a:avLst/>
-          </a:prstGeom>
-          <a:noFill/>
-        </p:spPr>
-        <p:txBody>
-          <a:bodyPr wrap="square">
-            <a:spAutoFit/>
-          </a:bodyPr>
-          <a:lstStyle/>
-          <a:p>
-            <a:pPr algn="ctr"/>
-            <a:r>
-              <a:rPr sz="3400" b="1" i="0">
-                <a:solidFill>
-                  <a:srgbClr val="00D47E"/>
-                </a:solidFill>
-              </a:rPr>
-              <a:t>€2.4M+</a:t>
-            </a:r>
+          <p:cNvPr id="6" name="Rectangle 5"/>
+          <p:cNvSpPr/>
+          <p:nvPr/>
+        </p:nvSpPr>
+        <p:spPr>
+          <a:xfrm>
+            <a:off x="868680" y="1600200"/>
+            <a:ext cx="3291840" cy="137160"/>
+          </a:xfrm>
+          <a:prstGeom prst="rect">
+            <a:avLst/>
+          </a:prstGeom>
+          <a:solidFill>
+            <a:srgbClr val="00A8E8"/>
+          </a:solidFill>
+          <a:ln>
+            <a:noFill/>
+          </a:ln>
+        </p:spPr>
+        <p:style>
+          <a:lnRef idx="1">
+            <a:schemeClr val="accent1"/>
+          </a:lnRef>
+          <a:fillRef idx="3">
+            <a:schemeClr val="accent1"/>
+          </a:fillRef>
+          <a:effectRef idx="2">
+            <a:schemeClr val="accent1"/>
+          </a:effectRef>
+          <a:fontRef idx="minor">
+            <a:schemeClr val="lt1"/>
+          </a:fontRef>
+        </p:style>
+        <p:txBody>
+          <a:bodyPr rtlCol="0" anchor="ctr"/>
+          <a:lstStyle/>
+          <a:p>
+            <a:pPr algn="ctr"/>
           </a:p>
         </p:txBody>
       </p:sp>
@@ -8780,77 +8751,112 @@
         </p:nvSpPr>
         <p:spPr>
           <a:xfrm>
-            <a:off x="2194560" y="1417320"/>
-            <a:ext cx="3657600" cy="457200"/>
-          </a:xfrm>
-          <a:prstGeom prst="rect">
-            <a:avLst/>
-          </a:prstGeom>
-          <a:noFill/>
-        </p:spPr>
-        <p:txBody>
-          <a:bodyPr wrap="square">
-            <a:spAutoFit/>
-          </a:bodyPr>
-          <a:lstStyle/>
-          <a:p>
-            <a:pPr algn="l"/>
-            <a:r>
-              <a:rPr sz="1600" b="1" i="0">
+            <a:off x="868680" y="1828800"/>
+            <a:ext cx="3291840" cy="594360"/>
+          </a:xfrm>
+          <a:prstGeom prst="rect">
+            <a:avLst/>
+          </a:prstGeom>
+          <a:noFill/>
+        </p:spPr>
+        <p:txBody>
+          <a:bodyPr wrap="square">
+            <a:spAutoFit/>
+          </a:bodyPr>
+          <a:lstStyle/>
+          <a:p>
+            <a:pPr algn="ctr"/>
+            <a:r>
+              <a:rPr sz="3000" b="1" i="0">
+                <a:solidFill>
+                  <a:srgbClr val="00A8E8"/>
+                </a:solidFill>
+              </a:rPr>
+              <a:t>01</a:t>
+            </a:r>
+          </a:p>
+        </p:txBody>
+      </p:sp>
+      <p:sp>
+        <p:nvSpPr>
+          <p:cNvPr id="8" name="TextBox 7"/>
+          <p:cNvSpPr txBox="1"/>
+          <p:nvPr/>
+        </p:nvSpPr>
+        <p:spPr>
+          <a:xfrm>
+            <a:off x="868680" y="2468880"/>
+            <a:ext cx="3291840" cy="594360"/>
+          </a:xfrm>
+          <a:prstGeom prst="rect">
+            <a:avLst/>
+          </a:prstGeom>
+          <a:noFill/>
+        </p:spPr>
+        <p:txBody>
+          <a:bodyPr wrap="square">
+            <a:spAutoFit/>
+          </a:bodyPr>
+          <a:lstStyle/>
+          <a:p>
+            <a:pPr algn="ctr"/>
+            <a:r>
+              <a:rPr sz="2000" b="1" i="0">
                 <a:solidFill>
                   <a:srgbClr val="FFFFFF"/>
                 </a:solidFill>
               </a:rPr>
-              <a:t>5-year liability exposure eliminated</a:t>
-            </a:r>
-          </a:p>
-        </p:txBody>
-      </p:sp>
-      <p:sp>
-        <p:nvSpPr>
-          <p:cNvPr id="8" name="TextBox 7"/>
-          <p:cNvSpPr txBox="1"/>
-          <p:nvPr/>
-        </p:nvSpPr>
-        <p:spPr>
-          <a:xfrm>
-            <a:off x="2194560" y="1847088"/>
-            <a:ext cx="9144000" cy="384048"/>
-          </a:xfrm>
-          <a:prstGeom prst="rect">
-            <a:avLst/>
-          </a:prstGeom>
-          <a:noFill/>
-        </p:spPr>
-        <p:txBody>
-          <a:bodyPr wrap="square">
-            <a:spAutoFit/>
-          </a:bodyPr>
-          <a:lstStyle/>
-          <a:p>
-            <a:pPr algn="l"/>
-            <a:r>
-              <a:rPr sz="1700" b="0" i="1">
+              <a:t>Approve Pilot</a:t>
+            </a:r>
+          </a:p>
+        </p:txBody>
+      </p:sp>
+      <p:sp>
+        <p:nvSpPr>
+          <p:cNvPr id="9" name="TextBox 8"/>
+          <p:cNvSpPr txBox="1"/>
+          <p:nvPr/>
+        </p:nvSpPr>
+        <p:spPr>
+          <a:xfrm>
+            <a:off x="1051560" y="3200400"/>
+            <a:ext cx="2926080" cy="2011680"/>
+          </a:xfrm>
+          <a:prstGeom prst="rect">
+            <a:avLst/>
+          </a:prstGeom>
+          <a:noFill/>
+        </p:spPr>
+        <p:txBody>
+          <a:bodyPr wrap="square">
+            <a:spAutoFit/>
+          </a:bodyPr>
+          <a:lstStyle/>
+          <a:p>
+            <a:pPr algn="ctr"/>
+            <a:r>
+              <a:rPr sz="1600" b="0" i="0">
                 <a:solidFill>
                   <a:srgbClr val="CCD6E0"/>
                 </a:solidFill>
               </a:rPr>
-              <a:t>by catching every defect before contractor sign-off
-(€120K/incident × ~30% miss rate)</a:t>
-            </a:r>
-          </a:p>
-        </p:txBody>
-      </p:sp>
-      <p:sp>
-        <p:nvSpPr>
-          <p:cNvPr id="9" name="Rectangle 8"/>
+              <a:t>Authorise the TrenchVerify AI pilot
+for the current Klosterneuburg
+route build</a:t>
+            </a:r>
+          </a:p>
+        </p:txBody>
+      </p:sp>
+      <p:sp>
+        <p:nvSpPr>
+          <p:cNvPr id="10" name="Rectangle 9"/>
           <p:cNvSpPr/>
           <p:nvPr/>
         </p:nvSpPr>
         <p:spPr>
           <a:xfrm>
-            <a:off x="365760" y="2286000"/>
-            <a:ext cx="11430000" cy="859536"/>
+            <a:off x="4617720" y="1600200"/>
+            <a:ext cx="3291840" cy="3840480"/>
           </a:xfrm>
           <a:prstGeom prst="rect">
             <a:avLst/>
@@ -8886,117 +8892,161 @@
       </p:sp>
       <p:sp>
         <p:nvSpPr>
-          <p:cNvPr id="10" name="TextBox 9"/>
-          <p:cNvSpPr txBox="1"/>
-          <p:nvPr/>
-        </p:nvSpPr>
-        <p:spPr>
-          <a:xfrm>
-            <a:off x="548640" y="2377440"/>
-            <a:ext cx="1463040" cy="731520"/>
-          </a:xfrm>
-          <a:prstGeom prst="rect">
-            <a:avLst/>
-          </a:prstGeom>
-          <a:noFill/>
-        </p:spPr>
-        <p:txBody>
-          <a:bodyPr wrap="square">
-            <a:spAutoFit/>
-          </a:bodyPr>
-          <a:lstStyle/>
-          <a:p>
-            <a:pPr algn="ctr"/>
-            <a:r>
-              <a:rPr sz="3400" b="1" i="0">
-                <a:solidFill>
-                  <a:srgbClr val="00A8E8"/>
-                </a:solidFill>
-              </a:rPr>
-              <a:t>99%</a:t>
-            </a:r>
-          </a:p>
-        </p:txBody>
-      </p:sp>
-      <p:sp>
-        <p:nvSpPr>
-          <p:cNvPr id="11" name="TextBox 10"/>
-          <p:cNvSpPr txBox="1"/>
-          <p:nvPr/>
-        </p:nvSpPr>
-        <p:spPr>
-          <a:xfrm>
-            <a:off x="2194560" y="2331720"/>
-            <a:ext cx="3657600" cy="457200"/>
-          </a:xfrm>
-          <a:prstGeom prst="rect">
-            <a:avLst/>
-          </a:prstGeom>
-          <a:noFill/>
-        </p:spPr>
-        <p:txBody>
-          <a:bodyPr wrap="square">
-            <a:spAutoFit/>
-          </a:bodyPr>
-          <a:lstStyle/>
-          <a:p>
-            <a:pPr algn="l"/>
-            <a:r>
-              <a:rPr sz="1600" b="1" i="0">
+          <p:cNvPr id="11" name="Rectangle 10"/>
+          <p:cNvSpPr/>
+          <p:nvPr/>
+        </p:nvSpPr>
+        <p:spPr>
+          <a:xfrm>
+            <a:off x="4617720" y="1600200"/>
+            <a:ext cx="3291840" cy="137160"/>
+          </a:xfrm>
+          <a:prstGeom prst="rect">
+            <a:avLst/>
+          </a:prstGeom>
+          <a:solidFill>
+            <a:srgbClr val="FFC107"/>
+          </a:solidFill>
+          <a:ln>
+            <a:noFill/>
+          </a:ln>
+        </p:spPr>
+        <p:style>
+          <a:lnRef idx="1">
+            <a:schemeClr val="accent1"/>
+          </a:lnRef>
+          <a:fillRef idx="3">
+            <a:schemeClr val="accent1"/>
+          </a:fillRef>
+          <a:effectRef idx="2">
+            <a:schemeClr val="accent1"/>
+          </a:effectRef>
+          <a:fontRef idx="minor">
+            <a:schemeClr val="lt1"/>
+          </a:fontRef>
+        </p:style>
+        <p:txBody>
+          <a:bodyPr rtlCol="0" anchor="ctr"/>
+          <a:lstStyle/>
+          <a:p>
+            <a:pPr algn="ctr"/>
+          </a:p>
+        </p:txBody>
+      </p:sp>
+      <p:sp>
+        <p:nvSpPr>
+          <p:cNvPr id="12" name="TextBox 11"/>
+          <p:cNvSpPr txBox="1"/>
+          <p:nvPr/>
+        </p:nvSpPr>
+        <p:spPr>
+          <a:xfrm>
+            <a:off x="4617720" y="1828800"/>
+            <a:ext cx="3291840" cy="594360"/>
+          </a:xfrm>
+          <a:prstGeom prst="rect">
+            <a:avLst/>
+          </a:prstGeom>
+          <a:noFill/>
+        </p:spPr>
+        <p:txBody>
+          <a:bodyPr wrap="square">
+            <a:spAutoFit/>
+          </a:bodyPr>
+          <a:lstStyle/>
+          <a:p>
+            <a:pPr algn="ctr"/>
+            <a:r>
+              <a:rPr sz="3000" b="1" i="0">
+                <a:solidFill>
+                  <a:srgbClr val="FFC107"/>
+                </a:solidFill>
+              </a:rPr>
+              <a:t>02</a:t>
+            </a:r>
+          </a:p>
+        </p:txBody>
+      </p:sp>
+      <p:sp>
+        <p:nvSpPr>
+          <p:cNvPr id="13" name="TextBox 12"/>
+          <p:cNvSpPr txBox="1"/>
+          <p:nvPr/>
+        </p:nvSpPr>
+        <p:spPr>
+          <a:xfrm>
+            <a:off x="4617720" y="2468880"/>
+            <a:ext cx="3291840" cy="594360"/>
+          </a:xfrm>
+          <a:prstGeom prst="rect">
+            <a:avLst/>
+          </a:prstGeom>
+          <a:noFill/>
+        </p:spPr>
+        <p:txBody>
+          <a:bodyPr wrap="square">
+            <a:spAutoFit/>
+          </a:bodyPr>
+          <a:lstStyle/>
+          <a:p>
+            <a:pPr algn="ctr"/>
+            <a:r>
+              <a:rPr sz="2000" b="1" i="0">
                 <a:solidFill>
                   <a:srgbClr val="FFFFFF"/>
                 </a:solidFill>
               </a:rPr>
-              <a:t>faster review time</a:t>
-            </a:r>
-          </a:p>
-        </p:txBody>
-      </p:sp>
-      <p:sp>
-        <p:nvSpPr>
-          <p:cNvPr id="12" name="TextBox 11"/>
-          <p:cNvSpPr txBox="1"/>
-          <p:nvPr/>
-        </p:nvSpPr>
-        <p:spPr>
-          <a:xfrm>
-            <a:off x="2194560" y="2761488"/>
-            <a:ext cx="9144000" cy="384048"/>
-          </a:xfrm>
-          <a:prstGeom prst="rect">
-            <a:avLst/>
-          </a:prstGeom>
-          <a:noFill/>
-        </p:spPr>
-        <p:txBody>
-          <a:bodyPr wrap="square">
-            <a:spAutoFit/>
-          </a:bodyPr>
-          <a:lstStyle/>
-          <a:p>
-            <a:pPr algn="l"/>
-            <a:r>
-              <a:rPr sz="1700" b="0" i="1">
+              <a:t>Define KPIs</a:t>
+            </a:r>
+          </a:p>
+        </p:txBody>
+      </p:sp>
+      <p:sp>
+        <p:nvSpPr>
+          <p:cNvPr id="14" name="TextBox 13"/>
+          <p:cNvSpPr txBox="1"/>
+          <p:nvPr/>
+        </p:nvSpPr>
+        <p:spPr>
+          <a:xfrm>
+            <a:off x="4800600" y="3200400"/>
+            <a:ext cx="2926080" cy="2011680"/>
+          </a:xfrm>
+          <a:prstGeom prst="rect">
+            <a:avLst/>
+          </a:prstGeom>
+          <a:noFill/>
+        </p:spPr>
+        <p:txBody>
+          <a:bodyPr wrap="square">
+            <a:spAutoFit/>
+          </a:bodyPr>
+          <a:lstStyle/>
+          <a:p>
+            <a:pPr algn="ctr"/>
+            <a:r>
+              <a:rPr sz="1600" b="0" i="0">
                 <a:solidFill>
                   <a:srgbClr val="CCD6E0"/>
                 </a:solidFill>
               </a:rPr>
-              <a:t>3–5 days per section → &lt; 30 min for the full route
-(measured: 3,929 photos in 28 min)</a:t>
-            </a:r>
-          </a:p>
-        </p:txBody>
-      </p:sp>
-      <p:sp>
-        <p:nvSpPr>
-          <p:cNvPr id="13" name="Rectangle 12"/>
+              <a:t>Set acceptance thresholds:
+coverage %, photo compliance rate,
+time-to-report</a:t>
+            </a:r>
+          </a:p>
+        </p:txBody>
+      </p:sp>
+      <p:sp>
+        <p:nvSpPr>
+          <p:cNvPr id="15" name="Rectangle 14"/>
           <p:cNvSpPr/>
           <p:nvPr/>
         </p:nvSpPr>
         <p:spPr>
           <a:xfrm>
-            <a:off x="365760" y="3200400"/>
-            <a:ext cx="11430000" cy="859536"/>
+            <a:off x="8366760" y="1600200"/>
+            <a:ext cx="3291840" cy="3840480"/>
           </a:xfrm>
           <a:prstGeom prst="rect">
             <a:avLst/>
@@ -9032,123 +9082,20 @@
       </p:sp>
       <p:sp>
         <p:nvSpPr>
-          <p:cNvPr id="14" name="TextBox 13"/>
-          <p:cNvSpPr txBox="1"/>
-          <p:nvPr/>
-        </p:nvSpPr>
-        <p:spPr>
-          <a:xfrm>
-            <a:off x="548640" y="3291840"/>
-            <a:ext cx="1463040" cy="731520"/>
-          </a:xfrm>
-          <a:prstGeom prst="rect">
-            <a:avLst/>
-          </a:prstGeom>
-          <a:noFill/>
-        </p:spPr>
-        <p:txBody>
-          <a:bodyPr wrap="square">
-            <a:spAutoFit/>
-          </a:bodyPr>
-          <a:lstStyle/>
-          <a:p>
-            <a:pPr algn="ctr"/>
-            <a:r>
-              <a:rPr sz="3400" b="1" i="0">
-                <a:solidFill>
-                  <a:srgbClr val="00D47E"/>
-                </a:solidFill>
-              </a:rPr>
-              <a:t>100%</a:t>
-            </a:r>
-          </a:p>
-        </p:txBody>
-      </p:sp>
-      <p:sp>
-        <p:nvSpPr>
-          <p:cNvPr id="15" name="TextBox 14"/>
-          <p:cNvSpPr txBox="1"/>
-          <p:nvPr/>
-        </p:nvSpPr>
-        <p:spPr>
-          <a:xfrm>
-            <a:off x="2194560" y="3246120"/>
-            <a:ext cx="3657600" cy="457200"/>
-          </a:xfrm>
-          <a:prstGeom prst="rect">
-            <a:avLst/>
-          </a:prstGeom>
-          <a:noFill/>
-        </p:spPr>
-        <p:txBody>
-          <a:bodyPr wrap="square">
-            <a:spAutoFit/>
-          </a:bodyPr>
-          <a:lstStyle/>
-          <a:p>
-            <a:pPr algn="l"/>
-            <a:r>
-              <a:rPr sz="1600" b="1" i="0">
-                <a:solidFill>
-                  <a:srgbClr val="FFFFFF"/>
-                </a:solidFill>
-              </a:rPr>
-              <a:t>segment coverage</a:t>
-            </a:r>
-          </a:p>
-        </p:txBody>
-      </p:sp>
-      <p:sp>
-        <p:nvSpPr>
-          <p:cNvPr id="16" name="TextBox 15"/>
-          <p:cNvSpPr txBox="1"/>
-          <p:nvPr/>
-        </p:nvSpPr>
-        <p:spPr>
-          <a:xfrm>
-            <a:off x="2194560" y="3675888"/>
-            <a:ext cx="9144000" cy="384048"/>
-          </a:xfrm>
-          <a:prstGeom prst="rect">
-            <a:avLst/>
-          </a:prstGeom>
-          <a:noFill/>
-        </p:spPr>
-        <p:txBody>
-          <a:bodyPr wrap="square">
-            <a:spAutoFit/>
-          </a:bodyPr>
-          <a:lstStyle/>
-          <a:p>
-            <a:pPr algn="l"/>
-            <a:r>
-              <a:rPr sz="1700" b="0" i="1">
-                <a:solidFill>
-                  <a:srgbClr val="CCD6E0"/>
-                </a:solidFill>
-              </a:rPr>
-              <a:t>zero trench meters go unreviewed
-(photo-per-5 m rule across all 2,983 segments)</a:t>
-            </a:r>
-          </a:p>
-        </p:txBody>
-      </p:sp>
-      <p:sp>
-        <p:nvSpPr>
-          <p:cNvPr id="17" name="Rectangle 16"/>
+          <p:cNvPr id="16" name="Rectangle 15"/>
           <p:cNvSpPr/>
           <p:nvPr/>
         </p:nvSpPr>
         <p:spPr>
           <a:xfrm>
-            <a:off x="365760" y="4114800"/>
-            <a:ext cx="11430000" cy="859536"/>
+            <a:off x="8366760" y="1600200"/>
+            <a:ext cx="3291840" cy="137160"/>
           </a:xfrm>
           <a:prstGeom prst="rect">
             <a:avLst/>
           </a:prstGeom>
           <a:solidFill>
-            <a:srgbClr val="122636"/>
+            <a:srgbClr val="00D47E"/>
           </a:solidFill>
           <a:ln>
             <a:noFill/>
@@ -9178,326 +9125,138 @@
       </p:sp>
       <p:sp>
         <p:nvSpPr>
+          <p:cNvPr id="17" name="TextBox 16"/>
+          <p:cNvSpPr txBox="1"/>
+          <p:nvPr/>
+        </p:nvSpPr>
+        <p:spPr>
+          <a:xfrm>
+            <a:off x="8366760" y="1828800"/>
+            <a:ext cx="3291840" cy="594360"/>
+          </a:xfrm>
+          <a:prstGeom prst="rect">
+            <a:avLst/>
+          </a:prstGeom>
+          <a:noFill/>
+        </p:spPr>
+        <p:txBody>
+          <a:bodyPr wrap="square">
+            <a:spAutoFit/>
+          </a:bodyPr>
+          <a:lstStyle/>
+          <a:p>
+            <a:pPr algn="ctr"/>
+            <a:r>
+              <a:rPr sz="3000" b="1" i="0">
+                <a:solidFill>
+                  <a:srgbClr val="00D47E"/>
+                </a:solidFill>
+              </a:rPr>
+              <a:t>03</a:t>
+            </a:r>
+          </a:p>
+        </p:txBody>
+      </p:sp>
+      <p:sp>
+        <p:nvSpPr>
           <p:cNvPr id="18" name="TextBox 17"/>
           <p:cNvSpPr txBox="1"/>
           <p:nvPr/>
         </p:nvSpPr>
         <p:spPr>
           <a:xfrm>
-            <a:off x="548640" y="4206240"/>
-            <a:ext cx="1463040" cy="731520"/>
-          </a:xfrm>
-          <a:prstGeom prst="rect">
-            <a:avLst/>
-          </a:prstGeom>
-          <a:noFill/>
-        </p:spPr>
-        <p:txBody>
-          <a:bodyPr wrap="square">
-            <a:spAutoFit/>
-          </a:bodyPr>
-          <a:lstStyle/>
-          <a:p>
-            <a:pPr algn="ctr"/>
-            <a:r>
-              <a:rPr sz="3400" b="1" i="0">
+            <a:off x="8366760" y="2468880"/>
+            <a:ext cx="3291840" cy="594360"/>
+          </a:xfrm>
+          <a:prstGeom prst="rect">
+            <a:avLst/>
+          </a:prstGeom>
+          <a:noFill/>
+        </p:spPr>
+        <p:txBody>
+          <a:bodyPr wrap="square">
+            <a:spAutoFit/>
+          </a:bodyPr>
+          <a:lstStyle/>
+          <a:p>
+            <a:pPr algn="ctr"/>
+            <a:r>
+              <a:rPr sz="2000" b="1" i="0">
+                <a:solidFill>
+                  <a:srgbClr val="FFFFFF"/>
+                </a:solidFill>
+              </a:rPr>
+              <a:t>Scale</a:t>
+            </a:r>
+          </a:p>
+        </p:txBody>
+      </p:sp>
+      <p:sp>
+        <p:nvSpPr>
+          <p:cNvPr id="19" name="TextBox 18"/>
+          <p:cNvSpPr txBox="1"/>
+          <p:nvPr/>
+        </p:nvSpPr>
+        <p:spPr>
+          <a:xfrm>
+            <a:off x="8549640" y="3200400"/>
+            <a:ext cx="2926080" cy="2011680"/>
+          </a:xfrm>
+          <a:prstGeom prst="rect">
+            <a:avLst/>
+          </a:prstGeom>
+          <a:noFill/>
+        </p:spPr>
+        <p:txBody>
+          <a:bodyPr wrap="square">
+            <a:spAutoFit/>
+          </a:bodyPr>
+          <a:lstStyle/>
+          <a:p>
+            <a:pPr algn="ctr"/>
+            <a:r>
+              <a:rPr sz="1600" b="0" i="0">
+                <a:solidFill>
+                  <a:srgbClr val="CCD6E0"/>
+                </a:solidFill>
+              </a:rPr>
+              <a:t>Roll out across all future APG
+construction phases — protect
+the full network</a:t>
+            </a:r>
+          </a:p>
+        </p:txBody>
+      </p:sp>
+      <p:sp>
+        <p:nvSpPr>
+          <p:cNvPr id="20" name="TextBox 19"/>
+          <p:cNvSpPr txBox="1"/>
+          <p:nvPr/>
+        </p:nvSpPr>
+        <p:spPr>
+          <a:xfrm>
+            <a:off x="457200" y="5623560"/>
+            <a:ext cx="11247120" cy="594360"/>
+          </a:xfrm>
+          <a:prstGeom prst="rect">
+            <a:avLst/>
+          </a:prstGeom>
+          <a:noFill/>
+        </p:spPr>
+        <p:txBody>
+          <a:bodyPr wrap="square">
+            <a:spAutoFit/>
+          </a:bodyPr>
+          <a:lstStyle/>
+          <a:p>
+            <a:pPr algn="ctr"/>
+            <a:r>
+              <a:rPr sz="1700" b="1" i="0">
                 <a:solidFill>
                   <a:srgbClr val="00D47E"/>
                 </a:solidFill>
               </a:rPr>
-              <a:t>100%</a:t>
-            </a:r>
-          </a:p>
-        </p:txBody>
-      </p:sp>
-      <p:sp>
-        <p:nvSpPr>
-          <p:cNvPr id="19" name="TextBox 18"/>
-          <p:cNvSpPr txBox="1"/>
-          <p:nvPr/>
-        </p:nvSpPr>
-        <p:spPr>
-          <a:xfrm>
-            <a:off x="2194560" y="4160520"/>
-            <a:ext cx="3657600" cy="457200"/>
-          </a:xfrm>
-          <a:prstGeom prst="rect">
-            <a:avLst/>
-          </a:prstGeom>
-          <a:noFill/>
-        </p:spPr>
-        <p:txBody>
-          <a:bodyPr wrap="square">
-            <a:spAutoFit/>
-          </a:bodyPr>
-          <a:lstStyle/>
-          <a:p>
-            <a:pPr algn="l"/>
-            <a:r>
-              <a:rPr sz="1600" b="1" i="0">
-                <a:solidFill>
-                  <a:srgbClr val="FFFFFF"/>
-                </a:solidFill>
-              </a:rPr>
-              <a:t>audit transparency</a:t>
-            </a:r>
-          </a:p>
-        </p:txBody>
-      </p:sp>
-      <p:sp>
-        <p:nvSpPr>
-          <p:cNvPr id="20" name="TextBox 19"/>
-          <p:cNvSpPr txBox="1"/>
-          <p:nvPr/>
-        </p:nvSpPr>
-        <p:spPr>
-          <a:xfrm>
-            <a:off x="2194560" y="4590288"/>
-            <a:ext cx="9144000" cy="384048"/>
-          </a:xfrm>
-          <a:prstGeom prst="rect">
-            <a:avLst/>
-          </a:prstGeom>
-          <a:noFill/>
-        </p:spPr>
-        <p:txBody>
-          <a:bodyPr wrap="square">
-            <a:spAutoFit/>
-          </a:bodyPr>
-          <a:lstStyle/>
-          <a:p>
-            <a:pPr algn="l"/>
-            <a:r>
-              <a:rPr sz="1700" b="0" i="1">
-                <a:solidFill>
-                  <a:srgbClr val="CCD6E0"/>
-                </a:solidFill>
-              </a:rPr>
-              <a:t>every check logged per photo · per meter · per timestamp
-(exportable CSV/HTML, court-admissible)</a:t>
-            </a:r>
-          </a:p>
-        </p:txBody>
-      </p:sp>
-      <p:sp>
-        <p:nvSpPr>
-          <p:cNvPr id="21" name="Rectangle 20"/>
-          <p:cNvSpPr/>
-          <p:nvPr/>
-        </p:nvSpPr>
-        <p:spPr>
-          <a:xfrm>
-            <a:off x="365760" y="5029200"/>
-            <a:ext cx="11430000" cy="859536"/>
-          </a:xfrm>
-          <a:prstGeom prst="rect">
-            <a:avLst/>
-          </a:prstGeom>
-          <a:solidFill>
-            <a:srgbClr val="122636"/>
-          </a:solidFill>
-          <a:ln>
-            <a:noFill/>
-          </a:ln>
-        </p:spPr>
-        <p:style>
-          <a:lnRef idx="1">
-            <a:schemeClr val="accent1"/>
-          </a:lnRef>
-          <a:fillRef idx="3">
-            <a:schemeClr val="accent1"/>
-          </a:fillRef>
-          <a:effectRef idx="2">
-            <a:schemeClr val="accent1"/>
-          </a:effectRef>
-          <a:fontRef idx="minor">
-            <a:schemeClr val="lt1"/>
-          </a:fontRef>
-        </p:style>
-        <p:txBody>
-          <a:bodyPr rtlCol="0" anchor="ctr"/>
-          <a:lstStyle/>
-          <a:p>
-            <a:pPr algn="ctr"/>
-          </a:p>
-        </p:txBody>
-      </p:sp>
-      <p:sp>
-        <p:nvSpPr>
-          <p:cNvPr id="22" name="TextBox 21"/>
-          <p:cNvSpPr txBox="1"/>
-          <p:nvPr/>
-        </p:nvSpPr>
-        <p:spPr>
-          <a:xfrm>
-            <a:off x="548640" y="5120640"/>
-            <a:ext cx="1463040" cy="731520"/>
-          </a:xfrm>
-          <a:prstGeom prst="rect">
-            <a:avLst/>
-          </a:prstGeom>
-          <a:noFill/>
-        </p:spPr>
-        <p:txBody>
-          <a:bodyPr wrap="square">
-            <a:spAutoFit/>
-          </a:bodyPr>
-          <a:lstStyle/>
-          <a:p>
-            <a:pPr algn="ctr"/>
-            <a:r>
-              <a:rPr sz="3400" b="1" i="0">
-                <a:solidFill>
-                  <a:srgbClr val="00D47E"/>
-                </a:solidFill>
-              </a:rPr>
-              <a:t>0%</a:t>
-            </a:r>
-          </a:p>
-        </p:txBody>
-      </p:sp>
-      <p:sp>
-        <p:nvSpPr>
-          <p:cNvPr id="23" name="TextBox 22"/>
-          <p:cNvSpPr txBox="1"/>
-          <p:nvPr/>
-        </p:nvSpPr>
-        <p:spPr>
-          <a:xfrm>
-            <a:off x="2194560" y="5074920"/>
-            <a:ext cx="3657600" cy="457200"/>
-          </a:xfrm>
-          <a:prstGeom prst="rect">
-            <a:avLst/>
-          </a:prstGeom>
-          <a:noFill/>
-        </p:spPr>
-        <p:txBody>
-          <a:bodyPr wrap="square">
-            <a:spAutoFit/>
-          </a:bodyPr>
-          <a:lstStyle/>
-          <a:p>
-            <a:pPr algn="l"/>
-            <a:r>
-              <a:rPr sz="1600" b="1" i="0">
-                <a:solidFill>
-                  <a:srgbClr val="FFFFFF"/>
-                </a:solidFill>
-              </a:rPr>
-              <a:t>hidden GDPR risk</a:t>
-            </a:r>
-          </a:p>
-        </p:txBody>
-      </p:sp>
-      <p:sp>
-        <p:nvSpPr>
-          <p:cNvPr id="24" name="TextBox 23"/>
-          <p:cNvSpPr txBox="1"/>
-          <p:nvPr/>
-        </p:nvSpPr>
-        <p:spPr>
-          <a:xfrm>
-            <a:off x="2194560" y="5504688"/>
-            <a:ext cx="9144000" cy="384048"/>
-          </a:xfrm>
-          <a:prstGeom prst="rect">
-            <a:avLst/>
-          </a:prstGeom>
-          <a:noFill/>
-        </p:spPr>
-        <p:txBody>
-          <a:bodyPr wrap="square">
-            <a:spAutoFit/>
-          </a:bodyPr>
-          <a:lstStyle/>
-          <a:p>
-            <a:pPr algn="l"/>
-            <a:r>
-              <a:rPr sz="1700" b="0" i="1">
-                <a:solidFill>
-                  <a:srgbClr val="CCD6E0"/>
-                </a:solidFill>
-              </a:rPr>
-              <a:t>faces &amp; plates flagged and withheld before any reviewer sees them
-(NIS2/GDPR checks run on 100% of photos)</a:t>
-            </a:r>
-          </a:p>
-        </p:txBody>
-      </p:sp>
-      <p:sp>
-        <p:nvSpPr>
-          <p:cNvPr id="25" name="Rectangle 24"/>
-          <p:cNvSpPr/>
-          <p:nvPr/>
-        </p:nvSpPr>
-        <p:spPr>
-          <a:xfrm>
-            <a:off x="365760" y="6080760"/>
-            <a:ext cx="11430000" cy="594360"/>
-          </a:xfrm>
-          <a:prstGeom prst="rect">
-            <a:avLst/>
-          </a:prstGeom>
-          <a:solidFill>
-            <a:srgbClr val="003A20"/>
-          </a:solidFill>
-          <a:ln>
-            <a:noFill/>
-          </a:ln>
-        </p:spPr>
-        <p:style>
-          <a:lnRef idx="1">
-            <a:schemeClr val="accent1"/>
-          </a:lnRef>
-          <a:fillRef idx="3">
-            <a:schemeClr val="accent1"/>
-          </a:fillRef>
-          <a:effectRef idx="2">
-            <a:schemeClr val="accent1"/>
-          </a:effectRef>
-          <a:fontRef idx="minor">
-            <a:schemeClr val="lt1"/>
-          </a:fontRef>
-        </p:style>
-        <p:txBody>
-          <a:bodyPr rtlCol="0" anchor="ctr"/>
-          <a:lstStyle/>
-          <a:p>
-            <a:pPr algn="ctr"/>
-          </a:p>
-        </p:txBody>
-      </p:sp>
-      <p:sp>
-        <p:nvSpPr>
-          <p:cNvPr id="26" name="TextBox 25"/>
-          <p:cNvSpPr txBox="1"/>
-          <p:nvPr/>
-        </p:nvSpPr>
-        <p:spPr>
-          <a:xfrm>
-            <a:off x="548640" y="6126480"/>
-            <a:ext cx="11155680" cy="502920"/>
-          </a:xfrm>
-          <a:prstGeom prst="rect">
-            <a:avLst/>
-          </a:prstGeom>
-          <a:noFill/>
-        </p:spPr>
-        <p:txBody>
-          <a:bodyPr wrap="square">
-            <a:spAutoFit/>
-          </a:bodyPr>
-          <a:lstStyle/>
-          <a:p>
-            <a:pPr algn="ctr"/>
-            <a:r>
-              <a:rPr sz="1400" b="1" i="0">
-                <a:solidFill>
-                  <a:srgbClr val="00D47E"/>
-                </a:solidFill>
-              </a:rPr>
-              <a:t>$15 in AI cost  ·  28 minutes end-to-end  ·  3,929 photos  ·  2,983 segments scored  ·  ~600 duplicates caught</a:t>
+              <a:t>Protect €42M+ in infrastructure.  Secure the 50-year network lifespan.  Act today.</a:t>
             </a:r>
           </a:p>
         </p:txBody>
@@ -9622,116 +9381,97 @@
         </p:nvSpPr>
         <p:spPr>
           <a:xfrm>
-            <a:off x="640080" y="548640"/>
-            <a:ext cx="10515600" cy="822960"/>
-          </a:xfrm>
-          <a:prstGeom prst="rect">
-            <a:avLst/>
-          </a:prstGeom>
-          <a:noFill/>
-        </p:spPr>
-        <p:txBody>
-          <a:bodyPr wrap="square">
-            <a:spAutoFit/>
-          </a:bodyPr>
-          <a:lstStyle/>
-          <a:p>
-            <a:pPr algn="ctr"/>
-            <a:r>
-              <a:rPr sz="2800" b="1" i="0">
+            <a:off x="457200" y="1645920"/>
+            <a:ext cx="11247120" cy="1645920"/>
+          </a:xfrm>
+          <a:prstGeom prst="rect">
+            <a:avLst/>
+          </a:prstGeom>
+          <a:noFill/>
+        </p:spPr>
+        <p:txBody>
+          <a:bodyPr wrap="square">
+            <a:spAutoFit/>
+          </a:bodyPr>
+          <a:lstStyle/>
+          <a:p>
+            <a:pPr algn="ctr"/>
+            <a:r>
+              <a:rPr sz="8000" b="1" i="0">
                 <a:solidFill>
                   <a:srgbClr val="FFFFFF"/>
                 </a:solidFill>
               </a:rPr>
-              <a:t>Every Unreviewed Meter Is a Liability.
-We Close That Gap — Automatically.</a:t>
-            </a:r>
-          </a:p>
-        </p:txBody>
-      </p:sp>
-      <p:sp>
-        <p:nvSpPr>
-          <p:cNvPr id="5" name="Rectangle 4"/>
-          <p:cNvSpPr/>
-          <p:nvPr/>
-        </p:nvSpPr>
-        <p:spPr>
-          <a:xfrm>
-            <a:off x="868680" y="1600200"/>
-            <a:ext cx="3291840" cy="3840480"/>
-          </a:xfrm>
-          <a:prstGeom prst="rect">
-            <a:avLst/>
-          </a:prstGeom>
-          <a:solidFill>
-            <a:srgbClr val="122636"/>
-          </a:solidFill>
-          <a:ln>
-            <a:noFill/>
-          </a:ln>
-        </p:spPr>
-        <p:style>
-          <a:lnRef idx="1">
-            <a:schemeClr val="accent1"/>
-          </a:lnRef>
-          <a:fillRef idx="3">
-            <a:schemeClr val="accent1"/>
-          </a:fillRef>
-          <a:effectRef idx="2">
-            <a:schemeClr val="accent1"/>
-          </a:effectRef>
-          <a:fontRef idx="minor">
-            <a:schemeClr val="lt1"/>
-          </a:fontRef>
-        </p:style>
-        <p:txBody>
-          <a:bodyPr rtlCol="0" anchor="ctr"/>
-          <a:lstStyle/>
-          <a:p>
-            <a:pPr algn="ctr"/>
-          </a:p>
-        </p:txBody>
-      </p:sp>
-      <p:sp>
-        <p:nvSpPr>
-          <p:cNvPr id="6" name="Rectangle 5"/>
-          <p:cNvSpPr/>
-          <p:nvPr/>
-        </p:nvSpPr>
-        <p:spPr>
-          <a:xfrm>
-            <a:off x="868680" y="1600200"/>
-            <a:ext cx="3291840" cy="137160"/>
-          </a:xfrm>
-          <a:prstGeom prst="rect">
-            <a:avLst/>
-          </a:prstGeom>
-          <a:solidFill>
-            <a:srgbClr val="00A8E8"/>
-          </a:solidFill>
-          <a:ln>
-            <a:noFill/>
-          </a:ln>
-        </p:spPr>
-        <p:style>
-          <a:lnRef idx="1">
-            <a:schemeClr val="accent1"/>
-          </a:lnRef>
-          <a:fillRef idx="3">
-            <a:schemeClr val="accent1"/>
-          </a:fillRef>
-          <a:effectRef idx="2">
-            <a:schemeClr val="accent1"/>
-          </a:effectRef>
-          <a:fontRef idx="minor">
-            <a:schemeClr val="lt1"/>
-          </a:fontRef>
-        </p:style>
-        <p:txBody>
-          <a:bodyPr rtlCol="0" anchor="ctr"/>
-          <a:lstStyle/>
-          <a:p>
-            <a:pPr algn="ctr"/>
+              <a:t>Thank You</a:t>
+            </a:r>
+          </a:p>
+        </p:txBody>
+      </p:sp>
+      <p:sp>
+        <p:nvSpPr>
+          <p:cNvPr id="5" name="TextBox 4"/>
+          <p:cNvSpPr txBox="1"/>
+          <p:nvPr/>
+        </p:nvSpPr>
+        <p:spPr>
+          <a:xfrm>
+            <a:off x="457200" y="3383280"/>
+            <a:ext cx="11247120" cy="640080"/>
+          </a:xfrm>
+          <a:prstGeom prst="rect">
+            <a:avLst/>
+          </a:prstGeom>
+          <a:noFill/>
+        </p:spPr>
+        <p:txBody>
+          <a:bodyPr wrap="square">
+            <a:spAutoFit/>
+          </a:bodyPr>
+          <a:lstStyle/>
+          <a:p>
+            <a:pPr algn="ctr"/>
+            <a:r>
+              <a:rPr sz="3000" b="0" i="0">
+                <a:solidFill>
+                  <a:srgbClr val="00A8E8"/>
+                </a:solidFill>
+              </a:rPr>
+              <a:t>Questions welcome</a:t>
+            </a:r>
+          </a:p>
+        </p:txBody>
+      </p:sp>
+      <p:sp>
+        <p:nvSpPr>
+          <p:cNvPr id="6" name="TextBox 5"/>
+          <p:cNvSpPr txBox="1"/>
+          <p:nvPr/>
+        </p:nvSpPr>
+        <p:spPr>
+          <a:xfrm>
+            <a:off x="457200" y="4206240"/>
+            <a:ext cx="11247120" cy="502920"/>
+          </a:xfrm>
+          <a:prstGeom prst="rect">
+            <a:avLst/>
+          </a:prstGeom>
+          <a:noFill/>
+        </p:spPr>
+        <p:txBody>
+          <a:bodyPr wrap="square">
+            <a:spAutoFit/>
+          </a:bodyPr>
+          <a:lstStyle/>
+          <a:p>
+            <a:pPr algn="ctr"/>
+            <a:r>
+              <a:rPr sz="1600" b="0" i="0">
+                <a:solidFill>
+                  <a:srgbClr val="CCD6E0"/>
+                </a:solidFill>
+              </a:rPr>
+              <a:t>TrenchVerify — From Site Photo to Compliance Audit — Automatically</a:t>
+            </a:r>
           </a:p>
         </p:txBody>
       </p:sp>
@@ -9743,28 +9483,28 @@
         </p:nvSpPr>
         <p:spPr>
           <a:xfrm>
-            <a:off x="868680" y="1828800"/>
-            <a:ext cx="3291840" cy="594360"/>
-          </a:xfrm>
-          <a:prstGeom prst="rect">
-            <a:avLst/>
-          </a:prstGeom>
-          <a:noFill/>
-        </p:spPr>
-        <p:txBody>
-          <a:bodyPr wrap="square">
-            <a:spAutoFit/>
-          </a:bodyPr>
-          <a:lstStyle/>
-          <a:p>
-            <a:pPr algn="ctr"/>
-            <a:r>
-              <a:rPr sz="3000" b="1" i="0">
-                <a:solidFill>
-                  <a:srgbClr val="00A8E8"/>
-                </a:solidFill>
-              </a:rPr>
-              <a:t>01</a:t>
+            <a:off x="457200" y="4754880"/>
+            <a:ext cx="11247120" cy="457200"/>
+          </a:xfrm>
+          <a:prstGeom prst="rect">
+            <a:avLst/>
+          </a:prstGeom>
+          <a:noFill/>
+        </p:spPr>
+        <p:txBody>
+          <a:bodyPr wrap="square">
+            <a:spAutoFit/>
+          </a:bodyPr>
+          <a:lstStyle/>
+          <a:p>
+            <a:pPr algn="ctr"/>
+            <a:r>
+              <a:rPr sz="1500" b="0" i="0">
+                <a:solidFill>
+                  <a:srgbClr val="CCD6E0"/>
+                </a:solidFill>
+              </a:rPr>
+              <a:t>Team: [Name 1]  ·  [Name 2]  ·  [Name 3]</a:t>
             </a:r>
           </a:p>
         </p:txBody>
@@ -9777,478 +9517,28 @@
         </p:nvSpPr>
         <p:spPr>
           <a:xfrm>
-            <a:off x="868680" y="2468880"/>
-            <a:ext cx="3291840" cy="594360"/>
-          </a:xfrm>
-          <a:prstGeom prst="rect">
-            <a:avLst/>
-          </a:prstGeom>
-          <a:noFill/>
-        </p:spPr>
-        <p:txBody>
-          <a:bodyPr wrap="square">
-            <a:spAutoFit/>
-          </a:bodyPr>
-          <a:lstStyle/>
-          <a:p>
-            <a:pPr algn="ctr"/>
-            <a:r>
-              <a:rPr sz="2000" b="1" i="0">
-                <a:solidFill>
-                  <a:srgbClr val="FFFFFF"/>
-                </a:solidFill>
-              </a:rPr>
-              <a:t>Approve Pilot</a:t>
-            </a:r>
-          </a:p>
-        </p:txBody>
-      </p:sp>
-      <p:sp>
-        <p:nvSpPr>
-          <p:cNvPr id="9" name="TextBox 8"/>
-          <p:cNvSpPr txBox="1"/>
-          <p:nvPr/>
-        </p:nvSpPr>
-        <p:spPr>
-          <a:xfrm>
-            <a:off x="1051560" y="3200400"/>
-            <a:ext cx="2926080" cy="2011680"/>
-          </a:xfrm>
-          <a:prstGeom prst="rect">
-            <a:avLst/>
-          </a:prstGeom>
-          <a:noFill/>
-        </p:spPr>
-        <p:txBody>
-          <a:bodyPr wrap="square">
-            <a:spAutoFit/>
-          </a:bodyPr>
-          <a:lstStyle/>
-          <a:p>
-            <a:pPr algn="ctr"/>
-            <a:r>
-              <a:rPr sz="1600" b="0" i="0">
-                <a:solidFill>
-                  <a:srgbClr val="CCD6E0"/>
-                </a:solidFill>
-              </a:rPr>
-              <a:t>Authorise the TrenchVerify AI pilot
-for the current Klosterneuburg
-route build</a:t>
-            </a:r>
-          </a:p>
-        </p:txBody>
-      </p:sp>
-      <p:sp>
-        <p:nvSpPr>
-          <p:cNvPr id="10" name="Rectangle 9"/>
-          <p:cNvSpPr/>
-          <p:nvPr/>
-        </p:nvSpPr>
-        <p:spPr>
-          <a:xfrm>
-            <a:off x="4617720" y="1600200"/>
-            <a:ext cx="3291840" cy="3840480"/>
-          </a:xfrm>
-          <a:prstGeom prst="rect">
-            <a:avLst/>
-          </a:prstGeom>
-          <a:solidFill>
-            <a:srgbClr val="122636"/>
-          </a:solidFill>
-          <a:ln>
-            <a:noFill/>
-          </a:ln>
-        </p:spPr>
-        <p:style>
-          <a:lnRef idx="1">
-            <a:schemeClr val="accent1"/>
-          </a:lnRef>
-          <a:fillRef idx="3">
-            <a:schemeClr val="accent1"/>
-          </a:fillRef>
-          <a:effectRef idx="2">
-            <a:schemeClr val="accent1"/>
-          </a:effectRef>
-          <a:fontRef idx="minor">
-            <a:schemeClr val="lt1"/>
-          </a:fontRef>
-        </p:style>
-        <p:txBody>
-          <a:bodyPr rtlCol="0" anchor="ctr"/>
-          <a:lstStyle/>
-          <a:p>
-            <a:pPr algn="ctr"/>
-          </a:p>
-        </p:txBody>
-      </p:sp>
-      <p:sp>
-        <p:nvSpPr>
-          <p:cNvPr id="11" name="Rectangle 10"/>
-          <p:cNvSpPr/>
-          <p:nvPr/>
-        </p:nvSpPr>
-        <p:spPr>
-          <a:xfrm>
-            <a:off x="4617720" y="1600200"/>
-            <a:ext cx="3291840" cy="137160"/>
-          </a:xfrm>
-          <a:prstGeom prst="rect">
-            <a:avLst/>
-          </a:prstGeom>
-          <a:solidFill>
-            <a:srgbClr val="FFC107"/>
-          </a:solidFill>
-          <a:ln>
-            <a:noFill/>
-          </a:ln>
-        </p:spPr>
-        <p:style>
-          <a:lnRef idx="1">
-            <a:schemeClr val="accent1"/>
-          </a:lnRef>
-          <a:fillRef idx="3">
-            <a:schemeClr val="accent1"/>
-          </a:fillRef>
-          <a:effectRef idx="2">
-            <a:schemeClr val="accent1"/>
-          </a:effectRef>
-          <a:fontRef idx="minor">
-            <a:schemeClr val="lt1"/>
-          </a:fontRef>
-        </p:style>
-        <p:txBody>
-          <a:bodyPr rtlCol="0" anchor="ctr"/>
-          <a:lstStyle/>
-          <a:p>
-            <a:pPr algn="ctr"/>
-          </a:p>
-        </p:txBody>
-      </p:sp>
-      <p:sp>
-        <p:nvSpPr>
-          <p:cNvPr id="12" name="TextBox 11"/>
-          <p:cNvSpPr txBox="1"/>
-          <p:nvPr/>
-        </p:nvSpPr>
-        <p:spPr>
-          <a:xfrm>
-            <a:off x="4617720" y="1828800"/>
-            <a:ext cx="3291840" cy="594360"/>
-          </a:xfrm>
-          <a:prstGeom prst="rect">
-            <a:avLst/>
-          </a:prstGeom>
-          <a:noFill/>
-        </p:spPr>
-        <p:txBody>
-          <a:bodyPr wrap="square">
-            <a:spAutoFit/>
-          </a:bodyPr>
-          <a:lstStyle/>
-          <a:p>
-            <a:pPr algn="ctr"/>
-            <a:r>
-              <a:rPr sz="3000" b="1" i="0">
-                <a:solidFill>
-                  <a:srgbClr val="FFC107"/>
-                </a:solidFill>
-              </a:rPr>
-              <a:t>02</a:t>
-            </a:r>
-          </a:p>
-        </p:txBody>
-      </p:sp>
-      <p:sp>
-        <p:nvSpPr>
-          <p:cNvPr id="13" name="TextBox 12"/>
-          <p:cNvSpPr txBox="1"/>
-          <p:nvPr/>
-        </p:nvSpPr>
-        <p:spPr>
-          <a:xfrm>
-            <a:off x="4617720" y="2468880"/>
-            <a:ext cx="3291840" cy="594360"/>
-          </a:xfrm>
-          <a:prstGeom prst="rect">
-            <a:avLst/>
-          </a:prstGeom>
-          <a:noFill/>
-        </p:spPr>
-        <p:txBody>
-          <a:bodyPr wrap="square">
-            <a:spAutoFit/>
-          </a:bodyPr>
-          <a:lstStyle/>
-          <a:p>
-            <a:pPr algn="ctr"/>
-            <a:r>
-              <a:rPr sz="2000" b="1" i="0">
-                <a:solidFill>
-                  <a:srgbClr val="FFFFFF"/>
-                </a:solidFill>
-              </a:rPr>
-              <a:t>Define KPIs</a:t>
-            </a:r>
-          </a:p>
-        </p:txBody>
-      </p:sp>
-      <p:sp>
-        <p:nvSpPr>
-          <p:cNvPr id="14" name="TextBox 13"/>
-          <p:cNvSpPr txBox="1"/>
-          <p:nvPr/>
-        </p:nvSpPr>
-        <p:spPr>
-          <a:xfrm>
-            <a:off x="4800600" y="3200400"/>
-            <a:ext cx="2926080" cy="2011680"/>
-          </a:xfrm>
-          <a:prstGeom prst="rect">
-            <a:avLst/>
-          </a:prstGeom>
-          <a:noFill/>
-        </p:spPr>
-        <p:txBody>
-          <a:bodyPr wrap="square">
-            <a:spAutoFit/>
-          </a:bodyPr>
-          <a:lstStyle/>
-          <a:p>
-            <a:pPr algn="ctr"/>
-            <a:r>
-              <a:rPr sz="1600" b="0" i="0">
-                <a:solidFill>
-                  <a:srgbClr val="CCD6E0"/>
-                </a:solidFill>
-              </a:rPr>
-              <a:t>Set acceptance thresholds:
-coverage %, photo compliance rate,
-time-to-report</a:t>
-            </a:r>
-          </a:p>
-        </p:txBody>
-      </p:sp>
-      <p:sp>
-        <p:nvSpPr>
-          <p:cNvPr id="15" name="Rectangle 14"/>
-          <p:cNvSpPr/>
-          <p:nvPr/>
-        </p:nvSpPr>
-        <p:spPr>
-          <a:xfrm>
-            <a:off x="8366760" y="1600200"/>
-            <a:ext cx="3291840" cy="3840480"/>
-          </a:xfrm>
-          <a:prstGeom prst="rect">
-            <a:avLst/>
-          </a:prstGeom>
-          <a:solidFill>
-            <a:srgbClr val="122636"/>
-          </a:solidFill>
-          <a:ln>
-            <a:noFill/>
-          </a:ln>
-        </p:spPr>
-        <p:style>
-          <a:lnRef idx="1">
-            <a:schemeClr val="accent1"/>
-          </a:lnRef>
-          <a:fillRef idx="3">
-            <a:schemeClr val="accent1"/>
-          </a:fillRef>
-          <a:effectRef idx="2">
-            <a:schemeClr val="accent1"/>
-          </a:effectRef>
-          <a:fontRef idx="minor">
-            <a:schemeClr val="lt1"/>
-          </a:fontRef>
-        </p:style>
-        <p:txBody>
-          <a:bodyPr rtlCol="0" anchor="ctr"/>
-          <a:lstStyle/>
-          <a:p>
-            <a:pPr algn="ctr"/>
-          </a:p>
-        </p:txBody>
-      </p:sp>
-      <p:sp>
-        <p:nvSpPr>
-          <p:cNvPr id="16" name="Rectangle 15"/>
-          <p:cNvSpPr/>
-          <p:nvPr/>
-        </p:nvSpPr>
-        <p:spPr>
-          <a:xfrm>
-            <a:off x="8366760" y="1600200"/>
-            <a:ext cx="3291840" cy="137160"/>
-          </a:xfrm>
-          <a:prstGeom prst="rect">
-            <a:avLst/>
-          </a:prstGeom>
-          <a:solidFill>
-            <a:srgbClr val="00D47E"/>
-          </a:solidFill>
-          <a:ln>
-            <a:noFill/>
-          </a:ln>
-        </p:spPr>
-        <p:style>
-          <a:lnRef idx="1">
-            <a:schemeClr val="accent1"/>
-          </a:lnRef>
-          <a:fillRef idx="3">
-            <a:schemeClr val="accent1"/>
-          </a:fillRef>
-          <a:effectRef idx="2">
-            <a:schemeClr val="accent1"/>
-          </a:effectRef>
-          <a:fontRef idx="minor">
-            <a:schemeClr val="lt1"/>
-          </a:fontRef>
-        </p:style>
-        <p:txBody>
-          <a:bodyPr rtlCol="0" anchor="ctr"/>
-          <a:lstStyle/>
-          <a:p>
-            <a:pPr algn="ctr"/>
-          </a:p>
-        </p:txBody>
-      </p:sp>
-      <p:sp>
-        <p:nvSpPr>
-          <p:cNvPr id="17" name="TextBox 16"/>
-          <p:cNvSpPr txBox="1"/>
-          <p:nvPr/>
-        </p:nvSpPr>
-        <p:spPr>
-          <a:xfrm>
-            <a:off x="8366760" y="1828800"/>
-            <a:ext cx="3291840" cy="594360"/>
-          </a:xfrm>
-          <a:prstGeom prst="rect">
-            <a:avLst/>
-          </a:prstGeom>
-          <a:noFill/>
-        </p:spPr>
-        <p:txBody>
-          <a:bodyPr wrap="square">
-            <a:spAutoFit/>
-          </a:bodyPr>
-          <a:lstStyle/>
-          <a:p>
-            <a:pPr algn="ctr"/>
-            <a:r>
-              <a:rPr sz="3000" b="1" i="0">
-                <a:solidFill>
-                  <a:srgbClr val="00D47E"/>
-                </a:solidFill>
-              </a:rPr>
-              <a:t>03</a:t>
-            </a:r>
-          </a:p>
-        </p:txBody>
-      </p:sp>
-      <p:sp>
-        <p:nvSpPr>
-          <p:cNvPr id="18" name="TextBox 17"/>
-          <p:cNvSpPr txBox="1"/>
-          <p:nvPr/>
-        </p:nvSpPr>
-        <p:spPr>
-          <a:xfrm>
-            <a:off x="8366760" y="2468880"/>
-            <a:ext cx="3291840" cy="594360"/>
-          </a:xfrm>
-          <a:prstGeom prst="rect">
-            <a:avLst/>
-          </a:prstGeom>
-          <a:noFill/>
-        </p:spPr>
-        <p:txBody>
-          <a:bodyPr wrap="square">
-            <a:spAutoFit/>
-          </a:bodyPr>
-          <a:lstStyle/>
-          <a:p>
-            <a:pPr algn="ctr"/>
-            <a:r>
-              <a:rPr sz="2000" b="1" i="0">
-                <a:solidFill>
-                  <a:srgbClr val="FFFFFF"/>
-                </a:solidFill>
-              </a:rPr>
-              <a:t>Scale</a:t>
-            </a:r>
-          </a:p>
-        </p:txBody>
-      </p:sp>
-      <p:sp>
-        <p:nvSpPr>
-          <p:cNvPr id="19" name="TextBox 18"/>
-          <p:cNvSpPr txBox="1"/>
-          <p:nvPr/>
-        </p:nvSpPr>
-        <p:spPr>
-          <a:xfrm>
-            <a:off x="8549640" y="3200400"/>
-            <a:ext cx="2926080" cy="2011680"/>
-          </a:xfrm>
-          <a:prstGeom prst="rect">
-            <a:avLst/>
-          </a:prstGeom>
-          <a:noFill/>
-        </p:spPr>
-        <p:txBody>
-          <a:bodyPr wrap="square">
-            <a:spAutoFit/>
-          </a:bodyPr>
-          <a:lstStyle/>
-          <a:p>
-            <a:pPr algn="ctr"/>
-            <a:r>
-              <a:rPr sz="1600" b="0" i="0">
-                <a:solidFill>
-                  <a:srgbClr val="CCD6E0"/>
-                </a:solidFill>
-              </a:rPr>
-              <a:t>Roll out across all future APG
-construction phases — protect
-the full network</a:t>
-            </a:r>
-          </a:p>
-        </p:txBody>
-      </p:sp>
-      <p:sp>
-        <p:nvSpPr>
-          <p:cNvPr id="20" name="TextBox 19"/>
-          <p:cNvSpPr txBox="1"/>
-          <p:nvPr/>
-        </p:nvSpPr>
-        <p:spPr>
-          <a:xfrm>
-            <a:off x="457200" y="5623560"/>
-            <a:ext cx="11247120" cy="594360"/>
-          </a:xfrm>
-          <a:prstGeom prst="rect">
-            <a:avLst/>
-          </a:prstGeom>
-          <a:noFill/>
-        </p:spPr>
-        <p:txBody>
-          <a:bodyPr wrap="square">
-            <a:spAutoFit/>
-          </a:bodyPr>
-          <a:lstStyle/>
-          <a:p>
-            <a:pPr algn="ctr"/>
-            <a:r>
-              <a:rPr sz="1700" b="1" i="0">
-                <a:solidFill>
-                  <a:srgbClr val="00D47E"/>
-                </a:solidFill>
-              </a:rPr>
-              <a:t>Protect €42M+ in infrastructure.  Secure the 50-year network lifespan.  Act today.</a:t>
+            <a:off x="457200" y="5989320"/>
+            <a:ext cx="11247120" cy="365760"/>
+          </a:xfrm>
+          <a:prstGeom prst="rect">
+            <a:avLst/>
+          </a:prstGeom>
+          <a:noFill/>
+        </p:spPr>
+        <p:txBody>
+          <a:bodyPr wrap="square">
+            <a:spAutoFit/>
+          </a:bodyPr>
+          <a:lstStyle/>
+          <a:p>
+            <a:pPr algn="ctr"/>
+            <a:r>
+              <a:rPr sz="1100" b="0" i="1">
+                <a:solidFill>
+                  <a:srgbClr val="445566"/>
+                </a:solidFill>
+              </a:rPr>
+              <a:t>Built at Vienna UP 2026  ·  All pilot data from APG partner dataset</a:t>
             </a:r>
           </a:p>
         </p:txBody>

</xml_diff>

<commit_message>
Update APG pitch deck
</commit_message>
<xml_diff>
--- a/APG_TrenchVerify_Pitch.pptx
+++ b/APG_TrenchVerify_Pitch.pptx
@@ -5,17 +5,16 @@
     <p:sldMasterId id="2147483648" r:id="rId1"/>
   </p:sldMasterIdLst>
   <p:sldIdLst>
-    <p:sldId id="256" r:id="rId7"/>
-    <p:sldId id="257" r:id="rId8"/>
-    <p:sldId id="258" r:id="rId9"/>
-    <p:sldId id="259" r:id="rId10"/>
-    <p:sldId id="260" r:id="rId11"/>
-    <p:sldId id="261" r:id="rId12"/>
-    <p:sldId id="262" r:id="rId13"/>
-    <p:sldId id="263" r:id="rId14"/>
-    <p:sldId id="264" r:id="rId15"/>
+    <p:sldId id="256" r:id="rId2"/>
+    <p:sldId id="257" r:id="rId3"/>
+    <p:sldId id="258" r:id="rId4"/>
+    <p:sldId id="259" r:id="rId5"/>
+    <p:sldId id="260" r:id="rId6"/>
+    <p:sldId id="261" r:id="rId7"/>
+    <p:sldId id="263" r:id="rId8"/>
+    <p:sldId id="264" r:id="rId9"/>
   </p:sldIdLst>
-  <p:sldSz cx="12188952" cy="6858000" type="screen4x3"/>
+  <p:sldSz cx="12188825" cy="6858000"/>
   <p:notesSz cx="6858000" cy="9144000"/>
   <p:defaultTextStyle>
     <a:defPPr>
@@ -112,6 +111,22 @@
       </a:defRPr>
     </a:lvl9pPr>
   </p:defaultTextStyle>
+  <p:extLst>
+    <p:ext uri="{EFAFB233-063F-42B5-8137-9DF3F51BA10A}">
+      <p15:sldGuideLst xmlns:p15="http://schemas.microsoft.com/office/powerpoint/2012/main">
+        <p15:guide id="1" orient="horz" pos="2160">
+          <p15:clr>
+            <a:srgbClr val="A4A3A4"/>
+          </p15:clr>
+        </p15:guide>
+        <p15:guide id="2" pos="2880">
+          <p15:clr>
+            <a:srgbClr val="A4A3A4"/>
+          </p15:clr>
+        </p15:guide>
+      </p15:sldGuideLst>
+    </p:ext>
+  </p:extLst>
 </p:presentation>
 </file>
 
@@ -296,7 +311,7 @@
           <a:p>
             <a:fld id="{5BCAD085-E8A6-8845-BD4E-CB4CCA059FC4}" type="datetimeFigureOut">
               <a:rPr lang="en-US" smtClean="0"/>
-              <a:t>1/27/13</a:t>
+              <a:t>5/16/2026</a:t>
             </a:fld>
             <a:endParaRPr lang="en-US"/>
           </a:p>
@@ -466,7 +481,7 @@
           <a:p>
             <a:fld id="{5BCAD085-E8A6-8845-BD4E-CB4CCA059FC4}" type="datetimeFigureOut">
               <a:rPr lang="en-US" smtClean="0"/>
-              <a:t>1/27/13</a:t>
+              <a:t>5/16/2026</a:t>
             </a:fld>
             <a:endParaRPr lang="en-US"/>
           </a:p>
@@ -646,7 +661,7 @@
           <a:p>
             <a:fld id="{5BCAD085-E8A6-8845-BD4E-CB4CCA059FC4}" type="datetimeFigureOut">
               <a:rPr lang="en-US" smtClean="0"/>
-              <a:t>1/27/13</a:t>
+              <a:t>5/16/2026</a:t>
             </a:fld>
             <a:endParaRPr lang="en-US"/>
           </a:p>
@@ -816,7 +831,7 @@
           <a:p>
             <a:fld id="{5BCAD085-E8A6-8845-BD4E-CB4CCA059FC4}" type="datetimeFigureOut">
               <a:rPr lang="en-US" smtClean="0"/>
-              <a:t>1/27/13</a:t>
+              <a:t>5/16/2026</a:t>
             </a:fld>
             <a:endParaRPr lang="en-US"/>
           </a:p>
@@ -1062,7 +1077,7 @@
           <a:p>
             <a:fld id="{5BCAD085-E8A6-8845-BD4E-CB4CCA059FC4}" type="datetimeFigureOut">
               <a:rPr lang="en-US" smtClean="0"/>
-              <a:t>1/27/13</a:t>
+              <a:t>5/16/2026</a:t>
             </a:fld>
             <a:endParaRPr lang="en-US"/>
           </a:p>
@@ -1350,7 +1365,7 @@
           <a:p>
             <a:fld id="{5BCAD085-E8A6-8845-BD4E-CB4CCA059FC4}" type="datetimeFigureOut">
               <a:rPr lang="en-US" smtClean="0"/>
-              <a:t>1/27/13</a:t>
+              <a:t>5/16/2026</a:t>
             </a:fld>
             <a:endParaRPr lang="en-US"/>
           </a:p>
@@ -1772,7 +1787,7 @@
           <a:p>
             <a:fld id="{5BCAD085-E8A6-8845-BD4E-CB4CCA059FC4}" type="datetimeFigureOut">
               <a:rPr lang="en-US" smtClean="0"/>
-              <a:t>1/27/13</a:t>
+              <a:t>5/16/2026</a:t>
             </a:fld>
             <a:endParaRPr lang="en-US"/>
           </a:p>
@@ -1890,7 +1905,7 @@
           <a:p>
             <a:fld id="{5BCAD085-E8A6-8845-BD4E-CB4CCA059FC4}" type="datetimeFigureOut">
               <a:rPr lang="en-US" smtClean="0"/>
-              <a:t>1/27/13</a:t>
+              <a:t>5/16/2026</a:t>
             </a:fld>
             <a:endParaRPr lang="en-US"/>
           </a:p>
@@ -1985,7 +2000,7 @@
           <a:p>
             <a:fld id="{5BCAD085-E8A6-8845-BD4E-CB4CCA059FC4}" type="datetimeFigureOut">
               <a:rPr lang="en-US" smtClean="0"/>
-              <a:t>1/27/13</a:t>
+              <a:t>5/16/2026</a:t>
             </a:fld>
             <a:endParaRPr lang="en-US"/>
           </a:p>
@@ -2262,7 +2277,7 @@
           <a:p>
             <a:fld id="{5BCAD085-E8A6-8845-BD4E-CB4CCA059FC4}" type="datetimeFigureOut">
               <a:rPr lang="en-US" smtClean="0"/>
-              <a:t>1/27/13</a:t>
+              <a:t>5/16/2026</a:t>
             </a:fld>
             <a:endParaRPr lang="en-US"/>
           </a:p>
@@ -2515,7 +2530,7 @@
           <a:p>
             <a:fld id="{5BCAD085-E8A6-8845-BD4E-CB4CCA059FC4}" type="datetimeFigureOut">
               <a:rPr lang="en-US" smtClean="0"/>
-              <a:t>1/27/13</a:t>
+              <a:t>5/16/2026</a:t>
             </a:fld>
             <a:endParaRPr lang="en-US"/>
           </a:p>
@@ -2728,7 +2743,7 @@
           <a:p>
             <a:fld id="{5BCAD085-E8A6-8845-BD4E-CB4CCA059FC4}" type="datetimeFigureOut">
               <a:rPr lang="en-US" smtClean="0"/>
-              <a:t>1/27/13</a:t>
+              <a:t>5/16/2026</a:t>
             </a:fld>
             <a:endParaRPr lang="en-US"/>
           </a:p>
@@ -3087,7 +3102,7 @@
 </file>
 
 <file path=ppt/slides/slide1.xml><?xml version="1.0" encoding="utf-8"?>
-<p:sld xmlns:a="http://schemas.openxmlformats.org/drawingml/2006/main" xmlns:p="http://schemas.openxmlformats.org/presentationml/2006/main" xmlns:r="http://schemas.openxmlformats.org/officeDocument/2006/relationships">
+<p:sld xmlns:a="http://schemas.openxmlformats.org/drawingml/2006/main" xmlns:r="http://schemas.openxmlformats.org/officeDocument/2006/relationships" xmlns:p="http://schemas.openxmlformats.org/presentationml/2006/main">
   <p:cSld>
     <p:bg>
       <p:bgPr>
@@ -3103,7 +3118,14 @@
         <p:cNvGrpSpPr/>
         <p:nvPr/>
       </p:nvGrpSpPr>
-      <p:grpSpPr/>
+      <p:grpSpPr>
+        <a:xfrm>
+          <a:off x="0" y="0"/>
+          <a:ext cx="0" cy="0"/>
+          <a:chOff x="0" y="0"/>
+          <a:chExt cx="0" cy="0"/>
+        </a:xfrm>
+      </p:grpSpPr>
       <p:sp>
         <p:nvSpPr>
           <p:cNvPr id="2" name="Rectangle 1"/>
@@ -3144,6 +3166,7 @@
           <a:lstStyle/>
           <a:p>
             <a:pPr algn="ctr"/>
+            <a:endParaRPr/>
           </a:p>
         </p:txBody>
       </p:sp>
@@ -3187,6 +3210,7 @@
           <a:lstStyle/>
           <a:p>
             <a:pPr algn="ctr"/>
+            <a:endParaRPr/>
           </a:p>
         </p:txBody>
       </p:sp>
@@ -3267,7 +3291,7 @@
         <p:spPr>
           <a:xfrm>
             <a:off x="640080" y="3566160"/>
-            <a:ext cx="10515600" cy="457200"/>
+            <a:ext cx="10515600" cy="307777"/>
           </a:xfrm>
           <a:prstGeom prst="rect">
             <a:avLst/>
@@ -3282,13 +3306,26 @@
           <a:p>
             <a:pPr algn="l"/>
             <a:r>
-              <a:rPr sz="1400" b="0" i="0">
+              <a:rPr sz="1400" b="0" i="0" dirty="0">
                 <a:solidFill>
                   <a:srgbClr val="CCD6E0"/>
                 </a:solidFill>
               </a:rPr>
-              <a:t>AI-powered photo review  ·  Full audit trail  ·  GDPR-compliant  ·  Zero data retained</a:t>
-            </a:r>
+              <a:t>AI-powered photo review  ·  Full audit trail  ·  </a:t>
+            </a:r>
+            <a:r>
+              <a:rPr sz="1400" b="0" i="0" dirty="0" smtClean="0">
+                <a:solidFill>
+                  <a:srgbClr val="CCD6E0"/>
+                </a:solidFill>
+              </a:rPr>
+              <a:t>GDPR-compliant</a:t>
+            </a:r>
+            <a:endParaRPr sz="1400" b="0" i="0" dirty="0">
+              <a:solidFill>
+                <a:srgbClr val="CCD6E0"/>
+              </a:solidFill>
+            </a:endParaRPr>
           </a:p>
         </p:txBody>
       </p:sp>
@@ -3301,7 +3338,7 @@
         <p:spPr>
           <a:xfrm>
             <a:off x="640080" y="5852160"/>
-            <a:ext cx="7315200" cy="457200"/>
+            <a:ext cx="7315200" cy="292388"/>
           </a:xfrm>
           <a:prstGeom prst="rect">
             <a:avLst/>
@@ -3314,15 +3351,155 @@
           </a:bodyPr>
           <a:lstStyle/>
           <a:p>
-            <a:pPr algn="l"/>
-            <a:r>
-              <a:rPr sz="1300" b="0" i="0">
+            <a:r>
+              <a:rPr sz="1300" b="0" i="0" dirty="0">
                 <a:solidFill>
                   <a:srgbClr val="CCD6E0"/>
                 </a:solidFill>
               </a:rPr>
-              <a:t>Team: [Name 1]  ·  [Name 2]  ·  [Name 3]</a:t>
-            </a:r>
+              <a:t>Team: </a:t>
+            </a:r>
+            <a:r>
+              <a:rPr lang="en-US" sz="1300" dirty="0">
+                <a:solidFill>
+                  <a:srgbClr val="CCD6E0"/>
+                </a:solidFill>
+              </a:rPr>
+              <a:t>42 </a:t>
+            </a:r>
+            <a:r>
+              <a:rPr lang="en-US" sz="1300" dirty="0" err="1">
+                <a:solidFill>
+                  <a:srgbClr val="CCD6E0"/>
+                </a:solidFill>
+              </a:rPr>
+              <a:t>Claudettes</a:t>
+            </a:r>
+            <a:r>
+              <a:rPr lang="en-US" sz="1300" dirty="0">
+                <a:solidFill>
+                  <a:srgbClr val="CCD6E0"/>
+                </a:solidFill>
+              </a:rPr>
+              <a:t> </a:t>
+            </a:r>
+            <a:r>
+              <a:rPr lang="en-US" sz="1300" dirty="0" smtClean="0">
+                <a:solidFill>
+                  <a:srgbClr val="CCD6E0"/>
+                </a:solidFill>
+              </a:rPr>
+              <a:t>: </a:t>
+            </a:r>
+            <a:r>
+              <a:rPr sz="1300" b="0" i="0" dirty="0" smtClean="0">
+                <a:solidFill>
+                  <a:srgbClr val="CCD6E0"/>
+                </a:solidFill>
+              </a:rPr>
+              <a:t>[</a:t>
+            </a:r>
+            <a:r>
+              <a:rPr lang="en-US" sz="1300" b="0" i="0" dirty="0" smtClean="0">
+                <a:solidFill>
+                  <a:srgbClr val="CCD6E0"/>
+                </a:solidFill>
+              </a:rPr>
+              <a:t>Ahmad</a:t>
+            </a:r>
+            <a:r>
+              <a:rPr sz="1300" b="0" i="0" dirty="0" smtClean="0">
+                <a:solidFill>
+                  <a:srgbClr val="CCD6E0"/>
+                </a:solidFill>
+              </a:rPr>
+              <a:t>]  </a:t>
+            </a:r>
+            <a:r>
+              <a:rPr sz="1300" b="0" i="0" dirty="0">
+                <a:solidFill>
+                  <a:srgbClr val="CCD6E0"/>
+                </a:solidFill>
+              </a:rPr>
+              <a:t>·  </a:t>
+            </a:r>
+            <a:r>
+              <a:rPr sz="1300" b="0" i="0" dirty="0" smtClean="0">
+                <a:solidFill>
+                  <a:srgbClr val="CCD6E0"/>
+                </a:solidFill>
+              </a:rPr>
+              <a:t>[</a:t>
+            </a:r>
+            <a:r>
+              <a:rPr lang="en-US" sz="1300" b="0" i="0" dirty="0" err="1" smtClean="0">
+                <a:solidFill>
+                  <a:srgbClr val="CCD6E0"/>
+                </a:solidFill>
+              </a:rPr>
+              <a:t>Tino</a:t>
+            </a:r>
+            <a:r>
+              <a:rPr sz="1300" b="0" i="0" dirty="0" smtClean="0">
+                <a:solidFill>
+                  <a:srgbClr val="CCD6E0"/>
+                </a:solidFill>
+              </a:rPr>
+              <a:t>]  </a:t>
+            </a:r>
+            <a:r>
+              <a:rPr sz="1300" b="0" i="0" dirty="0">
+                <a:solidFill>
+                  <a:srgbClr val="CCD6E0"/>
+                </a:solidFill>
+              </a:rPr>
+              <a:t>·  </a:t>
+            </a:r>
+            <a:r>
+              <a:rPr sz="1300" b="0" i="0" dirty="0" smtClean="0">
+                <a:solidFill>
+                  <a:srgbClr val="CCD6E0"/>
+                </a:solidFill>
+              </a:rPr>
+              <a:t>[</a:t>
+            </a:r>
+            <a:r>
+              <a:rPr lang="en-US" sz="1300" dirty="0">
+                <a:solidFill>
+                  <a:srgbClr val="CCD6E0"/>
+                </a:solidFill>
+              </a:rPr>
+              <a:t>Evgenii]  ·  </a:t>
+            </a:r>
+            <a:r>
+              <a:rPr lang="en-US" sz="1300" dirty="0" smtClean="0">
+                <a:solidFill>
+                  <a:srgbClr val="CCD6E0"/>
+                </a:solidFill>
+              </a:rPr>
+              <a:t>[</a:t>
+            </a:r>
+            <a:r>
+              <a:rPr lang="en-US" sz="1300" dirty="0" err="1" smtClean="0">
+                <a:solidFill>
+                  <a:srgbClr val="CCD6E0"/>
+                </a:solidFill>
+              </a:rPr>
+              <a:t>Himani</a:t>
+            </a:r>
+            <a:r>
+              <a:rPr lang="en-US" sz="1300" dirty="0" smtClean="0">
+                <a:solidFill>
+                  <a:srgbClr val="CCD6E0"/>
+                </a:solidFill>
+              </a:rPr>
+              <a:t>]</a:t>
+            </a:r>
+            <a:endParaRPr lang="en-US" sz="1300" dirty="0">
+              <a:solidFill>
+                <a:srgbClr val="CCD6E0"/>
+              </a:solidFill>
+            </a:endParaRPr>
           </a:p>
         </p:txBody>
       </p:sp>
@@ -3369,7 +3546,7 @@
 </file>
 
 <file path=ppt/slides/slide2.xml><?xml version="1.0" encoding="utf-8"?>
-<p:sld xmlns:a="http://schemas.openxmlformats.org/drawingml/2006/main" xmlns:p="http://schemas.openxmlformats.org/presentationml/2006/main" xmlns:r="http://schemas.openxmlformats.org/officeDocument/2006/relationships">
+<p:sld xmlns:a="http://schemas.openxmlformats.org/drawingml/2006/main" xmlns:r="http://schemas.openxmlformats.org/officeDocument/2006/relationships" xmlns:p="http://schemas.openxmlformats.org/presentationml/2006/main">
   <p:cSld>
     <p:bg>
       <p:bgPr>
@@ -3385,7 +3562,14 @@
         <p:cNvGrpSpPr/>
         <p:nvPr/>
       </p:nvGrpSpPr>
-      <p:grpSpPr/>
+      <p:grpSpPr>
+        <a:xfrm>
+          <a:off x="0" y="0"/>
+          <a:ext cx="0" cy="0"/>
+          <a:chOff x="0" y="0"/>
+          <a:chExt cx="0" cy="0"/>
+        </a:xfrm>
+      </p:grpSpPr>
       <p:sp>
         <p:nvSpPr>
           <p:cNvPr id="2" name="Rectangle 1"/>
@@ -3426,6 +3610,7 @@
           <a:lstStyle/>
           <a:p>
             <a:pPr algn="ctr"/>
+            <a:endParaRPr/>
           </a:p>
         </p:txBody>
       </p:sp>
@@ -3537,6 +3722,7 @@
           <a:lstStyle/>
           <a:p>
             <a:pPr algn="ctr"/>
+            <a:endParaRPr/>
           </a:p>
         </p:txBody>
       </p:sp>
@@ -3650,6 +3836,7 @@
           <a:lstStyle/>
           <a:p>
             <a:pPr algn="ctr"/>
+            <a:endParaRPr/>
           </a:p>
         </p:txBody>
       </p:sp>
@@ -3763,6 +3950,7 @@
           <a:lstStyle/>
           <a:p>
             <a:pPr algn="ctr"/>
+            <a:endParaRPr/>
           </a:p>
         </p:txBody>
       </p:sp>
@@ -3810,7 +3998,7 @@
         <p:spPr>
           <a:xfrm>
             <a:off x="8321040" y="2423160"/>
-            <a:ext cx="3200400" cy="3657600"/>
+            <a:ext cx="3200400" cy="3170099"/>
           </a:xfrm>
           <a:prstGeom prst="rect">
             <a:avLst/>
@@ -3825,14 +4013,249 @@
           <a:p>
             <a:pPr algn="l"/>
             <a:r>
-              <a:rPr sz="2000" b="0" i="0">
+              <a:rPr lang="en-US" sz="2000" dirty="0">
                 <a:solidFill>
                   <a:srgbClr val="CCD6E0"/>
                 </a:solidFill>
               </a:rPr>
-              <a:t>3–5 days per section × 9 sections × 100× backlog = thousands of person-days of review.
-Result: Review gets skipped. Problems surface years later via excavator damage.</a:t>
-            </a:r>
+              <a:t>1</a:t>
+            </a:r>
+            <a:r>
+              <a:rPr sz="2000" b="0" i="0" dirty="0" smtClean="0">
+                <a:solidFill>
+                  <a:srgbClr val="CCD6E0"/>
+                </a:solidFill>
+              </a:rPr>
+              <a:t>–</a:t>
+            </a:r>
+            <a:r>
+              <a:rPr lang="en-US" sz="2000" b="0" i="0" dirty="0" smtClean="0">
+                <a:solidFill>
+                  <a:srgbClr val="CCD6E0"/>
+                </a:solidFill>
+              </a:rPr>
+              <a:t>2</a:t>
+            </a:r>
+            <a:r>
+              <a:rPr sz="2000" b="0" i="0" dirty="0" smtClean="0">
+                <a:solidFill>
+                  <a:srgbClr val="CCD6E0"/>
+                </a:solidFill>
+              </a:rPr>
+              <a:t> </a:t>
+            </a:r>
+            <a:r>
+              <a:rPr lang="en-US" sz="2000" b="0" i="0" dirty="0" smtClean="0">
+                <a:solidFill>
+                  <a:srgbClr val="CCD6E0"/>
+                </a:solidFill>
+              </a:rPr>
+              <a:t>minutes</a:t>
+            </a:r>
+            <a:r>
+              <a:rPr sz="2000" b="0" i="0" dirty="0" smtClean="0">
+                <a:solidFill>
+                  <a:srgbClr val="CCD6E0"/>
+                </a:solidFill>
+              </a:rPr>
+              <a:t> </a:t>
+            </a:r>
+            <a:r>
+              <a:rPr sz="2000" b="0" i="0" dirty="0">
+                <a:solidFill>
+                  <a:srgbClr val="CCD6E0"/>
+                </a:solidFill>
+              </a:rPr>
+              <a:t>per </a:t>
+            </a:r>
+            <a:r>
+              <a:rPr lang="en-US" sz="2000" b="0" i="0" dirty="0" smtClean="0">
+                <a:solidFill>
+                  <a:srgbClr val="CCD6E0"/>
+                </a:solidFill>
+              </a:rPr>
+              <a:t>image</a:t>
+            </a:r>
+            <a:br>
+              <a:rPr lang="en-US" sz="2000" b="0" i="0" dirty="0" smtClean="0">
+                <a:solidFill>
+                  <a:srgbClr val="CCD6E0"/>
+                </a:solidFill>
+              </a:rPr>
+            </a:br>
+            <a:r>
+              <a:rPr sz="2000" b="0" i="0" dirty="0" smtClean="0">
+                <a:solidFill>
+                  <a:srgbClr val="CCD6E0"/>
+                </a:solidFill>
+              </a:rPr>
+              <a:t>× </a:t>
+            </a:r>
+            <a:r>
+              <a:rPr lang="en-US" sz="2000" dirty="0">
+                <a:solidFill>
+                  <a:srgbClr val="CCD6E0"/>
+                </a:solidFill>
+              </a:rPr>
+              <a:t>6</a:t>
+            </a:r>
+            <a:r>
+              <a:rPr lang="en-US" sz="2000" b="0" i="0" dirty="0" smtClean="0">
+                <a:solidFill>
+                  <a:srgbClr val="CCD6E0"/>
+                </a:solidFill>
+              </a:rPr>
+              <a:t>0</a:t>
+            </a:r>
+            <a:r>
+              <a:rPr sz="2000" b="0" i="0" dirty="0" smtClean="0">
+                <a:solidFill>
+                  <a:srgbClr val="CCD6E0"/>
+                </a:solidFill>
+              </a:rPr>
+              <a:t> </a:t>
+            </a:r>
+            <a:r>
+              <a:rPr lang="en-US" sz="2000" b="0" i="0" dirty="0" smtClean="0">
+                <a:solidFill>
+                  <a:srgbClr val="CCD6E0"/>
+                </a:solidFill>
+              </a:rPr>
+              <a:t>images per section</a:t>
+            </a:r>
+            <a:br>
+              <a:rPr lang="en-US" sz="2000" b="0" i="0" dirty="0" smtClean="0">
+                <a:solidFill>
+                  <a:srgbClr val="CCD6E0"/>
+                </a:solidFill>
+              </a:rPr>
+            </a:br>
+            <a:r>
+              <a:rPr sz="2000" b="0" i="0" dirty="0" smtClean="0">
+                <a:solidFill>
+                  <a:srgbClr val="CCD6E0"/>
+                </a:solidFill>
+              </a:rPr>
+              <a:t>× 10</a:t>
+            </a:r>
+            <a:r>
+              <a:rPr lang="en-US" sz="2000" b="0" i="0" dirty="0" smtClean="0">
+                <a:solidFill>
+                  <a:srgbClr val="CCD6E0"/>
+                </a:solidFill>
+              </a:rPr>
+              <a:t> sections per project</a:t>
+            </a:r>
+            <a:r>
+              <a:rPr sz="2000" b="0" i="0" dirty="0" smtClean="0">
+                <a:solidFill>
+                  <a:srgbClr val="CCD6E0"/>
+                </a:solidFill>
+              </a:rPr>
+              <a:t> </a:t>
+            </a:r>
+            <a:r>
+              <a:rPr sz="2000" b="0" i="0" dirty="0">
+                <a:solidFill>
+                  <a:srgbClr val="CCD6E0"/>
+                </a:solidFill>
+              </a:rPr>
+              <a:t>= thousands of person-days of </a:t>
+            </a:r>
+            <a:r>
+              <a:rPr sz="2000" b="0" i="0" dirty="0" smtClean="0">
+                <a:solidFill>
+                  <a:srgbClr val="CCD6E0"/>
+                </a:solidFill>
+              </a:rPr>
+              <a:t>revie</a:t>
+            </a:r>
+            <a:r>
+              <a:rPr lang="en-US" sz="2000" b="0" i="0" dirty="0" smtClean="0">
+                <a:solidFill>
+                  <a:srgbClr val="CCD6E0"/>
+                </a:solidFill>
+              </a:rPr>
+              <a:t>w</a:t>
+            </a:r>
+            <a:r>
+              <a:rPr sz="2000" b="0" i="0" dirty="0">
+                <a:solidFill>
+                  <a:srgbClr val="CCD6E0"/>
+                </a:solidFill>
+              </a:rPr>
+              <a:t>
+Result: </a:t>
+            </a:r>
+            <a:r>
+              <a:rPr lang="en-US" sz="2000" dirty="0" smtClean="0">
+                <a:solidFill>
+                  <a:srgbClr val="CCD6E0"/>
+                </a:solidFill>
+              </a:rPr>
+              <a:t>“expensive” or low-quality r</a:t>
+            </a:r>
+            <a:r>
+              <a:rPr sz="2000" b="0" i="0" dirty="0" smtClean="0">
+                <a:solidFill>
+                  <a:srgbClr val="CCD6E0"/>
+                </a:solidFill>
+              </a:rPr>
+              <a:t>eview</a:t>
+            </a:r>
+            <a:r>
+              <a:rPr lang="en-US" sz="2000" b="0" i="0" dirty="0" smtClean="0">
+                <a:solidFill>
+                  <a:srgbClr val="CCD6E0"/>
+                </a:solidFill>
+              </a:rPr>
+              <a:t> (p</a:t>
+            </a:r>
+            <a:r>
+              <a:rPr sz="2000" b="0" i="0" dirty="0" smtClean="0">
+                <a:solidFill>
+                  <a:srgbClr val="CCD6E0"/>
+                </a:solidFill>
+              </a:rPr>
+              <a:t>roblems </a:t>
+            </a:r>
+            <a:r>
+              <a:rPr sz="2000" b="0" i="0" dirty="0">
+                <a:solidFill>
+                  <a:srgbClr val="CCD6E0"/>
+                </a:solidFill>
+              </a:rPr>
+              <a:t>surface years later via excavator </a:t>
+            </a:r>
+            <a:r>
+              <a:rPr sz="2000" b="0" i="0" dirty="0" smtClean="0">
+                <a:solidFill>
+                  <a:srgbClr val="CCD6E0"/>
+                </a:solidFill>
+              </a:rPr>
+              <a:t>damage</a:t>
+            </a:r>
+            <a:r>
+              <a:rPr lang="en-US" sz="2000" b="0" i="0" dirty="0" smtClean="0">
+                <a:solidFill>
+                  <a:srgbClr val="CCD6E0"/>
+                </a:solidFill>
+              </a:rPr>
+              <a:t>)</a:t>
+            </a:r>
+            <a:r>
+              <a:rPr sz="2000" b="0" i="0" dirty="0" smtClean="0">
+                <a:solidFill>
+                  <a:srgbClr val="CCD6E0"/>
+                </a:solidFill>
+              </a:rPr>
+              <a:t>.</a:t>
+            </a:r>
+            <a:endParaRPr sz="2000" b="0" i="0" dirty="0">
+              <a:solidFill>
+                <a:srgbClr val="CCD6E0"/>
+              </a:solidFill>
+            </a:endParaRPr>
           </a:p>
         </p:txBody>
       </p:sp>
@@ -3845,7 +4268,7 @@
 </file>
 
 <file path=ppt/slides/slide3.xml><?xml version="1.0" encoding="utf-8"?>
-<p:sld xmlns:a="http://schemas.openxmlformats.org/drawingml/2006/main" xmlns:p="http://schemas.openxmlformats.org/presentationml/2006/main" xmlns:r="http://schemas.openxmlformats.org/officeDocument/2006/relationships">
+<p:sld xmlns:a="http://schemas.openxmlformats.org/drawingml/2006/main" xmlns:r="http://schemas.openxmlformats.org/officeDocument/2006/relationships" xmlns:p="http://schemas.openxmlformats.org/presentationml/2006/main">
   <p:cSld>
     <p:bg>
       <p:bgPr>
@@ -3861,7 +4284,14 @@
         <p:cNvGrpSpPr/>
         <p:nvPr/>
       </p:nvGrpSpPr>
-      <p:grpSpPr/>
+      <p:grpSpPr>
+        <a:xfrm>
+          <a:off x="0" y="0"/>
+          <a:ext cx="0" cy="0"/>
+          <a:chOff x="0" y="0"/>
+          <a:chExt cx="0" cy="0"/>
+        </a:xfrm>
+      </p:grpSpPr>
       <p:sp>
         <p:nvSpPr>
           <p:cNvPr id="2" name="Rectangle 1"/>
@@ -3902,6 +4332,7 @@
           <a:lstStyle/>
           <a:p>
             <a:pPr algn="ctr"/>
+            <a:endParaRPr/>
           </a:p>
         </p:txBody>
       </p:sp>
@@ -4013,6 +4444,7 @@
           <a:lstStyle/>
           <a:p>
             <a:pPr algn="ctr"/>
+            <a:endParaRPr/>
           </a:p>
         </p:txBody>
       </p:sp>
@@ -4125,6 +4557,7 @@
           <a:lstStyle/>
           <a:p>
             <a:pPr algn="ctr"/>
+            <a:endParaRPr/>
           </a:p>
         </p:txBody>
       </p:sp>
@@ -4237,6 +4670,7 @@
           <a:lstStyle/>
           <a:p>
             <a:pPr algn="ctr"/>
+            <a:endParaRPr/>
           </a:p>
         </p:txBody>
       </p:sp>
@@ -4349,6 +4783,7 @@
           <a:lstStyle/>
           <a:p>
             <a:pPr algn="ctr"/>
+            <a:endParaRPr/>
           </a:p>
         </p:txBody>
       </p:sp>
@@ -4499,7 +4934,7 @@
 </file>
 
 <file path=ppt/slides/slide4.xml><?xml version="1.0" encoding="utf-8"?>
-<p:sld xmlns:a="http://schemas.openxmlformats.org/drawingml/2006/main" xmlns:p="http://schemas.openxmlformats.org/presentationml/2006/main" xmlns:r="http://schemas.openxmlformats.org/officeDocument/2006/relationships">
+<p:sld xmlns:a="http://schemas.openxmlformats.org/drawingml/2006/main" xmlns:r="http://schemas.openxmlformats.org/officeDocument/2006/relationships" xmlns:p="http://schemas.openxmlformats.org/presentationml/2006/main">
   <p:cSld>
     <p:bg>
       <p:bgPr>
@@ -4515,7 +4950,14 @@
         <p:cNvGrpSpPr/>
         <p:nvPr/>
       </p:nvGrpSpPr>
-      <p:grpSpPr/>
+      <p:grpSpPr>
+        <a:xfrm>
+          <a:off x="0" y="0"/>
+          <a:ext cx="0" cy="0"/>
+          <a:chOff x="0" y="0"/>
+          <a:chExt cx="0" cy="0"/>
+        </a:xfrm>
+      </p:grpSpPr>
       <p:sp>
         <p:nvSpPr>
           <p:cNvPr id="2" name="Rectangle 1"/>
@@ -4556,6 +4998,7 @@
           <a:lstStyle/>
           <a:p>
             <a:pPr algn="ctr"/>
+            <a:endParaRPr/>
           </a:p>
         </p:txBody>
       </p:sp>
@@ -4667,6 +5110,7 @@
           <a:lstStyle/>
           <a:p>
             <a:pPr algn="ctr"/>
+            <a:endParaRPr/>
           </a:p>
         </p:txBody>
       </p:sp>
@@ -4710,6 +5154,7 @@
           <a:lstStyle/>
           <a:p>
             <a:pPr algn="ctr"/>
+            <a:endParaRPr/>
           </a:p>
         </p:txBody>
       </p:sp>
@@ -4823,6 +5268,7 @@
           <a:lstStyle/>
           <a:p>
             <a:pPr algn="ctr"/>
+            <a:endParaRPr/>
           </a:p>
         </p:txBody>
       </p:sp>
@@ -4866,6 +5312,7 @@
           <a:lstStyle/>
           <a:p>
             <a:pPr algn="ctr"/>
+            <a:endParaRPr/>
           </a:p>
         </p:txBody>
       </p:sp>
@@ -4979,6 +5426,7 @@
           <a:lstStyle/>
           <a:p>
             <a:pPr algn="ctr"/>
+            <a:endParaRPr/>
           </a:p>
         </p:txBody>
       </p:sp>
@@ -5022,6 +5470,7 @@
           <a:lstStyle/>
           <a:p>
             <a:pPr algn="ctr"/>
+            <a:endParaRPr/>
           </a:p>
         </p:txBody>
       </p:sp>
@@ -5135,6 +5584,7 @@
           <a:lstStyle/>
           <a:p>
             <a:pPr algn="ctr"/>
+            <a:endParaRPr/>
           </a:p>
         </p:txBody>
       </p:sp>
@@ -5178,6 +5628,7 @@
           <a:lstStyle/>
           <a:p>
             <a:pPr algn="ctr"/>
+            <a:endParaRPr/>
           </a:p>
         </p:txBody>
       </p:sp>
@@ -5240,7 +5691,7 @@
           <a:p>
             <a:pPr algn="ctr"/>
             <a:r>
-              <a:rPr sz="2000" b="0" i="0">
+              <a:rPr sz="2000" b="0" i="0" dirty="0">
                 <a:solidFill>
                   <a:srgbClr val="CCD6E0"/>
                 </a:solidFill>
@@ -5260,7 +5711,7 @@
 </file>
 
 <file path=ppt/slides/slide5.xml><?xml version="1.0" encoding="utf-8"?>
-<p:sld xmlns:a="http://schemas.openxmlformats.org/drawingml/2006/main" xmlns:p="http://schemas.openxmlformats.org/presentationml/2006/main" xmlns:r="http://schemas.openxmlformats.org/officeDocument/2006/relationships">
+<p:sld xmlns:a="http://schemas.openxmlformats.org/drawingml/2006/main" xmlns:r="http://schemas.openxmlformats.org/officeDocument/2006/relationships" xmlns:p="http://schemas.openxmlformats.org/presentationml/2006/main">
   <p:cSld>
     <p:bg>
       <p:bgPr>
@@ -5276,7 +5727,14 @@
         <p:cNvGrpSpPr/>
         <p:nvPr/>
       </p:nvGrpSpPr>
-      <p:grpSpPr/>
+      <p:grpSpPr>
+        <a:xfrm>
+          <a:off x="0" y="0"/>
+          <a:ext cx="0" cy="0"/>
+          <a:chOff x="0" y="0"/>
+          <a:chExt cx="0" cy="0"/>
+        </a:xfrm>
+      </p:grpSpPr>
       <p:sp>
         <p:nvSpPr>
           <p:cNvPr id="2" name="Rectangle 1"/>
@@ -5317,6 +5775,7 @@
           <a:lstStyle/>
           <a:p>
             <a:pPr algn="ctr"/>
+            <a:endParaRPr/>
           </a:p>
         </p:txBody>
       </p:sp>
@@ -5428,6 +5887,7 @@
           <a:lstStyle/>
           <a:p>
             <a:pPr algn="ctr"/>
+            <a:endParaRPr/>
           </a:p>
         </p:txBody>
       </p:sp>
@@ -5471,6 +5931,7 @@
           <a:lstStyle/>
           <a:p>
             <a:pPr algn="ctr"/>
+            <a:endParaRPr/>
           </a:p>
         </p:txBody>
       </p:sp>
@@ -5652,6 +6113,7 @@
           <a:lstStyle/>
           <a:p>
             <a:pPr algn="ctr"/>
+            <a:endParaRPr/>
           </a:p>
         </p:txBody>
       </p:sp>
@@ -5695,6 +6157,7 @@
           <a:lstStyle/>
           <a:p>
             <a:pPr algn="ctr"/>
+            <a:endParaRPr/>
           </a:p>
         </p:txBody>
       </p:sp>
@@ -5876,6 +6339,7 @@
           <a:lstStyle/>
           <a:p>
             <a:pPr algn="ctr"/>
+            <a:endParaRPr/>
           </a:p>
         </p:txBody>
       </p:sp>
@@ -5919,6 +6383,7 @@
           <a:lstStyle/>
           <a:p>
             <a:pPr algn="ctr"/>
+            <a:endParaRPr/>
           </a:p>
         </p:txBody>
       </p:sp>
@@ -6100,6 +6565,7 @@
           <a:lstStyle/>
           <a:p>
             <a:pPr algn="ctr"/>
+            <a:endParaRPr/>
           </a:p>
         </p:txBody>
       </p:sp>
@@ -6143,6 +6609,7 @@
           <a:lstStyle/>
           <a:p>
             <a:pPr algn="ctr"/>
+            <a:endParaRPr/>
           </a:p>
         </p:txBody>
       </p:sp>
@@ -6324,6 +6791,7 @@
           <a:lstStyle/>
           <a:p>
             <a:pPr algn="ctr"/>
+            <a:endParaRPr/>
           </a:p>
         </p:txBody>
       </p:sp>
@@ -6367,6 +6835,7 @@
           <a:lstStyle/>
           <a:p>
             <a:pPr algn="ctr"/>
+            <a:endParaRPr/>
           </a:p>
         </p:txBody>
       </p:sp>
@@ -6548,6 +7017,7 @@
           <a:lstStyle/>
           <a:p>
             <a:pPr algn="ctr"/>
+            <a:endParaRPr/>
           </a:p>
         </p:txBody>
       </p:sp>
@@ -6591,6 +7061,7 @@
           <a:lstStyle/>
           <a:p>
             <a:pPr algn="ctr"/>
+            <a:endParaRPr/>
           </a:p>
         </p:txBody>
       </p:sp>
@@ -6772,6 +7243,7 @@
           <a:lstStyle/>
           <a:p>
             <a:pPr algn="ctr"/>
+            <a:endParaRPr/>
           </a:p>
         </p:txBody>
       </p:sp>
@@ -6818,7 +7290,7 @@
 </file>
 
 <file path=ppt/slides/slide6.xml><?xml version="1.0" encoding="utf-8"?>
-<p:sld xmlns:a="http://schemas.openxmlformats.org/drawingml/2006/main" xmlns:p="http://schemas.openxmlformats.org/presentationml/2006/main" xmlns:r="http://schemas.openxmlformats.org/officeDocument/2006/relationships">
+<p:sld xmlns:a="http://schemas.openxmlformats.org/drawingml/2006/main" xmlns:r="http://schemas.openxmlformats.org/officeDocument/2006/relationships" xmlns:p="http://schemas.openxmlformats.org/presentationml/2006/main">
   <p:cSld>
     <p:bg>
       <p:bgPr>
@@ -6834,7 +7306,14 @@
         <p:cNvGrpSpPr/>
         <p:nvPr/>
       </p:nvGrpSpPr>
-      <p:grpSpPr/>
+      <p:grpSpPr>
+        <a:xfrm>
+          <a:off x="0" y="0"/>
+          <a:ext cx="0" cy="0"/>
+          <a:chOff x="0" y="0"/>
+          <a:chExt cx="0" cy="0"/>
+        </a:xfrm>
+      </p:grpSpPr>
       <p:sp>
         <p:nvSpPr>
           <p:cNvPr id="2" name="Rectangle 1"/>
@@ -6875,6 +7354,7 @@
           <a:lstStyle/>
           <a:p>
             <a:pPr algn="ctr"/>
+            <a:endParaRPr/>
           </a:p>
         </p:txBody>
       </p:sp>
@@ -6986,6 +7466,7 @@
           <a:lstStyle/>
           <a:p>
             <a:pPr algn="ctr"/>
+            <a:endParaRPr/>
           </a:p>
         </p:txBody>
       </p:sp>
@@ -7029,6 +7510,7 @@
           <a:lstStyle/>
           <a:p>
             <a:pPr algn="ctr"/>
+            <a:endParaRPr/>
           </a:p>
         </p:txBody>
       </p:sp>
@@ -7075,8 +7557,8 @@
         </p:nvSpPr>
         <p:spPr>
           <a:xfrm>
-            <a:off x="548640" y="2240280"/>
-            <a:ext cx="4937760" cy="1280160"/>
+            <a:off x="548640" y="2140131"/>
+            <a:ext cx="4937760" cy="1200329"/>
           </a:xfrm>
           <a:prstGeom prst="rect">
             <a:avLst/>
@@ -7091,12 +7573,12 @@
           <a:p>
             <a:pPr algn="l"/>
             <a:r>
-              <a:rPr sz="1800" b="0" i="0">
+              <a:rPr sz="1800" b="0" i="0" dirty="0">
                 <a:solidFill>
                   <a:srgbClr val="CCD6E0"/>
                 </a:solidFill>
               </a:rPr>
-              <a:t>Faces and license plates detected in every photo before any reviewer sees them. Flagged images are withheld from the display grid and routed to a "needs retake" list. No personal data is ever shown, stored, or transmitted to our infrastructure.</a:t>
+              <a:t>Faces and license plates detected in every photo before any reviewer sees them. Flagged images are withheld from the display grid and routed to a "needs retake" list. </a:t>
             </a:r>
           </a:p>
         </p:txBody>
@@ -7141,6 +7623,7 @@
           <a:lstStyle/>
           <a:p>
             <a:pPr algn="ctr"/>
+            <a:endParaRPr/>
           </a:p>
         </p:txBody>
       </p:sp>
@@ -7184,6 +7667,7 @@
           <a:lstStyle/>
           <a:p>
             <a:pPr algn="ctr"/>
+            <a:endParaRPr/>
           </a:p>
         </p:txBody>
       </p:sp>
@@ -7230,7 +7714,7 @@
         </p:nvSpPr>
         <p:spPr>
           <a:xfrm>
-            <a:off x="6492240" y="2240280"/>
+            <a:off x="6492240" y="2140131"/>
             <a:ext cx="4937760" cy="1280160"/>
           </a:xfrm>
           <a:prstGeom prst="rect">
@@ -7246,7 +7730,7 @@
           <a:p>
             <a:pPr algn="l"/>
             <a:r>
-              <a:rPr sz="1800" b="0" i="0">
+              <a:rPr sz="1800" b="0" i="0" dirty="0">
                 <a:solidFill>
                   <a:srgbClr val="CCD6E0"/>
                 </a:solidFill>
@@ -7296,6 +7780,7 @@
           <a:lstStyle/>
           <a:p>
             <a:pPr algn="ctr"/>
+            <a:endParaRPr/>
           </a:p>
         </p:txBody>
       </p:sp>
@@ -7339,6 +7824,7 @@
           <a:lstStyle/>
           <a:p>
             <a:pPr algn="ctr"/>
+            <a:endParaRPr/>
           </a:p>
         </p:txBody>
       </p:sp>
@@ -7451,6 +7937,7 @@
           <a:lstStyle/>
           <a:p>
             <a:pPr algn="ctr"/>
+            <a:endParaRPr/>
           </a:p>
         </p:txBody>
       </p:sp>
@@ -7494,6 +7981,7 @@
           <a:lstStyle/>
           <a:p>
             <a:pPr algn="ctr"/>
+            <a:endParaRPr/>
           </a:p>
         </p:txBody>
       </p:sp>
@@ -7575,7 +8063,7 @@
 </file>
 
 <file path=ppt/slides/slide7.xml><?xml version="1.0" encoding="utf-8"?>
-<p:sld xmlns:a="http://schemas.openxmlformats.org/drawingml/2006/main" xmlns:p="http://schemas.openxmlformats.org/presentationml/2006/main" xmlns:r="http://schemas.openxmlformats.org/officeDocument/2006/relationships">
+<p:sld xmlns:a="http://schemas.openxmlformats.org/drawingml/2006/main" xmlns:r="http://schemas.openxmlformats.org/officeDocument/2006/relationships" xmlns:p="http://schemas.openxmlformats.org/presentationml/2006/main">
   <p:cSld>
     <p:bg>
       <p:bgPr>
@@ -7591,7 +8079,14 @@
         <p:cNvGrpSpPr/>
         <p:nvPr/>
       </p:nvGrpSpPr>
-      <p:grpSpPr/>
+      <p:grpSpPr>
+        <a:xfrm>
+          <a:off x="0" y="0"/>
+          <a:ext cx="0" cy="0"/>
+          <a:chOff x="0" y="0"/>
+          <a:chExt cx="0" cy="0"/>
+        </a:xfrm>
+      </p:grpSpPr>
       <p:sp>
         <p:nvSpPr>
           <p:cNvPr id="2" name="Rectangle 1"/>
@@ -7600,7 +8095,51 @@
         </p:nvSpPr>
         <p:spPr>
           <a:xfrm>
-            <a:off x="0" y="109728"/>
+            <a:off x="0" y="0"/>
+            <a:ext cx="12188952" cy="73152"/>
+          </a:xfrm>
+          <a:prstGeom prst="rect">
+            <a:avLst/>
+          </a:prstGeom>
+          <a:solidFill>
+            <a:srgbClr val="00A8E8"/>
+          </a:solidFill>
+          <a:ln>
+            <a:noFill/>
+          </a:ln>
+        </p:spPr>
+        <p:style>
+          <a:lnRef idx="1">
+            <a:schemeClr val="accent1"/>
+          </a:lnRef>
+          <a:fillRef idx="3">
+            <a:schemeClr val="accent1"/>
+          </a:fillRef>
+          <a:effectRef idx="2">
+            <a:schemeClr val="accent1"/>
+          </a:effectRef>
+          <a:fontRef idx="minor">
+            <a:schemeClr val="lt1"/>
+          </a:fontRef>
+        </p:style>
+        <p:txBody>
+          <a:bodyPr rtlCol="0" anchor="ctr"/>
+          <a:lstStyle/>
+          <a:p>
+            <a:pPr algn="ctr"/>
+            <a:endParaRPr/>
+          </a:p>
+        </p:txBody>
+      </p:sp>
+      <p:sp>
+        <p:nvSpPr>
+          <p:cNvPr id="3" name="Rectangle 2"/>
+          <p:cNvSpPr/>
+          <p:nvPr/>
+        </p:nvSpPr>
+        <p:spPr>
+          <a:xfrm>
+            <a:off x="0" y="6766560"/>
             <a:ext cx="12188952" cy="73152"/>
           </a:xfrm>
           <a:prstGeom prst="rect">
@@ -7632,19 +8171,20 @@
           <a:lstStyle/>
           <a:p>
             <a:pPr algn="ctr"/>
-          </a:p>
-        </p:txBody>
-      </p:sp>
-      <p:sp>
-        <p:nvSpPr>
-          <p:cNvPr id="3" name="TextBox 2"/>
+            <a:endParaRPr/>
+          </a:p>
+        </p:txBody>
+      </p:sp>
+      <p:sp>
+        <p:nvSpPr>
+          <p:cNvPr id="4" name="TextBox 3"/>
           <p:cNvSpPr txBox="1"/>
           <p:nvPr/>
         </p:nvSpPr>
         <p:spPr>
           <a:xfrm>
-            <a:off x="457200" y="228600"/>
-            <a:ext cx="10972800" cy="365760"/>
+            <a:off x="640080" y="548640"/>
+            <a:ext cx="10515600" cy="822960"/>
           </a:xfrm>
           <a:prstGeom prst="rect">
             <a:avLst/>
@@ -7657,48 +8197,15 @@
           </a:bodyPr>
           <a:lstStyle/>
           <a:p>
-            <a:pPr algn="l"/>
-            <a:r>
-              <a:rPr sz="900" b="1" i="0">
-                <a:solidFill>
-                  <a:srgbClr val="00A8E8"/>
-                </a:solidFill>
-              </a:rPr>
-              <a:t>BUSINESS VALUE</a:t>
-            </a:r>
-          </a:p>
-        </p:txBody>
-      </p:sp>
-      <p:sp>
-        <p:nvSpPr>
-          <p:cNvPr id="4" name="TextBox 3"/>
-          <p:cNvSpPr txBox="1"/>
-          <p:nvPr/>
-        </p:nvSpPr>
-        <p:spPr>
-          <a:xfrm>
-            <a:off x="457200" y="502920"/>
-            <a:ext cx="10972800" cy="640080"/>
-          </a:xfrm>
-          <a:prstGeom prst="rect">
-            <a:avLst/>
-          </a:prstGeom>
-          <a:noFill/>
-        </p:spPr>
-        <p:txBody>
-          <a:bodyPr wrap="square">
-            <a:spAutoFit/>
-          </a:bodyPr>
-          <a:lstStyle/>
-          <a:p>
-            <a:pPr algn="l"/>
-            <a:r>
-              <a:rPr sz="2900" b="1" i="0">
+            <a:pPr algn="ctr"/>
+            <a:r>
+              <a:rPr sz="2800" b="1" i="0">
                 <a:solidFill>
                   <a:srgbClr val="FFFFFF"/>
                 </a:solidFill>
               </a:rPr>
-              <a:t>The Numbers Speak for Themselves</a:t>
+              <a:t>Every Unreviewed Meter Is a Liability.
+We Close That Gap — Automatically.</a:t>
             </a:r>
           </a:p>
         </p:txBody>
@@ -7711,8 +8218,8 @@
         </p:nvSpPr>
         <p:spPr>
           <a:xfrm>
-            <a:off x="365760" y="1371600"/>
-            <a:ext cx="11430000" cy="859536"/>
+            <a:off x="868680" y="1600200"/>
+            <a:ext cx="3291840" cy="3840480"/>
           </a:xfrm>
           <a:prstGeom prst="rect">
             <a:avLst/>
@@ -7743,19 +8250,64 @@
           <a:lstStyle/>
           <a:p>
             <a:pPr algn="ctr"/>
-          </a:p>
-        </p:txBody>
-      </p:sp>
-      <p:sp>
-        <p:nvSpPr>
-          <p:cNvPr id="6" name="TextBox 5"/>
+            <a:endParaRPr/>
+          </a:p>
+        </p:txBody>
+      </p:sp>
+      <p:sp>
+        <p:nvSpPr>
+          <p:cNvPr id="6" name="Rectangle 5"/>
+          <p:cNvSpPr/>
+          <p:nvPr/>
+        </p:nvSpPr>
+        <p:spPr>
+          <a:xfrm>
+            <a:off x="868680" y="1600200"/>
+            <a:ext cx="3291840" cy="137160"/>
+          </a:xfrm>
+          <a:prstGeom prst="rect">
+            <a:avLst/>
+          </a:prstGeom>
+          <a:solidFill>
+            <a:srgbClr val="00A8E8"/>
+          </a:solidFill>
+          <a:ln>
+            <a:noFill/>
+          </a:ln>
+        </p:spPr>
+        <p:style>
+          <a:lnRef idx="1">
+            <a:schemeClr val="accent1"/>
+          </a:lnRef>
+          <a:fillRef idx="3">
+            <a:schemeClr val="accent1"/>
+          </a:fillRef>
+          <a:effectRef idx="2">
+            <a:schemeClr val="accent1"/>
+          </a:effectRef>
+          <a:fontRef idx="minor">
+            <a:schemeClr val="lt1"/>
+          </a:fontRef>
+        </p:style>
+        <p:txBody>
+          <a:bodyPr rtlCol="0" anchor="ctr"/>
+          <a:lstStyle/>
+          <a:p>
+            <a:pPr algn="ctr"/>
+            <a:endParaRPr/>
+          </a:p>
+        </p:txBody>
+      </p:sp>
+      <p:sp>
+        <p:nvSpPr>
+          <p:cNvPr id="7" name="TextBox 6"/>
           <p:cNvSpPr txBox="1"/>
           <p:nvPr/>
         </p:nvSpPr>
         <p:spPr>
           <a:xfrm>
-            <a:off x="548640" y="1463040"/>
-            <a:ext cx="1463040" cy="731520"/>
+            <a:off x="868680" y="1828800"/>
+            <a:ext cx="3291840" cy="594360"/>
           </a:xfrm>
           <a:prstGeom prst="rect">
             <a:avLst/>
@@ -7770,26 +8322,26 @@
           <a:p>
             <a:pPr algn="ctr"/>
             <a:r>
-              <a:rPr sz="3400" b="1" i="0">
-                <a:solidFill>
-                  <a:srgbClr val="00D47E"/>
-                </a:solidFill>
-              </a:rPr>
-              <a:t>€2.4M+</a:t>
-            </a:r>
-          </a:p>
-        </p:txBody>
-      </p:sp>
-      <p:sp>
-        <p:nvSpPr>
-          <p:cNvPr id="7" name="TextBox 6"/>
+              <a:rPr sz="3000" b="1" i="0">
+                <a:solidFill>
+                  <a:srgbClr val="00A8E8"/>
+                </a:solidFill>
+              </a:rPr>
+              <a:t>01</a:t>
+            </a:r>
+          </a:p>
+        </p:txBody>
+      </p:sp>
+      <p:sp>
+        <p:nvSpPr>
+          <p:cNvPr id="8" name="TextBox 7"/>
           <p:cNvSpPr txBox="1"/>
           <p:nvPr/>
         </p:nvSpPr>
         <p:spPr>
           <a:xfrm>
-            <a:off x="2194560" y="1417320"/>
-            <a:ext cx="3657600" cy="457200"/>
+            <a:off x="868680" y="2468880"/>
+            <a:ext cx="3291840" cy="594360"/>
           </a:xfrm>
           <a:prstGeom prst="rect">
             <a:avLst/>
@@ -7802,28 +8354,28 @@
           </a:bodyPr>
           <a:lstStyle/>
           <a:p>
-            <a:pPr algn="l"/>
-            <a:r>
-              <a:rPr sz="1600" b="1" i="0">
+            <a:pPr algn="ctr"/>
+            <a:r>
+              <a:rPr sz="2000" b="1" i="0">
                 <a:solidFill>
                   <a:srgbClr val="FFFFFF"/>
                 </a:solidFill>
               </a:rPr>
-              <a:t>5-year liability exposure eliminated</a:t>
-            </a:r>
-          </a:p>
-        </p:txBody>
-      </p:sp>
-      <p:sp>
-        <p:nvSpPr>
-          <p:cNvPr id="8" name="TextBox 7"/>
+              <a:t>Approve Pilot</a:t>
+            </a:r>
+          </a:p>
+        </p:txBody>
+      </p:sp>
+      <p:sp>
+        <p:nvSpPr>
+          <p:cNvPr id="9" name="TextBox 8"/>
           <p:cNvSpPr txBox="1"/>
           <p:nvPr/>
         </p:nvSpPr>
         <p:spPr>
           <a:xfrm>
-            <a:off x="2194560" y="1847088"/>
-            <a:ext cx="9144000" cy="384048"/>
+            <a:off x="1051560" y="3200400"/>
+            <a:ext cx="2926080" cy="2011680"/>
           </a:xfrm>
           <a:prstGeom prst="rect">
             <a:avLst/>
@@ -7836,29 +8388,30 @@
           </a:bodyPr>
           <a:lstStyle/>
           <a:p>
-            <a:pPr algn="l"/>
-            <a:r>
-              <a:rPr sz="1700" b="0" i="1">
+            <a:pPr algn="ctr"/>
+            <a:r>
+              <a:rPr sz="1600" b="0" i="0">
                 <a:solidFill>
                   <a:srgbClr val="CCD6E0"/>
                 </a:solidFill>
               </a:rPr>
-              <a:t>by catching every defect before contractor sign-off
-(€120K/incident × ~30% miss rate)</a:t>
-            </a:r>
-          </a:p>
-        </p:txBody>
-      </p:sp>
-      <p:sp>
-        <p:nvSpPr>
-          <p:cNvPr id="9" name="Rectangle 8"/>
+              <a:t>Authorise the TrenchVerify AI pilot
+for the current Klosterneuburg
+route build</a:t>
+            </a:r>
+          </a:p>
+        </p:txBody>
+      </p:sp>
+      <p:sp>
+        <p:nvSpPr>
+          <p:cNvPr id="10" name="Rectangle 9"/>
           <p:cNvSpPr/>
           <p:nvPr/>
         </p:nvSpPr>
         <p:spPr>
           <a:xfrm>
-            <a:off x="365760" y="2286000"/>
-            <a:ext cx="11430000" cy="859536"/>
+            <a:off x="4617720" y="1600200"/>
+            <a:ext cx="3291840" cy="3840480"/>
           </a:xfrm>
           <a:prstGeom prst="rect">
             <a:avLst/>
@@ -7889,19 +8442,64 @@
           <a:lstStyle/>
           <a:p>
             <a:pPr algn="ctr"/>
-          </a:p>
-        </p:txBody>
-      </p:sp>
-      <p:sp>
-        <p:nvSpPr>
-          <p:cNvPr id="10" name="TextBox 9"/>
+            <a:endParaRPr/>
+          </a:p>
+        </p:txBody>
+      </p:sp>
+      <p:sp>
+        <p:nvSpPr>
+          <p:cNvPr id="11" name="Rectangle 10"/>
+          <p:cNvSpPr/>
+          <p:nvPr/>
+        </p:nvSpPr>
+        <p:spPr>
+          <a:xfrm>
+            <a:off x="4617720" y="1600200"/>
+            <a:ext cx="3291840" cy="137160"/>
+          </a:xfrm>
+          <a:prstGeom prst="rect">
+            <a:avLst/>
+          </a:prstGeom>
+          <a:solidFill>
+            <a:srgbClr val="FFC107"/>
+          </a:solidFill>
+          <a:ln>
+            <a:noFill/>
+          </a:ln>
+        </p:spPr>
+        <p:style>
+          <a:lnRef idx="1">
+            <a:schemeClr val="accent1"/>
+          </a:lnRef>
+          <a:fillRef idx="3">
+            <a:schemeClr val="accent1"/>
+          </a:fillRef>
+          <a:effectRef idx="2">
+            <a:schemeClr val="accent1"/>
+          </a:effectRef>
+          <a:fontRef idx="minor">
+            <a:schemeClr val="lt1"/>
+          </a:fontRef>
+        </p:style>
+        <p:txBody>
+          <a:bodyPr rtlCol="0" anchor="ctr"/>
+          <a:lstStyle/>
+          <a:p>
+            <a:pPr algn="ctr"/>
+            <a:endParaRPr/>
+          </a:p>
+        </p:txBody>
+      </p:sp>
+      <p:sp>
+        <p:nvSpPr>
+          <p:cNvPr id="12" name="TextBox 11"/>
           <p:cNvSpPr txBox="1"/>
           <p:nvPr/>
         </p:nvSpPr>
         <p:spPr>
           <a:xfrm>
-            <a:off x="548640" y="2377440"/>
-            <a:ext cx="1463040" cy="731520"/>
+            <a:off x="4617720" y="1828800"/>
+            <a:ext cx="3291840" cy="594360"/>
           </a:xfrm>
           <a:prstGeom prst="rect">
             <a:avLst/>
@@ -7916,26 +8514,26 @@
           <a:p>
             <a:pPr algn="ctr"/>
             <a:r>
-              <a:rPr sz="3400" b="1" i="0">
-                <a:solidFill>
-                  <a:srgbClr val="00A8E8"/>
-                </a:solidFill>
-              </a:rPr>
-              <a:t>99%</a:t>
-            </a:r>
-          </a:p>
-        </p:txBody>
-      </p:sp>
-      <p:sp>
-        <p:nvSpPr>
-          <p:cNvPr id="11" name="TextBox 10"/>
+              <a:rPr sz="3000" b="1" i="0">
+                <a:solidFill>
+                  <a:srgbClr val="FFC107"/>
+                </a:solidFill>
+              </a:rPr>
+              <a:t>02</a:t>
+            </a:r>
+          </a:p>
+        </p:txBody>
+      </p:sp>
+      <p:sp>
+        <p:nvSpPr>
+          <p:cNvPr id="13" name="TextBox 12"/>
           <p:cNvSpPr txBox="1"/>
           <p:nvPr/>
         </p:nvSpPr>
         <p:spPr>
           <a:xfrm>
-            <a:off x="2194560" y="2331720"/>
-            <a:ext cx="3657600" cy="457200"/>
+            <a:off x="4617720" y="2468880"/>
+            <a:ext cx="3291840" cy="594360"/>
           </a:xfrm>
           <a:prstGeom prst="rect">
             <a:avLst/>
@@ -7948,28 +8546,28 @@
           </a:bodyPr>
           <a:lstStyle/>
           <a:p>
-            <a:pPr algn="l"/>
-            <a:r>
-              <a:rPr sz="1600" b="1" i="0">
+            <a:pPr algn="ctr"/>
+            <a:r>
+              <a:rPr sz="2000" b="1" i="0">
                 <a:solidFill>
                   <a:srgbClr val="FFFFFF"/>
                 </a:solidFill>
               </a:rPr>
-              <a:t>faster review time</a:t>
-            </a:r>
-          </a:p>
-        </p:txBody>
-      </p:sp>
-      <p:sp>
-        <p:nvSpPr>
-          <p:cNvPr id="12" name="TextBox 11"/>
+              <a:t>Define KPIs</a:t>
+            </a:r>
+          </a:p>
+        </p:txBody>
+      </p:sp>
+      <p:sp>
+        <p:nvSpPr>
+          <p:cNvPr id="14" name="TextBox 13"/>
           <p:cNvSpPr txBox="1"/>
           <p:nvPr/>
         </p:nvSpPr>
         <p:spPr>
           <a:xfrm>
-            <a:off x="2194560" y="2761488"/>
-            <a:ext cx="9144000" cy="384048"/>
+            <a:off x="4800600" y="3200400"/>
+            <a:ext cx="2926080" cy="2011680"/>
           </a:xfrm>
           <a:prstGeom prst="rect">
             <a:avLst/>
@@ -7982,29 +8580,30 @@
           </a:bodyPr>
           <a:lstStyle/>
           <a:p>
-            <a:pPr algn="l"/>
-            <a:r>
-              <a:rPr sz="1700" b="0" i="1">
+            <a:pPr algn="ctr"/>
+            <a:r>
+              <a:rPr sz="1600" b="0" i="0">
                 <a:solidFill>
                   <a:srgbClr val="CCD6E0"/>
                 </a:solidFill>
               </a:rPr>
-              <a:t>3–5 days per section → &lt; 30 min for the full route
-(measured: 3,929 photos in 28 min)</a:t>
-            </a:r>
-          </a:p>
-        </p:txBody>
-      </p:sp>
-      <p:sp>
-        <p:nvSpPr>
-          <p:cNvPr id="13" name="Rectangle 12"/>
+              <a:t>Set acceptance thresholds:
+coverage %, photo compliance rate,
+time-to-report</a:t>
+            </a:r>
+          </a:p>
+        </p:txBody>
+      </p:sp>
+      <p:sp>
+        <p:nvSpPr>
+          <p:cNvPr id="15" name="Rectangle 14"/>
           <p:cNvSpPr/>
           <p:nvPr/>
         </p:nvSpPr>
         <p:spPr>
           <a:xfrm>
-            <a:off x="365760" y="3200400"/>
-            <a:ext cx="11430000" cy="859536"/>
+            <a:off x="8366760" y="1600200"/>
+            <a:ext cx="3291840" cy="3840480"/>
           </a:xfrm>
           <a:prstGeom prst="rect">
             <a:avLst/>
@@ -8035,128 +8634,26 @@
           <a:lstStyle/>
           <a:p>
             <a:pPr algn="ctr"/>
-          </a:p>
-        </p:txBody>
-      </p:sp>
-      <p:sp>
-        <p:nvSpPr>
-          <p:cNvPr id="14" name="TextBox 13"/>
-          <p:cNvSpPr txBox="1"/>
-          <p:nvPr/>
-        </p:nvSpPr>
-        <p:spPr>
-          <a:xfrm>
-            <a:off x="548640" y="3291840"/>
-            <a:ext cx="1463040" cy="731520"/>
-          </a:xfrm>
-          <a:prstGeom prst="rect">
-            <a:avLst/>
-          </a:prstGeom>
-          <a:noFill/>
-        </p:spPr>
-        <p:txBody>
-          <a:bodyPr wrap="square">
-            <a:spAutoFit/>
-          </a:bodyPr>
-          <a:lstStyle/>
-          <a:p>
-            <a:pPr algn="ctr"/>
-            <a:r>
-              <a:rPr sz="3400" b="1" i="0">
-                <a:solidFill>
-                  <a:srgbClr val="00D47E"/>
-                </a:solidFill>
-              </a:rPr>
-              <a:t>100%</a:t>
-            </a:r>
-          </a:p>
-        </p:txBody>
-      </p:sp>
-      <p:sp>
-        <p:nvSpPr>
-          <p:cNvPr id="15" name="TextBox 14"/>
-          <p:cNvSpPr txBox="1"/>
-          <p:nvPr/>
-        </p:nvSpPr>
-        <p:spPr>
-          <a:xfrm>
-            <a:off x="2194560" y="3246120"/>
-            <a:ext cx="3657600" cy="457200"/>
-          </a:xfrm>
-          <a:prstGeom prst="rect">
-            <a:avLst/>
-          </a:prstGeom>
-          <a:noFill/>
-        </p:spPr>
-        <p:txBody>
-          <a:bodyPr wrap="square">
-            <a:spAutoFit/>
-          </a:bodyPr>
-          <a:lstStyle/>
-          <a:p>
-            <a:pPr algn="l"/>
-            <a:r>
-              <a:rPr sz="1600" b="1" i="0">
-                <a:solidFill>
-                  <a:srgbClr val="FFFFFF"/>
-                </a:solidFill>
-              </a:rPr>
-              <a:t>segment coverage</a:t>
-            </a:r>
-          </a:p>
-        </p:txBody>
-      </p:sp>
-      <p:sp>
-        <p:nvSpPr>
-          <p:cNvPr id="16" name="TextBox 15"/>
-          <p:cNvSpPr txBox="1"/>
-          <p:nvPr/>
-        </p:nvSpPr>
-        <p:spPr>
-          <a:xfrm>
-            <a:off x="2194560" y="3675888"/>
-            <a:ext cx="9144000" cy="384048"/>
-          </a:xfrm>
-          <a:prstGeom prst="rect">
-            <a:avLst/>
-          </a:prstGeom>
-          <a:noFill/>
-        </p:spPr>
-        <p:txBody>
-          <a:bodyPr wrap="square">
-            <a:spAutoFit/>
-          </a:bodyPr>
-          <a:lstStyle/>
-          <a:p>
-            <a:pPr algn="l"/>
-            <a:r>
-              <a:rPr sz="1700" b="0" i="1">
-                <a:solidFill>
-                  <a:srgbClr val="CCD6E0"/>
-                </a:solidFill>
-              </a:rPr>
-              <a:t>zero trench meters go unreviewed
-(photo-per-5 m rule across all 2,983 segments)</a:t>
-            </a:r>
-          </a:p>
-        </p:txBody>
-      </p:sp>
-      <p:sp>
-        <p:nvSpPr>
-          <p:cNvPr id="17" name="Rectangle 16"/>
+            <a:endParaRPr/>
+          </a:p>
+        </p:txBody>
+      </p:sp>
+      <p:sp>
+        <p:nvSpPr>
+          <p:cNvPr id="16" name="Rectangle 15"/>
           <p:cNvSpPr/>
           <p:nvPr/>
         </p:nvSpPr>
         <p:spPr>
           <a:xfrm>
-            <a:off x="365760" y="4114800"/>
-            <a:ext cx="11430000" cy="859536"/>
+            <a:off x="8366760" y="1600200"/>
+            <a:ext cx="3291840" cy="137160"/>
           </a:xfrm>
           <a:prstGeom prst="rect">
             <a:avLst/>
           </a:prstGeom>
           <a:solidFill>
-            <a:srgbClr val="122636"/>
+            <a:srgbClr val="00D47E"/>
           </a:solidFill>
           <a:ln>
             <a:noFill/>
@@ -8181,19 +8678,20 @@
           <a:lstStyle/>
           <a:p>
             <a:pPr algn="ctr"/>
-          </a:p>
-        </p:txBody>
-      </p:sp>
-      <p:sp>
-        <p:nvSpPr>
-          <p:cNvPr id="18" name="TextBox 17"/>
+            <a:endParaRPr/>
+          </a:p>
+        </p:txBody>
+      </p:sp>
+      <p:sp>
+        <p:nvSpPr>
+          <p:cNvPr id="17" name="TextBox 16"/>
           <p:cNvSpPr txBox="1"/>
           <p:nvPr/>
         </p:nvSpPr>
         <p:spPr>
           <a:xfrm>
-            <a:off x="548640" y="4206240"/>
-            <a:ext cx="1463040" cy="731520"/>
+            <a:off x="8366760" y="1828800"/>
+            <a:ext cx="3291840" cy="594360"/>
           </a:xfrm>
           <a:prstGeom prst="rect">
             <a:avLst/>
@@ -8208,26 +8706,26 @@
           <a:p>
             <a:pPr algn="ctr"/>
             <a:r>
-              <a:rPr sz="3400" b="1" i="0">
+              <a:rPr sz="3000" b="1" i="0">
                 <a:solidFill>
                   <a:srgbClr val="00D47E"/>
                 </a:solidFill>
               </a:rPr>
-              <a:t>100%</a:t>
-            </a:r>
-          </a:p>
-        </p:txBody>
-      </p:sp>
-      <p:sp>
-        <p:nvSpPr>
-          <p:cNvPr id="19" name="TextBox 18"/>
+              <a:t>03</a:t>
+            </a:r>
+          </a:p>
+        </p:txBody>
+      </p:sp>
+      <p:sp>
+        <p:nvSpPr>
+          <p:cNvPr id="18" name="TextBox 17"/>
           <p:cNvSpPr txBox="1"/>
           <p:nvPr/>
         </p:nvSpPr>
         <p:spPr>
           <a:xfrm>
-            <a:off x="2194560" y="4160520"/>
-            <a:ext cx="3657600" cy="457200"/>
+            <a:off x="8366760" y="2468880"/>
+            <a:ext cx="3291840" cy="594360"/>
           </a:xfrm>
           <a:prstGeom prst="rect">
             <a:avLst/>
@@ -8240,28 +8738,28 @@
           </a:bodyPr>
           <a:lstStyle/>
           <a:p>
-            <a:pPr algn="l"/>
-            <a:r>
-              <a:rPr sz="1600" b="1" i="0">
+            <a:pPr algn="ctr"/>
+            <a:r>
+              <a:rPr sz="2000" b="1" i="0">
                 <a:solidFill>
                   <a:srgbClr val="FFFFFF"/>
                 </a:solidFill>
               </a:rPr>
-              <a:t>audit transparency</a:t>
-            </a:r>
-          </a:p>
-        </p:txBody>
-      </p:sp>
-      <p:sp>
-        <p:nvSpPr>
-          <p:cNvPr id="20" name="TextBox 19"/>
+              <a:t>Scale</a:t>
+            </a:r>
+          </a:p>
+        </p:txBody>
+      </p:sp>
+      <p:sp>
+        <p:nvSpPr>
+          <p:cNvPr id="19" name="TextBox 18"/>
           <p:cNvSpPr txBox="1"/>
           <p:nvPr/>
         </p:nvSpPr>
         <p:spPr>
           <a:xfrm>
-            <a:off x="2194560" y="4590288"/>
-            <a:ext cx="9144000" cy="384048"/>
+            <a:off x="8549640" y="3200400"/>
+            <a:ext cx="2926080" cy="2011680"/>
           </a:xfrm>
           <a:prstGeom prst="rect">
             <a:avLst/>
@@ -8274,72 +8772,30 @@
           </a:bodyPr>
           <a:lstStyle/>
           <a:p>
-            <a:pPr algn="l"/>
-            <a:r>
-              <a:rPr sz="1700" b="0" i="1">
+            <a:pPr algn="ctr"/>
+            <a:r>
+              <a:rPr sz="1600" b="0" i="0">
                 <a:solidFill>
                   <a:srgbClr val="CCD6E0"/>
                 </a:solidFill>
               </a:rPr>
-              <a:t>every check logged per photo · per meter · per timestamp
-(exportable CSV/PDF, court-admissible)</a:t>
-            </a:r>
-          </a:p>
-        </p:txBody>
-      </p:sp>
-      <p:sp>
-        <p:nvSpPr>
-          <p:cNvPr id="21" name="Rectangle 20"/>
-          <p:cNvSpPr/>
-          <p:nvPr/>
-        </p:nvSpPr>
-        <p:spPr>
-          <a:xfrm>
-            <a:off x="365760" y="5029200"/>
-            <a:ext cx="11430000" cy="859536"/>
-          </a:xfrm>
-          <a:prstGeom prst="rect">
-            <a:avLst/>
-          </a:prstGeom>
-          <a:solidFill>
-            <a:srgbClr val="122636"/>
-          </a:solidFill>
-          <a:ln>
-            <a:noFill/>
-          </a:ln>
-        </p:spPr>
-        <p:style>
-          <a:lnRef idx="1">
-            <a:schemeClr val="accent1"/>
-          </a:lnRef>
-          <a:fillRef idx="3">
-            <a:schemeClr val="accent1"/>
-          </a:fillRef>
-          <a:effectRef idx="2">
-            <a:schemeClr val="accent1"/>
-          </a:effectRef>
-          <a:fontRef idx="minor">
-            <a:schemeClr val="lt1"/>
-          </a:fontRef>
-        </p:style>
-        <p:txBody>
-          <a:bodyPr rtlCol="0" anchor="ctr"/>
-          <a:lstStyle/>
-          <a:p>
-            <a:pPr algn="ctr"/>
-          </a:p>
-        </p:txBody>
-      </p:sp>
-      <p:sp>
-        <p:nvSpPr>
-          <p:cNvPr id="22" name="TextBox 21"/>
+              <a:t>Roll out across all future APG
+construction phases — protect
+the full network</a:t>
+            </a:r>
+          </a:p>
+        </p:txBody>
+      </p:sp>
+      <p:sp>
+        <p:nvSpPr>
+          <p:cNvPr id="20" name="TextBox 19"/>
           <p:cNvSpPr txBox="1"/>
           <p:nvPr/>
         </p:nvSpPr>
         <p:spPr>
           <a:xfrm>
-            <a:off x="548640" y="5120640"/>
-            <a:ext cx="1463040" cy="731520"/>
+            <a:off x="457200" y="5623560"/>
+            <a:ext cx="11247120" cy="594360"/>
           </a:xfrm>
           <a:prstGeom prst="rect">
             <a:avLst/>
@@ -8354,158 +8810,12 @@
           <a:p>
             <a:pPr algn="ctr"/>
             <a:r>
-              <a:rPr sz="3400" b="1" i="0">
+              <a:rPr sz="1700" b="1" i="0">
                 <a:solidFill>
                   <a:srgbClr val="00D47E"/>
                 </a:solidFill>
               </a:rPr>
-              <a:t>0%</a:t>
-            </a:r>
-          </a:p>
-        </p:txBody>
-      </p:sp>
-      <p:sp>
-        <p:nvSpPr>
-          <p:cNvPr id="23" name="TextBox 22"/>
-          <p:cNvSpPr txBox="1"/>
-          <p:nvPr/>
-        </p:nvSpPr>
-        <p:spPr>
-          <a:xfrm>
-            <a:off x="2194560" y="5074920"/>
-            <a:ext cx="3657600" cy="457200"/>
-          </a:xfrm>
-          <a:prstGeom prst="rect">
-            <a:avLst/>
-          </a:prstGeom>
-          <a:noFill/>
-        </p:spPr>
-        <p:txBody>
-          <a:bodyPr wrap="square">
-            <a:spAutoFit/>
-          </a:bodyPr>
-          <a:lstStyle/>
-          <a:p>
-            <a:pPr algn="l"/>
-            <a:r>
-              <a:rPr sz="1600" b="1" i="0">
-                <a:solidFill>
-                  <a:srgbClr val="FFFFFF"/>
-                </a:solidFill>
-              </a:rPr>
-              <a:t>hidden GDPR risk</a:t>
-            </a:r>
-          </a:p>
-        </p:txBody>
-      </p:sp>
-      <p:sp>
-        <p:nvSpPr>
-          <p:cNvPr id="24" name="TextBox 23"/>
-          <p:cNvSpPr txBox="1"/>
-          <p:nvPr/>
-        </p:nvSpPr>
-        <p:spPr>
-          <a:xfrm>
-            <a:off x="2194560" y="5504688"/>
-            <a:ext cx="9144000" cy="384048"/>
-          </a:xfrm>
-          <a:prstGeom prst="rect">
-            <a:avLst/>
-          </a:prstGeom>
-          <a:noFill/>
-        </p:spPr>
-        <p:txBody>
-          <a:bodyPr wrap="square">
-            <a:spAutoFit/>
-          </a:bodyPr>
-          <a:lstStyle/>
-          <a:p>
-            <a:pPr algn="l"/>
-            <a:r>
-              <a:rPr sz="1700" b="0" i="1">
-                <a:solidFill>
-                  <a:srgbClr val="CCD6E0"/>
-                </a:solidFill>
-              </a:rPr>
-              <a:t>faces &amp; plates flagged and withheld before any reviewer sees them
-(NIS2/GDPR checks run on 100% of photos)</a:t>
-            </a:r>
-          </a:p>
-        </p:txBody>
-      </p:sp>
-      <p:sp>
-        <p:nvSpPr>
-          <p:cNvPr id="25" name="Rectangle 24"/>
-          <p:cNvSpPr/>
-          <p:nvPr/>
-        </p:nvSpPr>
-        <p:spPr>
-          <a:xfrm>
-            <a:off x="365760" y="6080760"/>
-            <a:ext cx="11430000" cy="594360"/>
-          </a:xfrm>
-          <a:prstGeom prst="rect">
-            <a:avLst/>
-          </a:prstGeom>
-          <a:solidFill>
-            <a:srgbClr val="003A20"/>
-          </a:solidFill>
-          <a:ln>
-            <a:noFill/>
-          </a:ln>
-        </p:spPr>
-        <p:style>
-          <a:lnRef idx="1">
-            <a:schemeClr val="accent1"/>
-          </a:lnRef>
-          <a:fillRef idx="3">
-            <a:schemeClr val="accent1"/>
-          </a:fillRef>
-          <a:effectRef idx="2">
-            <a:schemeClr val="accent1"/>
-          </a:effectRef>
-          <a:fontRef idx="minor">
-            <a:schemeClr val="lt1"/>
-          </a:fontRef>
-        </p:style>
-        <p:txBody>
-          <a:bodyPr rtlCol="0" anchor="ctr"/>
-          <a:lstStyle/>
-          <a:p>
-            <a:pPr algn="ctr"/>
-          </a:p>
-        </p:txBody>
-      </p:sp>
-      <p:sp>
-        <p:nvSpPr>
-          <p:cNvPr id="26" name="TextBox 25"/>
-          <p:cNvSpPr txBox="1"/>
-          <p:nvPr/>
-        </p:nvSpPr>
-        <p:spPr>
-          <a:xfrm>
-            <a:off x="548640" y="6126480"/>
-            <a:ext cx="11155680" cy="502920"/>
-          </a:xfrm>
-          <a:prstGeom prst="rect">
-            <a:avLst/>
-          </a:prstGeom>
-          <a:noFill/>
-        </p:spPr>
-        <p:txBody>
-          <a:bodyPr wrap="square">
-            <a:spAutoFit/>
-          </a:bodyPr>
-          <a:lstStyle/>
-          <a:p>
-            <a:pPr algn="ctr"/>
-            <a:r>
-              <a:rPr sz="1400" b="1" i="0">
-                <a:solidFill>
-                  <a:srgbClr val="00D47E"/>
-                </a:solidFill>
-              </a:rPr>
-              <a:t>28 minutes end-to-end  ·  3,929 photos  ·  2,983 segments scored  ·  ~600 duplicates caught</a:t>
+              <a:t>Protect €42M+ in infrastructure.  Secure the 50-year network lifespan.  Act today.</a:t>
             </a:r>
           </a:p>
         </p:txBody>
@@ -8519,7 +8829,7 @@
 </file>
 
 <file path=ppt/slides/slide8.xml><?xml version="1.0" encoding="utf-8"?>
-<p:sld xmlns:a="http://schemas.openxmlformats.org/drawingml/2006/main" xmlns:p="http://schemas.openxmlformats.org/presentationml/2006/main" xmlns:r="http://schemas.openxmlformats.org/officeDocument/2006/relationships">
+<p:sld xmlns:a="http://schemas.openxmlformats.org/drawingml/2006/main" xmlns:r="http://schemas.openxmlformats.org/officeDocument/2006/relationships" xmlns:p="http://schemas.openxmlformats.org/presentationml/2006/main">
   <p:cSld>
     <p:bg>
       <p:bgPr>
@@ -8535,7 +8845,14 @@
         <p:cNvGrpSpPr/>
         <p:nvPr/>
       </p:nvGrpSpPr>
-      <p:grpSpPr/>
+      <p:grpSpPr>
+        <a:xfrm>
+          <a:off x="0" y="0"/>
+          <a:ext cx="0" cy="0"/>
+          <a:chOff x="0" y="0"/>
+          <a:chExt cx="0" cy="0"/>
+        </a:xfrm>
+      </p:grpSpPr>
       <p:sp>
         <p:nvSpPr>
           <p:cNvPr id="2" name="Rectangle 1"/>
@@ -8576,6 +8893,7 @@
           <a:lstStyle/>
           <a:p>
             <a:pPr algn="ctr"/>
+            <a:endParaRPr/>
           </a:p>
         </p:txBody>
       </p:sp>
@@ -8619,6 +8937,7 @@
           <a:lstStyle/>
           <a:p>
             <a:pPr algn="ctr"/>
+            <a:endParaRPr/>
           </a:p>
         </p:txBody>
       </p:sp>
@@ -8630,8 +8949,8 @@
         </p:nvSpPr>
         <p:spPr>
           <a:xfrm>
-            <a:off x="640080" y="548640"/>
-            <a:ext cx="10515600" cy="822960"/>
+            <a:off x="457200" y="1645920"/>
+            <a:ext cx="11247120" cy="1645920"/>
           </a:xfrm>
           <a:prstGeom prst="rect">
             <a:avLst/>
@@ -8646,113 +8965,26 @@
           <a:p>
             <a:pPr algn="ctr"/>
             <a:r>
-              <a:rPr sz="2800" b="1" i="0">
+              <a:rPr sz="8000" b="1" i="0">
                 <a:solidFill>
                   <a:srgbClr val="FFFFFF"/>
                 </a:solidFill>
               </a:rPr>
-              <a:t>Every Unreviewed Meter Is a Liability.
-We Close That Gap — Automatically.</a:t>
-            </a:r>
-          </a:p>
-        </p:txBody>
-      </p:sp>
-      <p:sp>
-        <p:nvSpPr>
-          <p:cNvPr id="5" name="Rectangle 4"/>
-          <p:cNvSpPr/>
-          <p:nvPr/>
-        </p:nvSpPr>
-        <p:spPr>
-          <a:xfrm>
-            <a:off x="868680" y="1600200"/>
-            <a:ext cx="3291840" cy="3840480"/>
-          </a:xfrm>
-          <a:prstGeom prst="rect">
-            <a:avLst/>
-          </a:prstGeom>
-          <a:solidFill>
-            <a:srgbClr val="122636"/>
-          </a:solidFill>
-          <a:ln>
-            <a:noFill/>
-          </a:ln>
-        </p:spPr>
-        <p:style>
-          <a:lnRef idx="1">
-            <a:schemeClr val="accent1"/>
-          </a:lnRef>
-          <a:fillRef idx="3">
-            <a:schemeClr val="accent1"/>
-          </a:fillRef>
-          <a:effectRef idx="2">
-            <a:schemeClr val="accent1"/>
-          </a:effectRef>
-          <a:fontRef idx="minor">
-            <a:schemeClr val="lt1"/>
-          </a:fontRef>
-        </p:style>
-        <p:txBody>
-          <a:bodyPr rtlCol="0" anchor="ctr"/>
-          <a:lstStyle/>
-          <a:p>
-            <a:pPr algn="ctr"/>
-          </a:p>
-        </p:txBody>
-      </p:sp>
-      <p:sp>
-        <p:nvSpPr>
-          <p:cNvPr id="6" name="Rectangle 5"/>
-          <p:cNvSpPr/>
-          <p:nvPr/>
-        </p:nvSpPr>
-        <p:spPr>
-          <a:xfrm>
-            <a:off x="868680" y="1600200"/>
-            <a:ext cx="3291840" cy="137160"/>
-          </a:xfrm>
-          <a:prstGeom prst="rect">
-            <a:avLst/>
-          </a:prstGeom>
-          <a:solidFill>
-            <a:srgbClr val="00A8E8"/>
-          </a:solidFill>
-          <a:ln>
-            <a:noFill/>
-          </a:ln>
-        </p:spPr>
-        <p:style>
-          <a:lnRef idx="1">
-            <a:schemeClr val="accent1"/>
-          </a:lnRef>
-          <a:fillRef idx="3">
-            <a:schemeClr val="accent1"/>
-          </a:fillRef>
-          <a:effectRef idx="2">
-            <a:schemeClr val="accent1"/>
-          </a:effectRef>
-          <a:fontRef idx="minor">
-            <a:schemeClr val="lt1"/>
-          </a:fontRef>
-        </p:style>
-        <p:txBody>
-          <a:bodyPr rtlCol="0" anchor="ctr"/>
-          <a:lstStyle/>
-          <a:p>
-            <a:pPr algn="ctr"/>
-          </a:p>
-        </p:txBody>
-      </p:sp>
-      <p:sp>
-        <p:nvSpPr>
-          <p:cNvPr id="7" name="TextBox 6"/>
+              <a:t>Thank You</a:t>
+            </a:r>
+          </a:p>
+        </p:txBody>
+      </p:sp>
+      <p:sp>
+        <p:nvSpPr>
+          <p:cNvPr id="5" name="TextBox 4"/>
           <p:cNvSpPr txBox="1"/>
           <p:nvPr/>
         </p:nvSpPr>
         <p:spPr>
           <a:xfrm>
-            <a:off x="868680" y="1828800"/>
-            <a:ext cx="3291840" cy="594360"/>
+            <a:off x="457200" y="3383280"/>
+            <a:ext cx="11247120" cy="640080"/>
           </a:xfrm>
           <a:prstGeom prst="rect">
             <a:avLst/>
@@ -8767,26 +8999,26 @@
           <a:p>
             <a:pPr algn="ctr"/>
             <a:r>
-              <a:rPr sz="3000" b="1" i="0">
+              <a:rPr sz="3000" b="0" i="0">
                 <a:solidFill>
                   <a:srgbClr val="00A8E8"/>
                 </a:solidFill>
               </a:rPr>
-              <a:t>01</a:t>
-            </a:r>
-          </a:p>
-        </p:txBody>
-      </p:sp>
-      <p:sp>
-        <p:nvSpPr>
-          <p:cNvPr id="8" name="TextBox 7"/>
+              <a:t>Questions welcome</a:t>
+            </a:r>
+          </a:p>
+        </p:txBody>
+      </p:sp>
+      <p:sp>
+        <p:nvSpPr>
+          <p:cNvPr id="6" name="TextBox 5"/>
           <p:cNvSpPr txBox="1"/>
           <p:nvPr/>
         </p:nvSpPr>
         <p:spPr>
           <a:xfrm>
-            <a:off x="868680" y="2468880"/>
-            <a:ext cx="3291840" cy="594360"/>
+            <a:off x="457200" y="4206240"/>
+            <a:ext cx="11247120" cy="502920"/>
           </a:xfrm>
           <a:prstGeom prst="rect">
             <a:avLst/>
@@ -8801,26 +9033,26 @@
           <a:p>
             <a:pPr algn="ctr"/>
             <a:r>
-              <a:rPr sz="2000" b="1" i="0">
-                <a:solidFill>
-                  <a:srgbClr val="FFFFFF"/>
-                </a:solidFill>
-              </a:rPr>
-              <a:t>Approve Pilot</a:t>
-            </a:r>
-          </a:p>
-        </p:txBody>
-      </p:sp>
-      <p:sp>
-        <p:nvSpPr>
-          <p:cNvPr id="9" name="TextBox 8"/>
+              <a:rPr sz="1600" b="0" i="0">
+                <a:solidFill>
+                  <a:srgbClr val="CCD6E0"/>
+                </a:solidFill>
+              </a:rPr>
+              <a:t>TrenchVerify — From Site Photo to Compliance Audit — Automatically</a:t>
+            </a:r>
+          </a:p>
+        </p:txBody>
+      </p:sp>
+      <p:sp>
+        <p:nvSpPr>
+          <p:cNvPr id="7" name="TextBox 6"/>
           <p:cNvSpPr txBox="1"/>
           <p:nvPr/>
         </p:nvSpPr>
         <p:spPr>
           <a:xfrm>
-            <a:off x="1051560" y="3200400"/>
-            <a:ext cx="2926080" cy="2011680"/>
+            <a:off x="457200" y="4754880"/>
+            <a:ext cx="11247120" cy="323165"/>
           </a:xfrm>
           <a:prstGeom prst="rect">
             <a:avLst/>
@@ -8835,677 +9067,74 @@
           <a:p>
             <a:pPr algn="ctr"/>
             <a:r>
-              <a:rPr sz="1600" b="0" i="0">
+              <a:rPr sz="1500" b="0" i="0" dirty="0">
                 <a:solidFill>
                   <a:srgbClr val="CCD6E0"/>
                 </a:solidFill>
               </a:rPr>
-              <a:t>Authorise the TrenchVerify AI pilot
-for the current Klosterneuburg
-route build</a:t>
-            </a:r>
-          </a:p>
-        </p:txBody>
-      </p:sp>
-      <p:sp>
-        <p:nvSpPr>
-          <p:cNvPr id="10" name="Rectangle 9"/>
-          <p:cNvSpPr/>
-          <p:nvPr/>
-        </p:nvSpPr>
-        <p:spPr>
-          <a:xfrm>
-            <a:off x="4617720" y="1600200"/>
-            <a:ext cx="3291840" cy="3840480"/>
-          </a:xfrm>
-          <a:prstGeom prst="rect">
-            <a:avLst/>
-          </a:prstGeom>
-          <a:solidFill>
-            <a:srgbClr val="122636"/>
-          </a:solidFill>
-          <a:ln>
-            <a:noFill/>
-          </a:ln>
-        </p:spPr>
-        <p:style>
-          <a:lnRef idx="1">
-            <a:schemeClr val="accent1"/>
-          </a:lnRef>
-          <a:fillRef idx="3">
-            <a:schemeClr val="accent1"/>
-          </a:fillRef>
-          <a:effectRef idx="2">
-            <a:schemeClr val="accent1"/>
-          </a:effectRef>
-          <a:fontRef idx="minor">
-            <a:schemeClr val="lt1"/>
-          </a:fontRef>
-        </p:style>
-        <p:txBody>
-          <a:bodyPr rtlCol="0" anchor="ctr"/>
-          <a:lstStyle/>
-          <a:p>
-            <a:pPr algn="ctr"/>
-          </a:p>
-        </p:txBody>
-      </p:sp>
-      <p:sp>
-        <p:nvSpPr>
-          <p:cNvPr id="11" name="Rectangle 10"/>
-          <p:cNvSpPr/>
-          <p:nvPr/>
-        </p:nvSpPr>
-        <p:spPr>
-          <a:xfrm>
-            <a:off x="4617720" y="1600200"/>
-            <a:ext cx="3291840" cy="137160"/>
-          </a:xfrm>
-          <a:prstGeom prst="rect">
-            <a:avLst/>
-          </a:prstGeom>
-          <a:solidFill>
-            <a:srgbClr val="FFC107"/>
-          </a:solidFill>
-          <a:ln>
-            <a:noFill/>
-          </a:ln>
-        </p:spPr>
-        <p:style>
-          <a:lnRef idx="1">
-            <a:schemeClr val="accent1"/>
-          </a:lnRef>
-          <a:fillRef idx="3">
-            <a:schemeClr val="accent1"/>
-          </a:fillRef>
-          <a:effectRef idx="2">
-            <a:schemeClr val="accent1"/>
-          </a:effectRef>
-          <a:fontRef idx="minor">
-            <a:schemeClr val="lt1"/>
-          </a:fontRef>
-        </p:style>
-        <p:txBody>
-          <a:bodyPr rtlCol="0" anchor="ctr"/>
-          <a:lstStyle/>
-          <a:p>
-            <a:pPr algn="ctr"/>
-          </a:p>
-        </p:txBody>
-      </p:sp>
-      <p:sp>
-        <p:nvSpPr>
-          <p:cNvPr id="12" name="TextBox 11"/>
-          <p:cNvSpPr txBox="1"/>
-          <p:nvPr/>
-        </p:nvSpPr>
-        <p:spPr>
-          <a:xfrm>
-            <a:off x="4617720" y="1828800"/>
-            <a:ext cx="3291840" cy="594360"/>
-          </a:xfrm>
-          <a:prstGeom prst="rect">
-            <a:avLst/>
-          </a:prstGeom>
-          <a:noFill/>
-        </p:spPr>
-        <p:txBody>
-          <a:bodyPr wrap="square">
-            <a:spAutoFit/>
-          </a:bodyPr>
-          <a:lstStyle/>
-          <a:p>
-            <a:pPr algn="ctr"/>
-            <a:r>
-              <a:rPr sz="3000" b="1" i="0">
-                <a:solidFill>
-                  <a:srgbClr val="FFC107"/>
-                </a:solidFill>
-              </a:rPr>
-              <a:t>02</a:t>
-            </a:r>
-          </a:p>
-        </p:txBody>
-      </p:sp>
-      <p:sp>
-        <p:nvSpPr>
-          <p:cNvPr id="13" name="TextBox 12"/>
-          <p:cNvSpPr txBox="1"/>
-          <p:nvPr/>
-        </p:nvSpPr>
-        <p:spPr>
-          <a:xfrm>
-            <a:off x="4617720" y="2468880"/>
-            <a:ext cx="3291840" cy="594360"/>
-          </a:xfrm>
-          <a:prstGeom prst="rect">
-            <a:avLst/>
-          </a:prstGeom>
-          <a:noFill/>
-        </p:spPr>
-        <p:txBody>
-          <a:bodyPr wrap="square">
-            <a:spAutoFit/>
-          </a:bodyPr>
-          <a:lstStyle/>
-          <a:p>
-            <a:pPr algn="ctr"/>
-            <a:r>
-              <a:rPr sz="2000" b="1" i="0">
-                <a:solidFill>
-                  <a:srgbClr val="FFFFFF"/>
-                </a:solidFill>
-              </a:rPr>
-              <a:t>Define KPIs</a:t>
-            </a:r>
-          </a:p>
-        </p:txBody>
-      </p:sp>
-      <p:sp>
-        <p:nvSpPr>
-          <p:cNvPr id="14" name="TextBox 13"/>
-          <p:cNvSpPr txBox="1"/>
-          <p:nvPr/>
-        </p:nvSpPr>
-        <p:spPr>
-          <a:xfrm>
-            <a:off x="4800600" y="3200400"/>
-            <a:ext cx="2926080" cy="2011680"/>
-          </a:xfrm>
-          <a:prstGeom prst="rect">
-            <a:avLst/>
-          </a:prstGeom>
-          <a:noFill/>
-        </p:spPr>
-        <p:txBody>
-          <a:bodyPr wrap="square">
-            <a:spAutoFit/>
-          </a:bodyPr>
-          <a:lstStyle/>
-          <a:p>
-            <a:pPr algn="ctr"/>
-            <a:r>
-              <a:rPr sz="1600" b="0" i="0">
+              <a:t>Team: </a:t>
+            </a:r>
+            <a:r>
+              <a:rPr lang="en-US" sz="1500" dirty="0">
                 <a:solidFill>
                   <a:srgbClr val="CCD6E0"/>
                 </a:solidFill>
               </a:rPr>
-              <a:t>Set acceptance thresholds:
-coverage %, photo compliance rate,
-time-to-report</a:t>
-            </a:r>
-          </a:p>
-        </p:txBody>
-      </p:sp>
-      <p:sp>
-        <p:nvSpPr>
-          <p:cNvPr id="15" name="Rectangle 14"/>
-          <p:cNvSpPr/>
-          <p:nvPr/>
-        </p:nvSpPr>
-        <p:spPr>
-          <a:xfrm>
-            <a:off x="8366760" y="1600200"/>
-            <a:ext cx="3291840" cy="3840480"/>
-          </a:xfrm>
-          <a:prstGeom prst="rect">
-            <a:avLst/>
-          </a:prstGeom>
-          <a:solidFill>
-            <a:srgbClr val="122636"/>
-          </a:solidFill>
-          <a:ln>
-            <a:noFill/>
-          </a:ln>
-        </p:spPr>
-        <p:style>
-          <a:lnRef idx="1">
-            <a:schemeClr val="accent1"/>
-          </a:lnRef>
-          <a:fillRef idx="3">
-            <a:schemeClr val="accent1"/>
-          </a:fillRef>
-          <a:effectRef idx="2">
-            <a:schemeClr val="accent1"/>
-          </a:effectRef>
-          <a:fontRef idx="minor">
-            <a:schemeClr val="lt1"/>
-          </a:fontRef>
-        </p:style>
-        <p:txBody>
-          <a:bodyPr rtlCol="0" anchor="ctr"/>
-          <a:lstStyle/>
-          <a:p>
-            <a:pPr algn="ctr"/>
-          </a:p>
-        </p:txBody>
-      </p:sp>
-      <p:sp>
-        <p:nvSpPr>
-          <p:cNvPr id="16" name="Rectangle 15"/>
-          <p:cNvSpPr/>
-          <p:nvPr/>
-        </p:nvSpPr>
-        <p:spPr>
-          <a:xfrm>
-            <a:off x="8366760" y="1600200"/>
-            <a:ext cx="3291840" cy="137160"/>
-          </a:xfrm>
-          <a:prstGeom prst="rect">
-            <a:avLst/>
-          </a:prstGeom>
-          <a:solidFill>
-            <a:srgbClr val="00D47E"/>
-          </a:solidFill>
-          <a:ln>
-            <a:noFill/>
-          </a:ln>
-        </p:spPr>
-        <p:style>
-          <a:lnRef idx="1">
-            <a:schemeClr val="accent1"/>
-          </a:lnRef>
-          <a:fillRef idx="3">
-            <a:schemeClr val="accent1"/>
-          </a:fillRef>
-          <a:effectRef idx="2">
-            <a:schemeClr val="accent1"/>
-          </a:effectRef>
-          <a:fontRef idx="minor">
-            <a:schemeClr val="lt1"/>
-          </a:fontRef>
-        </p:style>
-        <p:txBody>
-          <a:bodyPr rtlCol="0" anchor="ctr"/>
-          <a:lstStyle/>
-          <a:p>
-            <a:pPr algn="ctr"/>
-          </a:p>
-        </p:txBody>
-      </p:sp>
-      <p:sp>
-        <p:nvSpPr>
-          <p:cNvPr id="17" name="TextBox 16"/>
-          <p:cNvSpPr txBox="1"/>
-          <p:nvPr/>
-        </p:nvSpPr>
-        <p:spPr>
-          <a:xfrm>
-            <a:off x="8366760" y="1828800"/>
-            <a:ext cx="3291840" cy="594360"/>
-          </a:xfrm>
-          <a:prstGeom prst="rect">
-            <a:avLst/>
-          </a:prstGeom>
-          <a:noFill/>
-        </p:spPr>
-        <p:txBody>
-          <a:bodyPr wrap="square">
-            <a:spAutoFit/>
-          </a:bodyPr>
-          <a:lstStyle/>
-          <a:p>
-            <a:pPr algn="ctr"/>
-            <a:r>
-              <a:rPr sz="3000" b="1" i="0">
-                <a:solidFill>
-                  <a:srgbClr val="00D47E"/>
-                </a:solidFill>
-              </a:rPr>
-              <a:t>03</a:t>
-            </a:r>
-          </a:p>
-        </p:txBody>
-      </p:sp>
-      <p:sp>
-        <p:nvSpPr>
-          <p:cNvPr id="18" name="TextBox 17"/>
-          <p:cNvSpPr txBox="1"/>
-          <p:nvPr/>
-        </p:nvSpPr>
-        <p:spPr>
-          <a:xfrm>
-            <a:off x="8366760" y="2468880"/>
-            <a:ext cx="3291840" cy="594360"/>
-          </a:xfrm>
-          <a:prstGeom prst="rect">
-            <a:avLst/>
-          </a:prstGeom>
-          <a:noFill/>
-        </p:spPr>
-        <p:txBody>
-          <a:bodyPr wrap="square">
-            <a:spAutoFit/>
-          </a:bodyPr>
-          <a:lstStyle/>
-          <a:p>
-            <a:pPr algn="ctr"/>
-            <a:r>
-              <a:rPr sz="2000" b="1" i="0">
-                <a:solidFill>
-                  <a:srgbClr val="FFFFFF"/>
-                </a:solidFill>
-              </a:rPr>
-              <a:t>Scale</a:t>
-            </a:r>
-          </a:p>
-        </p:txBody>
-      </p:sp>
-      <p:sp>
-        <p:nvSpPr>
-          <p:cNvPr id="19" name="TextBox 18"/>
-          <p:cNvSpPr txBox="1"/>
-          <p:nvPr/>
-        </p:nvSpPr>
-        <p:spPr>
-          <a:xfrm>
-            <a:off x="8549640" y="3200400"/>
-            <a:ext cx="2926080" cy="2011680"/>
-          </a:xfrm>
-          <a:prstGeom prst="rect">
-            <a:avLst/>
-          </a:prstGeom>
-          <a:noFill/>
-        </p:spPr>
-        <p:txBody>
-          <a:bodyPr wrap="square">
-            <a:spAutoFit/>
-          </a:bodyPr>
-          <a:lstStyle/>
-          <a:p>
-            <a:pPr algn="ctr"/>
-            <a:r>
-              <a:rPr sz="1600" b="0" i="0">
+              <a:t>42 </a:t>
+            </a:r>
+            <a:r>
+              <a:rPr lang="en-US" sz="1500" dirty="0" err="1">
                 <a:solidFill>
                   <a:srgbClr val="CCD6E0"/>
                 </a:solidFill>
               </a:rPr>
-              <a:t>Roll out across all future APG
-construction phases — protect
-the full network</a:t>
-            </a:r>
-          </a:p>
-        </p:txBody>
-      </p:sp>
-      <p:sp>
-        <p:nvSpPr>
-          <p:cNvPr id="20" name="TextBox 19"/>
-          <p:cNvSpPr txBox="1"/>
-          <p:nvPr/>
-        </p:nvSpPr>
-        <p:spPr>
-          <a:xfrm>
-            <a:off x="457200" y="5623560"/>
-            <a:ext cx="11247120" cy="594360"/>
-          </a:xfrm>
-          <a:prstGeom prst="rect">
-            <a:avLst/>
-          </a:prstGeom>
-          <a:noFill/>
-        </p:spPr>
-        <p:txBody>
-          <a:bodyPr wrap="square">
-            <a:spAutoFit/>
-          </a:bodyPr>
-          <a:lstStyle/>
-          <a:p>
-            <a:pPr algn="ctr"/>
-            <a:r>
-              <a:rPr sz="1700" b="1" i="0">
-                <a:solidFill>
-                  <a:srgbClr val="00D47E"/>
-                </a:solidFill>
-              </a:rPr>
-              <a:t>Protect €42M+ in infrastructure.  Secure the 50-year network lifespan.  Act today.</a:t>
-            </a:r>
-          </a:p>
-        </p:txBody>
-      </p:sp>
-    </p:spTree>
-  </p:cSld>
-  <p:clrMapOvr>
-    <a:masterClrMapping/>
-  </p:clrMapOvr>
-</p:sld>
-</file>
-
-<file path=ppt/slides/slide9.xml><?xml version="1.0" encoding="utf-8"?>
-<p:sld xmlns:a="http://schemas.openxmlformats.org/drawingml/2006/main" xmlns:p="http://schemas.openxmlformats.org/presentationml/2006/main" xmlns:r="http://schemas.openxmlformats.org/officeDocument/2006/relationships">
-  <p:cSld>
-    <p:bg>
-      <p:bgPr>
-        <a:solidFill>
-          <a:srgbClr val="0D1B2A"/>
-        </a:solidFill>
-        <a:effectLst/>
-      </p:bgPr>
-    </p:bg>
-    <p:spTree>
-      <p:nvGrpSpPr>
-        <p:cNvPr id="1" name=""/>
-        <p:cNvGrpSpPr/>
-        <p:nvPr/>
-      </p:nvGrpSpPr>
-      <p:grpSpPr/>
-      <p:sp>
-        <p:nvSpPr>
-          <p:cNvPr id="2" name="Rectangle 1"/>
-          <p:cNvSpPr/>
-          <p:nvPr/>
-        </p:nvSpPr>
-        <p:spPr>
-          <a:xfrm>
-            <a:off x="0" y="0"/>
-            <a:ext cx="12188952" cy="73152"/>
-          </a:xfrm>
-          <a:prstGeom prst="rect">
-            <a:avLst/>
-          </a:prstGeom>
-          <a:solidFill>
-            <a:srgbClr val="00A8E8"/>
-          </a:solidFill>
-          <a:ln>
-            <a:noFill/>
-          </a:ln>
-        </p:spPr>
-        <p:style>
-          <a:lnRef idx="1">
-            <a:schemeClr val="accent1"/>
-          </a:lnRef>
-          <a:fillRef idx="3">
-            <a:schemeClr val="accent1"/>
-          </a:fillRef>
-          <a:effectRef idx="2">
-            <a:schemeClr val="accent1"/>
-          </a:effectRef>
-          <a:fontRef idx="minor">
-            <a:schemeClr val="lt1"/>
-          </a:fontRef>
-        </p:style>
-        <p:txBody>
-          <a:bodyPr rtlCol="0" anchor="ctr"/>
-          <a:lstStyle/>
-          <a:p>
-            <a:pPr algn="ctr"/>
-          </a:p>
-        </p:txBody>
-      </p:sp>
-      <p:sp>
-        <p:nvSpPr>
-          <p:cNvPr id="3" name="Rectangle 2"/>
-          <p:cNvSpPr/>
-          <p:nvPr/>
-        </p:nvSpPr>
-        <p:spPr>
-          <a:xfrm>
-            <a:off x="0" y="6766560"/>
-            <a:ext cx="12188952" cy="73152"/>
-          </a:xfrm>
-          <a:prstGeom prst="rect">
-            <a:avLst/>
-          </a:prstGeom>
-          <a:solidFill>
-            <a:srgbClr val="00D47E"/>
-          </a:solidFill>
-          <a:ln>
-            <a:noFill/>
-          </a:ln>
-        </p:spPr>
-        <p:style>
-          <a:lnRef idx="1">
-            <a:schemeClr val="accent1"/>
-          </a:lnRef>
-          <a:fillRef idx="3">
-            <a:schemeClr val="accent1"/>
-          </a:fillRef>
-          <a:effectRef idx="2">
-            <a:schemeClr val="accent1"/>
-          </a:effectRef>
-          <a:fontRef idx="minor">
-            <a:schemeClr val="lt1"/>
-          </a:fontRef>
-        </p:style>
-        <p:txBody>
-          <a:bodyPr rtlCol="0" anchor="ctr"/>
-          <a:lstStyle/>
-          <a:p>
-            <a:pPr algn="ctr"/>
-          </a:p>
-        </p:txBody>
-      </p:sp>
-      <p:sp>
-        <p:nvSpPr>
-          <p:cNvPr id="4" name="TextBox 3"/>
-          <p:cNvSpPr txBox="1"/>
-          <p:nvPr/>
-        </p:nvSpPr>
-        <p:spPr>
-          <a:xfrm>
-            <a:off x="457200" y="1645920"/>
-            <a:ext cx="11247120" cy="1645920"/>
-          </a:xfrm>
-          <a:prstGeom prst="rect">
-            <a:avLst/>
-          </a:prstGeom>
-          <a:noFill/>
-        </p:spPr>
-        <p:txBody>
-          <a:bodyPr wrap="square">
-            <a:spAutoFit/>
-          </a:bodyPr>
-          <a:lstStyle/>
-          <a:p>
-            <a:pPr algn="ctr"/>
-            <a:r>
-              <a:rPr sz="8000" b="1" i="0">
-                <a:solidFill>
-                  <a:srgbClr val="FFFFFF"/>
-                </a:solidFill>
-              </a:rPr>
-              <a:t>Thank You</a:t>
-            </a:r>
-          </a:p>
-        </p:txBody>
-      </p:sp>
-      <p:sp>
-        <p:nvSpPr>
-          <p:cNvPr id="5" name="TextBox 4"/>
-          <p:cNvSpPr txBox="1"/>
-          <p:nvPr/>
-        </p:nvSpPr>
-        <p:spPr>
-          <a:xfrm>
-            <a:off x="457200" y="3383280"/>
-            <a:ext cx="11247120" cy="640080"/>
-          </a:xfrm>
-          <a:prstGeom prst="rect">
-            <a:avLst/>
-          </a:prstGeom>
-          <a:noFill/>
-        </p:spPr>
-        <p:txBody>
-          <a:bodyPr wrap="square">
-            <a:spAutoFit/>
-          </a:bodyPr>
-          <a:lstStyle/>
-          <a:p>
-            <a:pPr algn="ctr"/>
-            <a:r>
-              <a:rPr sz="3000" b="0" i="0">
-                <a:solidFill>
-                  <a:srgbClr val="00A8E8"/>
-                </a:solidFill>
-              </a:rPr>
-              <a:t>Questions welcome</a:t>
-            </a:r>
-          </a:p>
-        </p:txBody>
-      </p:sp>
-      <p:sp>
-        <p:nvSpPr>
-          <p:cNvPr id="6" name="TextBox 5"/>
-          <p:cNvSpPr txBox="1"/>
-          <p:nvPr/>
-        </p:nvSpPr>
-        <p:spPr>
-          <a:xfrm>
-            <a:off x="457200" y="4206240"/>
-            <a:ext cx="11247120" cy="502920"/>
-          </a:xfrm>
-          <a:prstGeom prst="rect">
-            <a:avLst/>
-          </a:prstGeom>
-          <a:noFill/>
-        </p:spPr>
-        <p:txBody>
-          <a:bodyPr wrap="square">
-            <a:spAutoFit/>
-          </a:bodyPr>
-          <a:lstStyle/>
-          <a:p>
-            <a:pPr algn="ctr"/>
-            <a:r>
-              <a:rPr sz="1600" b="0" i="0">
+              <a:t>Claudettes</a:t>
+            </a:r>
+            <a:r>
+              <a:rPr lang="en-US" sz="1500" dirty="0">
                 <a:solidFill>
                   <a:srgbClr val="CCD6E0"/>
                 </a:solidFill>
               </a:rPr>
-              <a:t>TrenchVerify — From Site Photo to Compliance Audit — Automatically</a:t>
-            </a:r>
-          </a:p>
-        </p:txBody>
-      </p:sp>
-      <p:sp>
-        <p:nvSpPr>
-          <p:cNvPr id="7" name="TextBox 6"/>
-          <p:cNvSpPr txBox="1"/>
-          <p:nvPr/>
-        </p:nvSpPr>
-        <p:spPr>
-          <a:xfrm>
-            <a:off x="457200" y="4754880"/>
-            <a:ext cx="11247120" cy="457200"/>
-          </a:xfrm>
-          <a:prstGeom prst="rect">
-            <a:avLst/>
-          </a:prstGeom>
-          <a:noFill/>
-        </p:spPr>
-        <p:txBody>
-          <a:bodyPr wrap="square">
-            <a:spAutoFit/>
-          </a:bodyPr>
-          <a:lstStyle/>
-          <a:p>
-            <a:pPr algn="ctr"/>
-            <a:r>
-              <a:rPr sz="1500" b="0" i="0">
+              <a:t> : [Ahmad]  ·  [</a:t>
+            </a:r>
+            <a:r>
+              <a:rPr lang="en-US" sz="1500" dirty="0" err="1">
                 <a:solidFill>
                   <a:srgbClr val="CCD6E0"/>
                 </a:solidFill>
               </a:rPr>
-              <a:t>Team: [Name 1]  ·  [Name 2]  ·  [Name 3]</a:t>
-            </a:r>
+              <a:t>Tino</a:t>
+            </a:r>
+            <a:r>
+              <a:rPr lang="en-US" sz="1500" dirty="0">
+                <a:solidFill>
+                  <a:srgbClr val="CCD6E0"/>
+                </a:solidFill>
+              </a:rPr>
+              <a:t>]  ·  [Evgenii]  ·  [</a:t>
+            </a:r>
+            <a:r>
+              <a:rPr lang="en-US" sz="1500" dirty="0" err="1">
+                <a:solidFill>
+                  <a:srgbClr val="CCD6E0"/>
+                </a:solidFill>
+              </a:rPr>
+              <a:t>Himani</a:t>
+            </a:r>
+            <a:r>
+              <a:rPr lang="en-US" sz="1500" dirty="0">
+                <a:solidFill>
+                  <a:srgbClr val="CCD6E0"/>
+                </a:solidFill>
+              </a:rPr>
+              <a:t>]</a:t>
+            </a:r>
+            <a:endParaRPr sz="1500" b="0" i="0" dirty="0">
+              <a:solidFill>
+                <a:srgbClr val="CCD6E0"/>
+              </a:solidFill>
+            </a:endParaRPr>
           </a:p>
         </p:txBody>
       </p:sp>

</xml_diff>